<commit_message>
add google link for video
</commit_message>
<xml_diff>
--- a/docs/FootballPredictorDemoDay20260803.pptx
+++ b/docs/FootballPredictorDemoDay20260803.pptx
@@ -5,7 +5,7 @@
     <p:sldMasterId id="2147483648" r:id="rId1"/>
   </p:sldMasterIdLst>
   <p:notesMasterIdLst>
-    <p:notesMasterId r:id="rId18"/>
+    <p:notesMasterId r:id="rId17"/>
   </p:notesMasterIdLst>
   <p:sldIdLst>
     <p:sldId id="256" r:id="rId2"/>
@@ -13,17 +13,16 @@
     <p:sldId id="258" r:id="rId4"/>
     <p:sldId id="259" r:id="rId5"/>
     <p:sldId id="260" r:id="rId6"/>
-    <p:sldId id="271" r:id="rId7"/>
-    <p:sldId id="261" r:id="rId8"/>
-    <p:sldId id="262" r:id="rId9"/>
-    <p:sldId id="263" r:id="rId10"/>
-    <p:sldId id="264" r:id="rId11"/>
-    <p:sldId id="265" r:id="rId12"/>
-    <p:sldId id="266" r:id="rId13"/>
-    <p:sldId id="267" r:id="rId14"/>
-    <p:sldId id="268" r:id="rId15"/>
-    <p:sldId id="269" r:id="rId16"/>
-    <p:sldId id="270" r:id="rId17"/>
+    <p:sldId id="261" r:id="rId7"/>
+    <p:sldId id="262" r:id="rId8"/>
+    <p:sldId id="263" r:id="rId9"/>
+    <p:sldId id="264" r:id="rId10"/>
+    <p:sldId id="265" r:id="rId11"/>
+    <p:sldId id="266" r:id="rId12"/>
+    <p:sldId id="267" r:id="rId13"/>
+    <p:sldId id="268" r:id="rId14"/>
+    <p:sldId id="269" r:id="rId15"/>
+    <p:sldId id="270" r:id="rId16"/>
   </p:sldIdLst>
   <p:sldSz cx="9144000" cy="5143500" type="screen16x9"/>
   <p:notesSz cx="6858000" cy="9144000"/>
@@ -325,6 +324,11 @@
       </a:defRPr>
     </a:lvl9pPr>
   </p:defaultTextStyle>
+  <p:extLst>
+    <p:ext uri="{EFAFB233-063F-42B5-8137-9DF3F51BA10A}">
+      <p15:sldGuideLst xmlns:p15="http://schemas.microsoft.com/office/powerpoint/2012/main"/>
+    </p:ext>
+  </p:extLst>
 </p:presentation>
 </file>
 
@@ -1153,7 +1157,7 @@
 
 <file path=ppt/slideLayouts/slideLayout3.xml><?xml version="1.0" encoding="utf-8"?>
 <p:sldLayout xmlns:a="http://schemas.openxmlformats.org/drawingml/2006/main" xmlns:r="http://schemas.openxmlformats.org/officeDocument/2006/relationships" xmlns:p="http://schemas.openxmlformats.org/presentationml/2006/main" type="tx">
-  <p:cSld name="TITLE_AND_BODY">
+  <p:cSld name="1_TITLE_AND_BODY">
     <p:spTree>
       <p:nvGrpSpPr>
         <p:cNvPr id="1" name=""/>
@@ -2216,7 +2220,7 @@
           </a:ln>
           <a:extLst>
             <a:ext uri="{C572A759-6A51-4108-AA02-DFA0A04FC94B}">
-              <ma14:wrappingTextBoxFlag xmlns:ma14="http://schemas.microsoft.com/office/mac/drawingml/2011/main" xmlns:a14="http://schemas.microsoft.com/office/drawing/2010/main" xmlns:m="http://schemas.openxmlformats.org/officeDocument/2006/math" xmlns="" val="1"/>
+              <ma14:wrappingTextBoxFlag xmlns="" xmlns:m="http://schemas.openxmlformats.org/officeDocument/2006/math" xmlns:a14="http://schemas.microsoft.com/office/drawing/2010/main" xmlns:ma14="http://schemas.microsoft.com/office/mac/drawingml/2011/main" val="1"/>
             </a:ext>
           </a:extLst>
         </p:spPr>
@@ -2255,7 +2259,7 @@
           </a:ln>
           <a:extLst>
             <a:ext uri="{C572A759-6A51-4108-AA02-DFA0A04FC94B}">
-              <ma14:wrappingTextBoxFlag xmlns:ma14="http://schemas.microsoft.com/office/mac/drawingml/2011/main" xmlns:a14="http://schemas.microsoft.com/office/drawing/2010/main" xmlns:m="http://schemas.openxmlformats.org/officeDocument/2006/math" xmlns="" val="1"/>
+              <ma14:wrappingTextBoxFlag xmlns="" xmlns:m="http://schemas.openxmlformats.org/officeDocument/2006/math" xmlns:a14="http://schemas.microsoft.com/office/drawing/2010/main" xmlns:ma14="http://schemas.microsoft.com/office/mac/drawingml/2011/main" val="1"/>
             </a:ext>
           </a:extLst>
         </p:spPr>
@@ -3237,7 +3241,7 @@
           </a:ln>
           <a:extLst>
             <a:ext uri="{C572A759-6A51-4108-AA02-DFA0A04FC94B}">
-              <ma14:wrappingTextBoxFlag xmlns:ma14="http://schemas.microsoft.com/office/mac/drawingml/2011/main" xmlns:a14="http://schemas.microsoft.com/office/drawing/2010/main" xmlns:m="http://schemas.openxmlformats.org/officeDocument/2006/math" xmlns="" val="1"/>
+              <ma14:wrappingTextBoxFlag xmlns="" xmlns:m="http://schemas.openxmlformats.org/officeDocument/2006/math" xmlns:a14="http://schemas.microsoft.com/office/drawing/2010/main" xmlns:ma14="http://schemas.microsoft.com/office/mac/drawingml/2011/main" val="1"/>
             </a:ext>
           </a:extLst>
         </p:spPr>
@@ -3275,813 +3279,6 @@
 </file>
 
 <file path=ppt/slides/slide10.xml><?xml version="1.0" encoding="utf-8"?>
-<p:sld xmlns:a="http://schemas.openxmlformats.org/drawingml/2006/main" xmlns:r="http://schemas.openxmlformats.org/officeDocument/2006/relationships" xmlns:p="http://schemas.openxmlformats.org/presentationml/2006/main">
-  <p:cSld>
-    <p:spTree>
-      <p:nvGrpSpPr>
-        <p:cNvPr id="1" name=""/>
-        <p:cNvGrpSpPr/>
-        <p:nvPr/>
-      </p:nvGrpSpPr>
-      <p:grpSpPr>
-        <a:xfrm>
-          <a:off x="0" y="0"/>
-          <a:ext cx="0" cy="0"/>
-          <a:chOff x="0" y="0"/>
-          <a:chExt cx="0" cy="0"/>
-        </a:xfrm>
-      </p:grpSpPr>
-      <p:pic>
-        <p:nvPicPr>
-          <p:cNvPr id="266" name="Fond FC Barcelone" descr="Fond FC Barcelone"/>
-          <p:cNvPicPr>
-            <a:picLocks noChangeAspect="1"/>
-          </p:cNvPicPr>
-          <p:nvPr/>
-        </p:nvPicPr>
-        <p:blipFill>
-          <a:blip r:embed="rId2"/>
-          <a:srcRect t="7813" b="7812"/>
-          <a:stretch>
-            <a:fillRect/>
-          </a:stretch>
-        </p:blipFill>
-        <p:spPr>
-          <a:xfrm>
-            <a:off x="0" y="-1"/>
-            <a:ext cx="9144000" cy="5143502"/>
-          </a:xfrm>
-          <a:prstGeom prst="rect">
-            <a:avLst/>
-          </a:prstGeom>
-          <a:ln w="12700">
-            <a:miter lim="400000"/>
-          </a:ln>
-        </p:spPr>
-      </p:pic>
-      <p:sp>
-        <p:nvSpPr>
-          <p:cNvPr id="267" name="Google Shape;75;p16"/>
-          <p:cNvSpPr txBox="1">
-            <a:spLocks noGrp="1"/>
-          </p:cNvSpPr>
-          <p:nvPr>
-            <p:ph type="title"/>
-          </p:nvPr>
-        </p:nvSpPr>
-        <p:spPr>
-          <a:xfrm>
-            <a:off x="1192664" y="403309"/>
-            <a:ext cx="5315101" cy="533101"/>
-          </a:xfrm>
-          <a:prstGeom prst="rect">
-            <a:avLst/>
-          </a:prstGeom>
-        </p:spPr>
-        <p:txBody>
-          <a:bodyPr/>
-          <a:lstStyle>
-            <a:lvl1pPr defTabSz="822959">
-              <a:defRPr sz="2250">
-                <a:solidFill>
-                  <a:srgbClr val="0E3449"/>
-                </a:solidFill>
-                <a:latin typeface="Inter SemiBold"/>
-                <a:ea typeface="Inter SemiBold"/>
-                <a:cs typeface="Inter SemiBold"/>
-                <a:sym typeface="Inter SemiBold"/>
-              </a:defRPr>
-            </a:lvl1pPr>
-          </a:lstStyle>
-          <a:p>
-            <a:r>
-              <a:t>Architecture - Entrainement</a:t>
-            </a:r>
-          </a:p>
-        </p:txBody>
-      </p:sp>
-      <p:pic>
-        <p:nvPicPr>
-          <p:cNvPr id="268" name="Google Shape;76;p16" descr="Google Shape;76;p16"/>
-          <p:cNvPicPr>
-            <a:picLocks noChangeAspect="1"/>
-          </p:cNvPicPr>
-          <p:nvPr/>
-        </p:nvPicPr>
-        <p:blipFill>
-          <a:blip r:embed="rId3"/>
-          <a:stretch>
-            <a:fillRect/>
-          </a:stretch>
-        </p:blipFill>
-        <p:spPr>
-          <a:xfrm>
-            <a:off x="463375" y="482852"/>
-            <a:ext cx="576901" cy="385905"/>
-          </a:xfrm>
-          <a:prstGeom prst="rect">
-            <a:avLst/>
-          </a:prstGeom>
-          <a:ln w="12700">
-            <a:miter lim="400000"/>
-          </a:ln>
-        </p:spPr>
-      </p:pic>
-      <p:sp>
-        <p:nvSpPr>
-          <p:cNvPr id="269" name="Google Shape;77;p16"/>
-          <p:cNvSpPr/>
-          <p:nvPr/>
-        </p:nvSpPr>
-        <p:spPr>
-          <a:xfrm>
-            <a:off x="10224" y="4892025"/>
-            <a:ext cx="9144001" cy="251400"/>
-          </a:xfrm>
-          <a:prstGeom prst="rect">
-            <a:avLst/>
-          </a:prstGeom>
-          <a:solidFill>
-            <a:srgbClr val="C3FFFC"/>
-          </a:solidFill>
-          <a:ln w="12700">
-            <a:miter lim="400000"/>
-          </a:ln>
-        </p:spPr>
-        <p:txBody>
-          <a:bodyPr lIns="45719" rIns="45719" anchor="ctr"/>
-          <a:lstStyle/>
-          <a:p>
-            <a:endParaRPr/>
-          </a:p>
-        </p:txBody>
-      </p:sp>
-      <p:grpSp>
-        <p:nvGrpSpPr>
-          <p:cNvPr id="272" name="Groupe 27"/>
-          <p:cNvGrpSpPr/>
-          <p:nvPr/>
-        </p:nvGrpSpPr>
-        <p:grpSpPr>
-          <a:xfrm>
-            <a:off x="7096703" y="1678903"/>
-            <a:ext cx="1143100" cy="1615649"/>
-            <a:chOff x="0" y="0"/>
-            <a:chExt cx="1143099" cy="1615648"/>
-          </a:xfrm>
-        </p:grpSpPr>
-        <p:pic>
-          <p:nvPicPr>
-            <p:cNvPr id="270" name="Image 7" descr="Image 7"/>
-            <p:cNvPicPr>
-              <a:picLocks noChangeAspect="1"/>
-            </p:cNvPicPr>
-            <p:nvPr/>
-          </p:nvPicPr>
-          <p:blipFill>
-            <a:blip r:embed="rId4"/>
-            <a:stretch>
-              <a:fillRect/>
-            </a:stretch>
-          </p:blipFill>
-          <p:spPr>
-            <a:xfrm>
-              <a:off x="0" y="396341"/>
-              <a:ext cx="1143100" cy="1219307"/>
-            </a:xfrm>
-            <a:prstGeom prst="rect">
-              <a:avLst/>
-            </a:prstGeom>
-            <a:ln w="12700" cap="flat">
-              <a:noFill/>
-              <a:miter lim="400000"/>
-            </a:ln>
-            <a:effectLst/>
-          </p:spPr>
-        </p:pic>
-        <p:pic>
-          <p:nvPicPr>
-            <p:cNvPr id="271" name="Image 13" descr="Image 13"/>
-            <p:cNvPicPr>
-              <a:picLocks noChangeAspect="1"/>
-            </p:cNvPicPr>
-            <p:nvPr/>
-          </p:nvPicPr>
-          <p:blipFill>
-            <a:blip r:embed="rId5"/>
-            <a:stretch>
-              <a:fillRect/>
-            </a:stretch>
-          </p:blipFill>
-          <p:spPr>
-            <a:xfrm>
-              <a:off x="220147" y="-1"/>
-              <a:ext cx="844692" cy="530697"/>
-            </a:xfrm>
-            <a:prstGeom prst="rect">
-              <a:avLst/>
-            </a:prstGeom>
-            <a:ln w="12700" cap="flat">
-              <a:noFill/>
-              <a:miter lim="400000"/>
-            </a:ln>
-            <a:effectLst/>
-          </p:spPr>
-        </p:pic>
-      </p:grpSp>
-      <p:grpSp>
-        <p:nvGrpSpPr>
-          <p:cNvPr id="276" name="Groupe 17"/>
-          <p:cNvGrpSpPr/>
-          <p:nvPr/>
-        </p:nvGrpSpPr>
-        <p:grpSpPr>
-          <a:xfrm>
-            <a:off x="2546643" y="1488950"/>
-            <a:ext cx="2268735" cy="2356464"/>
-            <a:chOff x="0" y="0"/>
-            <a:chExt cx="2268733" cy="2356462"/>
-          </a:xfrm>
-        </p:grpSpPr>
-        <p:pic>
-          <p:nvPicPr>
-            <p:cNvPr id="273" name="Image 2" descr="Image 2"/>
-            <p:cNvPicPr>
-              <a:picLocks noChangeAspect="1"/>
-            </p:cNvPicPr>
-            <p:nvPr/>
-          </p:nvPicPr>
-          <p:blipFill>
-            <a:blip r:embed="rId6"/>
-            <a:stretch>
-              <a:fillRect/>
-            </a:stretch>
-          </p:blipFill>
-          <p:spPr>
-            <a:xfrm>
-              <a:off x="143865" y="837871"/>
-              <a:ext cx="1196483" cy="577613"/>
-            </a:xfrm>
-            <a:prstGeom prst="rect">
-              <a:avLst/>
-            </a:prstGeom>
-            <a:ln w="12700" cap="flat">
-              <a:noFill/>
-              <a:miter lim="400000"/>
-            </a:ln>
-            <a:effectLst/>
-          </p:spPr>
-        </p:pic>
-        <p:pic>
-          <p:nvPicPr>
-            <p:cNvPr id="274" name="Image 15" descr="Image 15"/>
-            <p:cNvPicPr>
-              <a:picLocks noChangeAspect="1"/>
-            </p:cNvPicPr>
-            <p:nvPr/>
-          </p:nvPicPr>
-          <p:blipFill>
-            <a:blip r:embed="rId7"/>
-            <a:stretch>
-              <a:fillRect/>
-            </a:stretch>
-          </p:blipFill>
-          <p:spPr>
-            <a:xfrm>
-              <a:off x="392206" y="0"/>
-              <a:ext cx="699801" cy="627208"/>
-            </a:xfrm>
-            <a:prstGeom prst="rect">
-              <a:avLst/>
-            </a:prstGeom>
-            <a:ln w="12700" cap="flat">
-              <a:noFill/>
-              <a:miter lim="400000"/>
-            </a:ln>
-            <a:effectLst/>
-          </p:spPr>
-        </p:pic>
-        <p:sp>
-          <p:nvSpPr>
-            <p:cNvPr id="275" name="ZoneTexte 16"/>
-            <p:cNvSpPr txBox="1"/>
-            <p:nvPr/>
-          </p:nvSpPr>
-          <p:spPr>
-            <a:xfrm>
-              <a:off x="0" y="1617322"/>
-              <a:ext cx="2268734" cy="739141"/>
-            </a:xfrm>
-            <a:prstGeom prst="rect">
-              <a:avLst/>
-            </a:prstGeom>
-            <a:noFill/>
-            <a:ln w="12700" cap="flat">
-              <a:noFill/>
-              <a:miter lim="400000"/>
-            </a:ln>
-            <a:effectLst/>
-            <a:extLst>
-              <a:ext uri="{C572A759-6A51-4108-AA02-DFA0A04FC94B}">
-                <ma14:wrappingTextBoxFlag xmlns:ma14="http://schemas.microsoft.com/office/mac/drawingml/2011/main" xmlns:a14="http://schemas.microsoft.com/office/drawing/2010/main" xmlns:m="http://schemas.openxmlformats.org/officeDocument/2006/math" xmlns="" val="1"/>
-              </a:ext>
-            </a:extLst>
-          </p:spPr>
-          <p:txBody>
-            <a:bodyPr wrap="none" lIns="45719" tIns="45719" rIns="45719" bIns="45719" numCol="1" anchor="t">
-              <a:spAutoFit/>
-            </a:bodyPr>
-            <a:lstStyle/>
-            <a:p>
-              <a:pPr>
-                <a:defRPr>
-                  <a:latin typeface="Inter"/>
-                  <a:ea typeface="Inter"/>
-                  <a:cs typeface="Inter"/>
-                  <a:sym typeface="Inter"/>
-                </a:defRPr>
-              </a:pPr>
-              <a:r>
-                <a:t>Construction dataset</a:t>
-              </a:r>
-              <a:br/>
-              <a:r>
-                <a:t>et entrainement du modèle </a:t>
-              </a:r>
-            </a:p>
-            <a:p>
-              <a:pPr>
-                <a:defRPr>
-                  <a:latin typeface="Inter"/>
-                  <a:ea typeface="Inter"/>
-                  <a:cs typeface="Inter"/>
-                  <a:sym typeface="Inter"/>
-                </a:defRPr>
-              </a:pPr>
-              <a:r>
-                <a:t>en Local</a:t>
-              </a:r>
-            </a:p>
-          </p:txBody>
-        </p:sp>
-      </p:grpSp>
-      <p:sp>
-        <p:nvSpPr>
-          <p:cNvPr id="291" name="Fleche FastAPI vers Render"/>
-          <p:cNvSpPr/>
-          <p:nvPr/>
-        </p:nvSpPr>
-        <p:spPr>
-          <a:xfrm>
-            <a:off x="1664018" y="2785794"/>
-            <a:ext cx="1026492" cy="122923"/>
-          </a:xfrm>
-          <a:custGeom>
-            <a:avLst/>
-            <a:gdLst/>
-            <a:ahLst/>
-            <a:cxnLst>
-              <a:cxn ang="0">
-                <a:pos x="wd2" y="hd2"/>
-              </a:cxn>
-              <a:cxn ang="5400000">
-                <a:pos x="wd2" y="hd2"/>
-              </a:cxn>
-              <a:cxn ang="10800000">
-                <a:pos x="wd2" y="hd2"/>
-              </a:cxn>
-              <a:cxn ang="16200000">
-                <a:pos x="wd2" y="hd2"/>
-              </a:cxn>
-            </a:cxnLst>
-            <a:rect l="0" t="0" r="r" b="b"/>
-            <a:pathLst>
-              <a:path w="21600" h="21600" extrusionOk="0">
-                <a:moveTo>
-                  <a:pt x="0" y="21600"/>
-                </a:moveTo>
-                <a:lnTo>
-                  <a:pt x="21600" y="0"/>
-                </a:lnTo>
-              </a:path>
-            </a:pathLst>
-          </a:custGeom>
-          <a:ln w="19050" cap="rnd">
-            <a:solidFill>
-              <a:srgbClr val="015955"/>
-            </a:solidFill>
-            <a:tailEnd type="triangle"/>
-          </a:ln>
-        </p:spPr>
-        <p:txBody>
-          <a:bodyPr/>
-          <a:lstStyle/>
-          <a:p>
-            <a:endParaRPr/>
-          </a:p>
-        </p:txBody>
-      </p:sp>
-      <p:sp>
-        <p:nvSpPr>
-          <p:cNvPr id="292" name="Fleche FastAPI vers Render"/>
-          <p:cNvSpPr/>
-          <p:nvPr/>
-        </p:nvSpPr>
-        <p:spPr>
-          <a:xfrm>
-            <a:off x="3886991" y="2579290"/>
-            <a:ext cx="863916" cy="70972"/>
-          </a:xfrm>
-          <a:custGeom>
-            <a:avLst/>
-            <a:gdLst/>
-            <a:ahLst/>
-            <a:cxnLst>
-              <a:cxn ang="0">
-                <a:pos x="wd2" y="hd2"/>
-              </a:cxn>
-              <a:cxn ang="5400000">
-                <a:pos x="wd2" y="hd2"/>
-              </a:cxn>
-              <a:cxn ang="10800000">
-                <a:pos x="wd2" y="hd2"/>
-              </a:cxn>
-              <a:cxn ang="16200000">
-                <a:pos x="wd2" y="hd2"/>
-              </a:cxn>
-            </a:cxnLst>
-            <a:rect l="0" t="0" r="r" b="b"/>
-            <a:pathLst>
-              <a:path w="21600" h="21600" extrusionOk="0">
-                <a:moveTo>
-                  <a:pt x="0" y="21600"/>
-                </a:moveTo>
-                <a:lnTo>
-                  <a:pt x="21600" y="0"/>
-                </a:lnTo>
-              </a:path>
-            </a:pathLst>
-          </a:custGeom>
-          <a:ln w="19050" cap="rnd">
-            <a:solidFill>
-              <a:srgbClr val="015955"/>
-            </a:solidFill>
-            <a:tailEnd type="triangle"/>
-          </a:ln>
-        </p:spPr>
-        <p:txBody>
-          <a:bodyPr/>
-          <a:lstStyle/>
-          <a:p>
-            <a:endParaRPr/>
-          </a:p>
-        </p:txBody>
-      </p:sp>
-      <p:sp>
-        <p:nvSpPr>
-          <p:cNvPr id="293" name="Fleche FastAPI vers Render"/>
-          <p:cNvSpPr/>
-          <p:nvPr/>
-        </p:nvSpPr>
-        <p:spPr>
-          <a:xfrm>
-            <a:off x="6259797" y="2494809"/>
-            <a:ext cx="836907" cy="11836"/>
-          </a:xfrm>
-          <a:custGeom>
-            <a:avLst/>
-            <a:gdLst/>
-            <a:ahLst/>
-            <a:cxnLst>
-              <a:cxn ang="0">
-                <a:pos x="wd2" y="hd2"/>
-              </a:cxn>
-              <a:cxn ang="5400000">
-                <a:pos x="wd2" y="hd2"/>
-              </a:cxn>
-              <a:cxn ang="10800000">
-                <a:pos x="wd2" y="hd2"/>
-              </a:cxn>
-              <a:cxn ang="16200000">
-                <a:pos x="wd2" y="hd2"/>
-              </a:cxn>
-            </a:cxnLst>
-            <a:rect l="0" t="0" r="r" b="b"/>
-            <a:pathLst>
-              <a:path w="21600" h="21600" extrusionOk="0">
-                <a:moveTo>
-                  <a:pt x="0" y="21600"/>
-                </a:moveTo>
-                <a:lnTo>
-                  <a:pt x="21600" y="0"/>
-                </a:lnTo>
-              </a:path>
-            </a:pathLst>
-          </a:custGeom>
-          <a:ln w="19050" cap="rnd">
-            <a:solidFill>
-              <a:srgbClr val="015955"/>
-            </a:solidFill>
-            <a:tailEnd type="triangle"/>
-          </a:ln>
-        </p:spPr>
-        <p:txBody>
-          <a:bodyPr/>
-          <a:lstStyle/>
-          <a:p>
-            <a:endParaRPr/>
-          </a:p>
-        </p:txBody>
-      </p:sp>
-      <p:grpSp>
-        <p:nvGrpSpPr>
-          <p:cNvPr id="282" name="Groupe 36"/>
-          <p:cNvGrpSpPr/>
-          <p:nvPr/>
-        </p:nvGrpSpPr>
-        <p:grpSpPr>
-          <a:xfrm>
-            <a:off x="904198" y="2278927"/>
-            <a:ext cx="759821" cy="1350567"/>
-            <a:chOff x="0" y="0"/>
-            <a:chExt cx="759819" cy="1350566"/>
-          </a:xfrm>
-        </p:grpSpPr>
-        <p:pic>
-          <p:nvPicPr>
-            <p:cNvPr id="280" name="Image 9" descr="Image 9"/>
-            <p:cNvPicPr>
-              <a:picLocks noChangeAspect="1"/>
-            </p:cNvPicPr>
-            <p:nvPr/>
-          </p:nvPicPr>
-          <p:blipFill>
-            <a:blip r:embed="rId8"/>
-            <a:stretch>
-              <a:fillRect/>
-            </a:stretch>
-          </p:blipFill>
-          <p:spPr>
-            <a:xfrm>
-              <a:off x="0" y="-1"/>
-              <a:ext cx="759820" cy="698366"/>
-            </a:xfrm>
-            <a:prstGeom prst="rect">
-              <a:avLst/>
-            </a:prstGeom>
-            <a:ln w="12700" cap="flat">
-              <a:noFill/>
-              <a:miter lim="400000"/>
-            </a:ln>
-            <a:effectLst/>
-          </p:spPr>
-        </p:pic>
-        <p:pic>
-          <p:nvPicPr>
-            <p:cNvPr id="281" name="Image 35" descr="Image 35"/>
-            <p:cNvPicPr>
-              <a:picLocks noChangeAspect="1"/>
-            </p:cNvPicPr>
-            <p:nvPr/>
-          </p:nvPicPr>
-          <p:blipFill>
-            <a:blip r:embed="rId9"/>
-            <a:stretch>
-              <a:fillRect/>
-            </a:stretch>
-          </p:blipFill>
-          <p:spPr>
-            <a:xfrm>
-              <a:off x="0" y="572214"/>
-              <a:ext cx="759820" cy="778353"/>
-            </a:xfrm>
-            <a:prstGeom prst="rect">
-              <a:avLst/>
-            </a:prstGeom>
-            <a:ln w="12700" cap="flat">
-              <a:noFill/>
-              <a:miter lim="400000"/>
-            </a:ln>
-            <a:effectLst/>
-          </p:spPr>
-        </p:pic>
-      </p:grpSp>
-      <p:grpSp>
-        <p:nvGrpSpPr>
-          <p:cNvPr id="289" name="Groupe 39"/>
-          <p:cNvGrpSpPr/>
-          <p:nvPr/>
-        </p:nvGrpSpPr>
-        <p:grpSpPr>
-          <a:xfrm>
-            <a:off x="4750906" y="1740510"/>
-            <a:ext cx="1508892" cy="1553606"/>
-            <a:chOff x="0" y="0"/>
-            <a:chExt cx="1508891" cy="1553604"/>
-          </a:xfrm>
-        </p:grpSpPr>
-        <p:grpSp>
-          <p:nvGrpSpPr>
-            <p:cNvPr id="287" name="Groupe 26"/>
-            <p:cNvGrpSpPr/>
-            <p:nvPr/>
-          </p:nvGrpSpPr>
-          <p:grpSpPr>
-            <a:xfrm>
-              <a:off x="0" y="0"/>
-              <a:ext cx="1508892" cy="1553605"/>
-              <a:chOff x="0" y="0"/>
-              <a:chExt cx="1508891" cy="1553605"/>
-            </a:xfrm>
-          </p:grpSpPr>
-          <p:grpSp>
-            <p:nvGrpSpPr>
-              <p:cNvPr id="285" name="Groupe 3"/>
-              <p:cNvGrpSpPr/>
-              <p:nvPr/>
-            </p:nvGrpSpPr>
-            <p:grpSpPr>
-              <a:xfrm>
-                <a:off x="0" y="484198"/>
-                <a:ext cx="1508892" cy="1069408"/>
-                <a:chOff x="0" y="0"/>
-                <a:chExt cx="1508891" cy="1069406"/>
-              </a:xfrm>
-            </p:grpSpPr>
-            <p:pic>
-              <p:nvPicPr>
-                <p:cNvPr id="283" name="Image 4" descr="Image 4"/>
-                <p:cNvPicPr>
-                  <a:picLocks noChangeAspect="1"/>
-                </p:cNvPicPr>
-                <p:nvPr/>
-              </p:nvPicPr>
-              <p:blipFill>
-                <a:blip r:embed="rId10"/>
-                <a:stretch>
-                  <a:fillRect/>
-                </a:stretch>
-              </p:blipFill>
-              <p:spPr>
-                <a:xfrm>
-                  <a:off x="0" y="0"/>
-                  <a:ext cx="1508892" cy="762067"/>
-                </a:xfrm>
-                <a:prstGeom prst="rect">
-                  <a:avLst/>
-                </a:prstGeom>
-                <a:ln w="12700" cap="flat">
-                  <a:noFill/>
-                  <a:miter lim="400000"/>
-                </a:ln>
-                <a:effectLst/>
-              </p:spPr>
-            </p:pic>
-            <p:sp>
-              <p:nvSpPr>
-                <p:cNvPr id="284" name="ZoneTexte 5"/>
-                <p:cNvSpPr txBox="1"/>
-                <p:nvPr/>
-              </p:nvSpPr>
-              <p:spPr>
-                <a:xfrm>
-                  <a:off x="345738" y="762066"/>
-                  <a:ext cx="779400" cy="307341"/>
-                </a:xfrm>
-                <a:prstGeom prst="rect">
-                  <a:avLst/>
-                </a:prstGeom>
-                <a:noFill/>
-                <a:ln w="12700" cap="flat">
-                  <a:noFill/>
-                  <a:miter lim="400000"/>
-                </a:ln>
-                <a:effectLst/>
-                <a:extLst>
-                  <a:ext uri="{C572A759-6A51-4108-AA02-DFA0A04FC94B}">
-                    <ma14:wrappingTextBoxFlag xmlns:ma14="http://schemas.microsoft.com/office/mac/drawingml/2011/main" xmlns:a14="http://schemas.microsoft.com/office/drawing/2010/main" xmlns:m="http://schemas.openxmlformats.org/officeDocument/2006/math" xmlns="" val="1"/>
-                  </a:ext>
-                </a:extLst>
-              </p:spPr>
-              <p:txBody>
-                <a:bodyPr wrap="none" lIns="45719" tIns="45719" rIns="45719" bIns="45719" numCol="1" anchor="t">
-                  <a:spAutoFit/>
-                </a:bodyPr>
-                <a:lstStyle>
-                  <a:lvl1pPr>
-                    <a:defRPr>
-                      <a:latin typeface="Inter"/>
-                      <a:ea typeface="Inter"/>
-                      <a:cs typeface="Inter"/>
-                      <a:sym typeface="Inter"/>
-                    </a:defRPr>
-                  </a:lvl1pPr>
-                </a:lstStyle>
-                <a:p>
-                  <a:r>
-                    <a:t>Tracking</a:t>
-                  </a:r>
-                </a:p>
-              </p:txBody>
-            </p:sp>
-          </p:grpSp>
-          <p:pic>
-            <p:nvPicPr>
-              <p:cNvPr id="286" name="Image 11" descr="Image 11"/>
-              <p:cNvPicPr>
-                <a:picLocks noChangeAspect="1"/>
-              </p:cNvPicPr>
-              <p:nvPr/>
-            </p:nvPicPr>
-            <p:blipFill>
-              <a:blip r:embed="rId11"/>
-              <a:stretch>
-                <a:fillRect/>
-              </a:stretch>
-            </p:blipFill>
-            <p:spPr>
-              <a:xfrm>
-                <a:off x="390419" y="0"/>
-                <a:ext cx="728055" cy="599032"/>
-              </a:xfrm>
-              <a:prstGeom prst="rect">
-                <a:avLst/>
-              </a:prstGeom>
-              <a:ln w="12700" cap="flat">
-                <a:noFill/>
-                <a:miter lim="400000"/>
-              </a:ln>
-              <a:effectLst/>
-            </p:spPr>
-          </p:pic>
-        </p:grpSp>
-        <p:pic>
-          <p:nvPicPr>
-            <p:cNvPr id="288" name="Image 38" descr="Image 38"/>
-            <p:cNvPicPr>
-              <a:picLocks noChangeAspect="1"/>
-            </p:cNvPicPr>
-            <p:nvPr/>
-          </p:nvPicPr>
-          <p:blipFill>
-            <a:blip r:embed="rId12"/>
-            <a:stretch>
-              <a:fillRect/>
-            </a:stretch>
-          </p:blipFill>
-          <p:spPr>
-            <a:xfrm>
-              <a:off x="1138058" y="320055"/>
-              <a:ext cx="351248" cy="213377"/>
-            </a:xfrm>
-            <a:prstGeom prst="rect">
-              <a:avLst/>
-            </a:prstGeom>
-            <a:ln w="12700" cap="flat">
-              <a:noFill/>
-              <a:miter lim="400000"/>
-            </a:ln>
-            <a:effectLst/>
-          </p:spPr>
-        </p:pic>
-      </p:grpSp>
-      <p:pic>
-        <p:nvPicPr>
-          <p:cNvPr id="290" name="Image 41" descr="Image 41"/>
-          <p:cNvPicPr>
-            <a:picLocks noChangeAspect="1"/>
-          </p:cNvPicPr>
-          <p:nvPr/>
-        </p:nvPicPr>
-        <p:blipFill>
-          <a:blip r:embed="rId13"/>
-          <a:stretch>
-            <a:fillRect/>
-          </a:stretch>
-        </p:blipFill>
-        <p:spPr>
-          <a:xfrm>
-            <a:off x="3092480" y="3816081"/>
-            <a:ext cx="759821" cy="410655"/>
-          </a:xfrm>
-          <a:prstGeom prst="rect">
-            <a:avLst/>
-          </a:prstGeom>
-          <a:ln w="12700">
-            <a:miter lim="400000"/>
-          </a:ln>
-        </p:spPr>
-      </p:pic>
-    </p:spTree>
-  </p:cSld>
-  <p:clrMapOvr>
-    <a:masterClrMapping/>
-  </p:clrMapOvr>
-  <p:transition spd="med"/>
-</p:sld>
-</file>
-
-<file path=ppt/slides/slide11.xml><?xml version="1.0" encoding="utf-8"?>
 <p:sld xmlns:a="http://schemas.openxmlformats.org/drawingml/2006/main" xmlns:r="http://schemas.openxmlformats.org/officeDocument/2006/relationships" xmlns:p="http://schemas.openxmlformats.org/presentationml/2006/main">
   <p:cSld>
     <p:spTree>
@@ -4887,8 +4084,8 @@
         </p:blipFill>
         <p:spPr>
           <a:xfrm>
-            <a:off x="4815473" y="1345760"/>
-            <a:ext cx="3861001" cy="3299401"/>
+            <a:off x="4815473" y="1393654"/>
+            <a:ext cx="3861001" cy="3203612"/>
           </a:xfrm>
           <a:prstGeom prst="rect">
             <a:avLst/>
@@ -4936,9 +4133,9 @@
         <p:grpSpPr>
           <a:xfrm>
             <a:off x="2812992" y="3443897"/>
-            <a:ext cx="1508892" cy="1452149"/>
+            <a:ext cx="1508895" cy="1452151"/>
             <a:chOff x="0" y="0"/>
-            <a:chExt cx="1508891" cy="1452148"/>
+            <a:chExt cx="1508894" cy="1452150"/>
           </a:xfrm>
         </p:grpSpPr>
         <p:grpSp>
@@ -4950,9 +4147,9 @@
           <p:grpSpPr>
             <a:xfrm>
               <a:off x="0" y="0"/>
-              <a:ext cx="1508892" cy="1452149"/>
+              <a:ext cx="1508894" cy="1452150"/>
               <a:chOff x="0" y="0"/>
-              <a:chExt cx="1508891" cy="1452148"/>
+              <a:chExt cx="1508893" cy="1452149"/>
             </a:xfrm>
           </p:grpSpPr>
           <p:grpSp>
@@ -4964,9 +4161,9 @@
             <p:grpSpPr>
               <a:xfrm>
                 <a:off x="0" y="401258"/>
-                <a:ext cx="1508892" cy="1050891"/>
+                <a:ext cx="1508893" cy="1050891"/>
                 <a:chOff x="0" y="0"/>
-                <a:chExt cx="1508891" cy="1050889"/>
+                <a:chExt cx="1508892" cy="1050890"/>
               </a:xfrm>
             </p:grpSpPr>
             <p:pic>
@@ -5020,7 +4217,7 @@
                 <a:effectLst/>
                 <a:extLst>
                   <a:ext uri="{C572A759-6A51-4108-AA02-DFA0A04FC94B}">
-                    <ma14:wrappingTextBoxFlag xmlns:ma14="http://schemas.microsoft.com/office/mac/drawingml/2011/main" xmlns:a14="http://schemas.microsoft.com/office/drawing/2010/main" xmlns:m="http://schemas.openxmlformats.org/officeDocument/2006/math" xmlns="" val="1"/>
+                    <ma14:wrappingTextBoxFlag xmlns="" xmlns:m="http://schemas.openxmlformats.org/officeDocument/2006/math" xmlns:a14="http://schemas.microsoft.com/office/drawing/2010/main" xmlns:ma14="http://schemas.microsoft.com/office/mac/drawingml/2011/main" val="1"/>
                   </a:ext>
                 </a:extLst>
               </p:spPr>
@@ -5105,10 +4302,10 @@
         </p:nvGrpSpPr>
         <p:grpSpPr>
           <a:xfrm>
-            <a:off x="5074482" y="1489796"/>
-            <a:ext cx="1284870" cy="863623"/>
-            <a:chOff x="0" y="0"/>
-            <a:chExt cx="1284869" cy="863622"/>
+            <a:off x="5074481" y="1489796"/>
+            <a:ext cx="1284872" cy="863623"/>
+            <a:chOff x="-1" y="0"/>
+            <a:chExt cx="1284871" cy="863623"/>
           </a:xfrm>
         </p:grpSpPr>
         <p:sp>
@@ -5133,7 +4330,7 @@
             <a:effectLst/>
             <a:extLst>
               <a:ext uri="{C572A759-6A51-4108-AA02-DFA0A04FC94B}">
-                <ma14:wrappingTextBoxFlag xmlns:ma14="http://schemas.microsoft.com/office/mac/drawingml/2011/main" xmlns:a14="http://schemas.microsoft.com/office/drawing/2010/main" xmlns:m="http://schemas.openxmlformats.org/officeDocument/2006/math" xmlns="" val="1"/>
+                <ma14:wrappingTextBoxFlag xmlns="" xmlns:m="http://schemas.openxmlformats.org/officeDocument/2006/math" xmlns:a14="http://schemas.microsoft.com/office/drawing/2010/main" xmlns:ma14="http://schemas.microsoft.com/office/mac/drawingml/2011/main" val="1"/>
               </a:ext>
             </a:extLst>
           </p:spPr>
@@ -5167,9 +4364,9 @@
           <p:grpSpPr>
             <a:xfrm>
               <a:off x="-1" y="0"/>
-              <a:ext cx="1134268" cy="632036"/>
+              <a:ext cx="1134269" cy="632037"/>
               <a:chOff x="0" y="0"/>
-              <a:chExt cx="1134266" cy="632035"/>
+              <a:chExt cx="1134267" cy="632036"/>
             </a:xfrm>
           </p:grpSpPr>
           <p:pic>
@@ -5240,10 +4437,10 @@
         </p:nvGrpSpPr>
         <p:grpSpPr>
           <a:xfrm>
-            <a:off x="6998003" y="2855765"/>
-            <a:ext cx="1327672" cy="1005705"/>
-            <a:chOff x="0" y="0"/>
-            <a:chExt cx="1327671" cy="1005704"/>
+            <a:off x="6998003" y="2855764"/>
+            <a:ext cx="1327674" cy="1005707"/>
+            <a:chOff x="0" y="-1"/>
+            <a:chExt cx="1327673" cy="1005706"/>
           </a:xfrm>
         </p:grpSpPr>
         <p:grpSp>
@@ -5255,9 +4452,9 @@
           <p:grpSpPr>
             <a:xfrm>
               <a:off x="129243" y="-1"/>
-              <a:ext cx="1198429" cy="1005706"/>
+              <a:ext cx="1198430" cy="1005706"/>
               <a:chOff x="0" y="0"/>
-              <a:chExt cx="1198427" cy="1005704"/>
+              <a:chExt cx="1198428" cy="1005705"/>
             </a:xfrm>
           </p:grpSpPr>
           <p:pic>
@@ -5311,7 +4508,7 @@
               <a:effectLst/>
               <a:extLst>
                 <a:ext uri="{C572A759-6A51-4108-AA02-DFA0A04FC94B}">
-                  <ma14:wrappingTextBoxFlag xmlns:ma14="http://schemas.microsoft.com/office/mac/drawingml/2011/main" xmlns:a14="http://schemas.microsoft.com/office/drawing/2010/main" xmlns:m="http://schemas.openxmlformats.org/officeDocument/2006/math" xmlns="" val="1"/>
+                  <ma14:wrappingTextBoxFlag xmlns="" xmlns:m="http://schemas.openxmlformats.org/officeDocument/2006/math" xmlns:a14="http://schemas.microsoft.com/office/drawing/2010/main" xmlns:ma14="http://schemas.microsoft.com/office/mac/drawingml/2011/main" val="1"/>
                 </a:ext>
               </a:extLst>
             </p:spPr>
@@ -5375,10 +4572,10 @@
         </p:nvGrpSpPr>
         <p:grpSpPr>
           <a:xfrm>
-            <a:off x="4991815" y="2520993"/>
-            <a:ext cx="1184279" cy="913434"/>
-            <a:chOff x="0" y="0"/>
-            <a:chExt cx="1184278" cy="913432"/>
+            <a:off x="4991814" y="2520993"/>
+            <a:ext cx="1184282" cy="913435"/>
+            <a:chOff x="-1" y="0"/>
+            <a:chExt cx="1184281" cy="913434"/>
           </a:xfrm>
         </p:grpSpPr>
         <p:grpSp>
@@ -5390,9 +4587,9 @@
           <p:grpSpPr>
             <a:xfrm>
               <a:off x="-1" y="27498"/>
-              <a:ext cx="1184280" cy="885935"/>
+              <a:ext cx="1184281" cy="885936"/>
               <a:chOff x="0" y="0"/>
-              <a:chExt cx="1184278" cy="885935"/>
+              <a:chExt cx="1184279" cy="885936"/>
             </a:xfrm>
           </p:grpSpPr>
           <p:pic>
@@ -5446,7 +4643,7 @@
               <a:effectLst/>
               <a:extLst>
                 <a:ext uri="{C572A759-6A51-4108-AA02-DFA0A04FC94B}">
-                  <ma14:wrappingTextBoxFlag xmlns:ma14="http://schemas.microsoft.com/office/mac/drawingml/2011/main" xmlns:a14="http://schemas.microsoft.com/office/drawing/2010/main" xmlns:m="http://schemas.openxmlformats.org/officeDocument/2006/math" xmlns="" val="1"/>
+                  <ma14:wrappingTextBoxFlag xmlns="" xmlns:m="http://schemas.openxmlformats.org/officeDocument/2006/math" xmlns:a14="http://schemas.microsoft.com/office/drawing/2010/main" xmlns:ma14="http://schemas.microsoft.com/office/mac/drawingml/2011/main" val="1"/>
                 </a:ext>
               </a:extLst>
             </p:spPr>
@@ -5523,9 +4720,9 @@
         <p:grpSpPr>
           <a:xfrm>
             <a:off x="5032095" y="3665180"/>
-            <a:ext cx="1348456" cy="632036"/>
+            <a:ext cx="1348458" cy="632038"/>
             <a:chOff x="0" y="0"/>
-            <a:chExt cx="1348454" cy="632035"/>
+            <a:chExt cx="1348457" cy="632037"/>
           </a:xfrm>
         </p:grpSpPr>
         <p:grpSp>
@@ -5537,9 +4734,9 @@
           <p:grpSpPr>
             <a:xfrm>
               <a:off x="0" y="0"/>
-              <a:ext cx="1348455" cy="632036"/>
+              <a:ext cx="1348457" cy="632037"/>
               <a:chOff x="0" y="0"/>
-              <a:chExt cx="1348454" cy="632035"/>
+              <a:chExt cx="1348455" cy="632036"/>
             </a:xfrm>
           </p:grpSpPr>
           <p:pic>
@@ -5593,7 +4790,7 @@
               <a:effectLst/>
               <a:extLst>
                 <a:ext uri="{C572A759-6A51-4108-AA02-DFA0A04FC94B}">
-                  <ma14:wrappingTextBoxFlag xmlns:ma14="http://schemas.microsoft.com/office/mac/drawingml/2011/main" xmlns:a14="http://schemas.microsoft.com/office/drawing/2010/main" xmlns:m="http://schemas.openxmlformats.org/officeDocument/2006/math" xmlns="" val="1"/>
+                  <ma14:wrappingTextBoxFlag xmlns="" xmlns:m="http://schemas.openxmlformats.org/officeDocument/2006/math" xmlns:a14="http://schemas.microsoft.com/office/drawing/2010/main" xmlns:ma14="http://schemas.microsoft.com/office/mac/drawingml/2011/main" val="1"/>
                 </a:ext>
               </a:extLst>
             </p:spPr>
@@ -5775,7 +4972,7 @@
 </p:sld>
 </file>
 
-<file path=ppt/slides/slide12.xml><?xml version="1.0" encoding="utf-8"?>
+<file path=ppt/slides/slide11.xml><?xml version="1.0" encoding="utf-8"?>
 <p:sld xmlns:a="http://schemas.openxmlformats.org/drawingml/2006/main" xmlns:r="http://schemas.openxmlformats.org/officeDocument/2006/relationships" xmlns:p="http://schemas.openxmlformats.org/presentationml/2006/main">
   <p:cSld>
     <p:spTree>
@@ -5936,7 +5133,7 @@
           </a:ln>
           <a:extLst>
             <a:ext uri="{C572A759-6A51-4108-AA02-DFA0A04FC94B}">
-              <ma14:wrappingTextBoxFlag xmlns:ma14="http://schemas.microsoft.com/office/mac/drawingml/2011/main" xmlns:a14="http://schemas.microsoft.com/office/drawing/2010/main" xmlns:m="http://schemas.openxmlformats.org/officeDocument/2006/math" xmlns="" val="1"/>
+              <ma14:wrappingTextBoxFlag xmlns="" xmlns:m="http://schemas.openxmlformats.org/officeDocument/2006/math" xmlns:a14="http://schemas.microsoft.com/office/drawing/2010/main" xmlns:ma14="http://schemas.microsoft.com/office/mac/drawingml/2011/main" val="1"/>
             </a:ext>
           </a:extLst>
         </p:spPr>
@@ -6137,7 +5334,7 @@
 </p:sld>
 </file>
 
-<file path=ppt/slides/slide13.xml><?xml version="1.0" encoding="utf-8"?>
+<file path=ppt/slides/slide12.xml><?xml version="1.0" encoding="utf-8"?>
 <p:sld xmlns:a="http://schemas.openxmlformats.org/drawingml/2006/main" xmlns:r="http://schemas.openxmlformats.org/officeDocument/2006/relationships" xmlns:p="http://schemas.openxmlformats.org/presentationml/2006/main">
   <p:cSld>
     <p:spTree>
@@ -6298,7 +5495,7 @@
           </a:ln>
           <a:extLst>
             <a:ext uri="{C572A759-6A51-4108-AA02-DFA0A04FC94B}">
-              <ma14:wrappingTextBoxFlag xmlns:ma14="http://schemas.microsoft.com/office/mac/drawingml/2011/main" xmlns:a14="http://schemas.microsoft.com/office/drawing/2010/main" xmlns:m="http://schemas.openxmlformats.org/officeDocument/2006/math" xmlns="" val="1"/>
+              <ma14:wrappingTextBoxFlag xmlns="" xmlns:m="http://schemas.openxmlformats.org/officeDocument/2006/math" xmlns:a14="http://schemas.microsoft.com/office/drawing/2010/main" xmlns:ma14="http://schemas.microsoft.com/office/mac/drawingml/2011/main" val="1"/>
             </a:ext>
           </a:extLst>
         </p:spPr>
@@ -6503,7 +5700,7 @@
 </p:sld>
 </file>
 
-<file path=ppt/slides/slide14.xml><?xml version="1.0" encoding="utf-8"?>
+<file path=ppt/slides/slide13.xml><?xml version="1.0" encoding="utf-8"?>
 <p:sld xmlns:a="http://schemas.openxmlformats.org/drawingml/2006/main" xmlns:r="http://schemas.openxmlformats.org/officeDocument/2006/relationships" xmlns:p="http://schemas.openxmlformats.org/presentationml/2006/main">
   <p:cSld>
     <p:bg>
@@ -6632,7 +5829,7 @@
 </p:sld>
 </file>
 
-<file path=ppt/slides/slide15.xml><?xml version="1.0" encoding="utf-8"?>
+<file path=ppt/slides/slide14.xml><?xml version="1.0" encoding="utf-8"?>
 <p:sld xmlns:a="http://schemas.openxmlformats.org/drawingml/2006/main" xmlns:r="http://schemas.openxmlformats.org/officeDocument/2006/relationships" xmlns:p="http://schemas.openxmlformats.org/presentationml/2006/main">
   <p:cSld>
     <p:spTree>
@@ -6795,7 +5992,7 @@
           </a:ln>
           <a:extLst>
             <a:ext uri="{C572A759-6A51-4108-AA02-DFA0A04FC94B}">
-              <ma14:wrappingTextBoxFlag xmlns:ma14="http://schemas.microsoft.com/office/mac/drawingml/2011/main" xmlns:a14="http://schemas.microsoft.com/office/drawing/2010/main" xmlns:m="http://schemas.openxmlformats.org/officeDocument/2006/math" xmlns="" val="1"/>
+              <ma14:wrappingTextBoxFlag xmlns="" xmlns:m="http://schemas.openxmlformats.org/officeDocument/2006/math" xmlns:a14="http://schemas.microsoft.com/office/drawing/2010/main" xmlns:ma14="http://schemas.microsoft.com/office/mac/drawingml/2011/main" val="1"/>
             </a:ext>
           </a:extLst>
         </p:spPr>
@@ -6900,7 +6097,7 @@
           </a:ln>
           <a:extLst>
             <a:ext uri="{C572A759-6A51-4108-AA02-DFA0A04FC94B}">
-              <ma14:wrappingTextBoxFlag xmlns:ma14="http://schemas.microsoft.com/office/mac/drawingml/2011/main" xmlns:a14="http://schemas.microsoft.com/office/drawing/2010/main" xmlns:m="http://schemas.openxmlformats.org/officeDocument/2006/math" xmlns="" val="1"/>
+              <ma14:wrappingTextBoxFlag xmlns="" xmlns:m="http://schemas.openxmlformats.org/officeDocument/2006/math" xmlns:a14="http://schemas.microsoft.com/office/drawing/2010/main" xmlns:ma14="http://schemas.microsoft.com/office/mac/drawingml/2011/main" val="1"/>
             </a:ext>
           </a:extLst>
         </p:spPr>
@@ -7023,7 +6220,7 @@
 </p:sld>
 </file>
 
-<file path=ppt/slides/slide16.xml><?xml version="1.0" encoding="utf-8"?>
+<file path=ppt/slides/slide15.xml><?xml version="1.0" encoding="utf-8"?>
 <p:sld xmlns:a="http://schemas.openxmlformats.org/drawingml/2006/main" xmlns:r="http://schemas.openxmlformats.org/officeDocument/2006/relationships" xmlns:p="http://schemas.openxmlformats.org/presentationml/2006/main">
   <p:cSld>
     <p:spTree>
@@ -7173,9 +6370,9 @@
         <p:grpSpPr>
           <a:xfrm>
             <a:off x="4261163" y="1653247"/>
-            <a:ext cx="1508892" cy="1050891"/>
+            <a:ext cx="1508893" cy="1050891"/>
             <a:chOff x="0" y="0"/>
-            <a:chExt cx="1508891" cy="1050889"/>
+            <a:chExt cx="1508892" cy="1050890"/>
           </a:xfrm>
         </p:grpSpPr>
         <p:pic>
@@ -7229,7 +6426,7 @@
             <a:effectLst/>
             <a:extLst>
               <a:ext uri="{C572A759-6A51-4108-AA02-DFA0A04FC94B}">
-                <ma14:wrappingTextBoxFlag xmlns:ma14="http://schemas.microsoft.com/office/mac/drawingml/2011/main" xmlns:a14="http://schemas.microsoft.com/office/drawing/2010/main" xmlns:m="http://schemas.openxmlformats.org/officeDocument/2006/math" xmlns="" val="1"/>
+                <ma14:wrappingTextBoxFlag xmlns="" xmlns:m="http://schemas.openxmlformats.org/officeDocument/2006/math" xmlns:a14="http://schemas.microsoft.com/office/drawing/2010/main" xmlns:ma14="http://schemas.microsoft.com/office/mac/drawingml/2011/main" val="1"/>
               </a:ext>
             </a:extLst>
           </p:spPr>
@@ -7255,9 +6452,9 @@
         <p:grpSpPr>
           <a:xfrm>
             <a:off x="5770055" y="1653247"/>
-            <a:ext cx="1508892" cy="1050891"/>
+            <a:ext cx="1508893" cy="1050891"/>
             <a:chOff x="0" y="0"/>
-            <a:chExt cx="1508891" cy="1050889"/>
+            <a:chExt cx="1508892" cy="1050890"/>
           </a:xfrm>
         </p:grpSpPr>
         <p:pic>
@@ -7311,7 +6508,7 @@
             <a:effectLst/>
             <a:extLst>
               <a:ext uri="{C572A759-6A51-4108-AA02-DFA0A04FC94B}">
-                <ma14:wrappingTextBoxFlag xmlns:ma14="http://schemas.microsoft.com/office/mac/drawingml/2011/main" xmlns:a14="http://schemas.microsoft.com/office/drawing/2010/main" xmlns:m="http://schemas.openxmlformats.org/officeDocument/2006/math" xmlns="" val="1"/>
+                <ma14:wrappingTextBoxFlag xmlns="" xmlns:m="http://schemas.openxmlformats.org/officeDocument/2006/math" xmlns:a14="http://schemas.microsoft.com/office/drawing/2010/main" xmlns:ma14="http://schemas.microsoft.com/office/mac/drawingml/2011/main" val="1"/>
               </a:ext>
             </a:extLst>
           </p:spPr>
@@ -8226,7 +7423,7 @@
           </a:ln>
           <a:extLst>
             <a:ext uri="{C572A759-6A51-4108-AA02-DFA0A04FC94B}">
-              <ma14:wrappingTextBoxFlag xmlns:ma14="http://schemas.microsoft.com/office/mac/drawingml/2011/main" xmlns:a14="http://schemas.microsoft.com/office/drawing/2010/main" xmlns:m="http://schemas.openxmlformats.org/officeDocument/2006/math" xmlns="" val="1"/>
+              <ma14:wrappingTextBoxFlag xmlns="" xmlns:m="http://schemas.openxmlformats.org/officeDocument/2006/math" xmlns:a14="http://schemas.microsoft.com/office/drawing/2010/main" xmlns:ma14="http://schemas.microsoft.com/office/mac/drawingml/2011/main" val="1"/>
             </a:ext>
           </a:extLst>
         </p:spPr>
@@ -8499,7 +7696,7 @@
           </a:ln>
           <a:extLst>
             <a:ext uri="{C572A759-6A51-4108-AA02-DFA0A04FC94B}">
-              <ma14:wrappingTextBoxFlag xmlns:ma14="http://schemas.microsoft.com/office/mac/drawingml/2011/main" xmlns:a14="http://schemas.microsoft.com/office/drawing/2010/main" xmlns:m="http://schemas.openxmlformats.org/officeDocument/2006/math" xmlns="" val="1"/>
+              <ma14:wrappingTextBoxFlag xmlns="" xmlns:m="http://schemas.openxmlformats.org/officeDocument/2006/math" xmlns:a14="http://schemas.microsoft.com/office/drawing/2010/main" xmlns:ma14="http://schemas.microsoft.com/office/mac/drawingml/2011/main" val="1"/>
             </a:ext>
           </a:extLst>
         </p:spPr>
@@ -8546,7 +7743,7 @@
           </a:ln>
           <a:extLst>
             <a:ext uri="{C572A759-6A51-4108-AA02-DFA0A04FC94B}">
-              <ma14:wrappingTextBoxFlag xmlns:ma14="http://schemas.microsoft.com/office/mac/drawingml/2011/main" xmlns:a14="http://schemas.microsoft.com/office/drawing/2010/main" xmlns:m="http://schemas.openxmlformats.org/officeDocument/2006/math" xmlns="" val="1"/>
+              <ma14:wrappingTextBoxFlag xmlns="" xmlns:m="http://schemas.openxmlformats.org/officeDocument/2006/math" xmlns:a14="http://schemas.microsoft.com/office/drawing/2010/main" xmlns:ma14="http://schemas.microsoft.com/office/mac/drawingml/2011/main" val="1"/>
             </a:ext>
           </a:extLst>
         </p:spPr>
@@ -8593,7 +7790,7 @@
           </a:ln>
           <a:extLst>
             <a:ext uri="{C572A759-6A51-4108-AA02-DFA0A04FC94B}">
-              <ma14:wrappingTextBoxFlag xmlns:ma14="http://schemas.microsoft.com/office/mac/drawingml/2011/main" xmlns:a14="http://schemas.microsoft.com/office/drawing/2010/main" xmlns:m="http://schemas.openxmlformats.org/officeDocument/2006/math" xmlns="" val="1"/>
+              <ma14:wrappingTextBoxFlag xmlns="" xmlns:m="http://schemas.openxmlformats.org/officeDocument/2006/math" xmlns:a14="http://schemas.microsoft.com/office/drawing/2010/main" xmlns:ma14="http://schemas.microsoft.com/office/mac/drawingml/2011/main" val="1"/>
             </a:ext>
           </a:extLst>
         </p:spPr>
@@ -8640,7 +7837,7 @@
           </a:ln>
           <a:extLst>
             <a:ext uri="{C572A759-6A51-4108-AA02-DFA0A04FC94B}">
-              <ma14:wrappingTextBoxFlag xmlns:ma14="http://schemas.microsoft.com/office/mac/drawingml/2011/main" xmlns:a14="http://schemas.microsoft.com/office/drawing/2010/main" xmlns:m="http://schemas.openxmlformats.org/officeDocument/2006/math" xmlns="" val="1"/>
+              <ma14:wrappingTextBoxFlag xmlns="" xmlns:m="http://schemas.openxmlformats.org/officeDocument/2006/math" xmlns:a14="http://schemas.microsoft.com/office/drawing/2010/main" xmlns:ma14="http://schemas.microsoft.com/office/mac/drawingml/2011/main" val="1"/>
             </a:ext>
           </a:extLst>
         </p:spPr>
@@ -9175,7 +8372,7 @@
           </a:ln>
           <a:extLst>
             <a:ext uri="{C572A759-6A51-4108-AA02-DFA0A04FC94B}">
-              <ma14:wrappingTextBoxFlag xmlns:ma14="http://schemas.microsoft.com/office/mac/drawingml/2011/main" xmlns:a14="http://schemas.microsoft.com/office/drawing/2010/main" xmlns:m="http://schemas.openxmlformats.org/officeDocument/2006/math" xmlns="" val="1"/>
+              <ma14:wrappingTextBoxFlag xmlns="" xmlns:m="http://schemas.openxmlformats.org/officeDocument/2006/math" xmlns:a14="http://schemas.microsoft.com/office/drawing/2010/main" xmlns:ma14="http://schemas.microsoft.com/office/mac/drawingml/2011/main" val="1"/>
             </a:ext>
           </a:extLst>
         </p:spPr>
@@ -9222,7 +8419,7 @@
           </a:ln>
           <a:extLst>
             <a:ext uri="{C572A759-6A51-4108-AA02-DFA0A04FC94B}">
-              <ma14:wrappingTextBoxFlag xmlns:ma14="http://schemas.microsoft.com/office/mac/drawingml/2011/main" xmlns:a14="http://schemas.microsoft.com/office/drawing/2010/main" xmlns:m="http://schemas.openxmlformats.org/officeDocument/2006/math" xmlns="" val="1"/>
+              <ma14:wrappingTextBoxFlag xmlns="" xmlns:m="http://schemas.openxmlformats.org/officeDocument/2006/math" xmlns:a14="http://schemas.microsoft.com/office/drawing/2010/main" xmlns:ma14="http://schemas.microsoft.com/office/mac/drawingml/2011/main" val="1"/>
             </a:ext>
           </a:extLst>
         </p:spPr>
@@ -9269,7 +8466,7 @@
           </a:ln>
           <a:extLst>
             <a:ext uri="{C572A759-6A51-4108-AA02-DFA0A04FC94B}">
-              <ma14:wrappingTextBoxFlag xmlns:ma14="http://schemas.microsoft.com/office/mac/drawingml/2011/main" xmlns:a14="http://schemas.microsoft.com/office/drawing/2010/main" xmlns:m="http://schemas.openxmlformats.org/officeDocument/2006/math" xmlns="" val="1"/>
+              <ma14:wrappingTextBoxFlag xmlns="" xmlns:m="http://schemas.openxmlformats.org/officeDocument/2006/math" xmlns:a14="http://schemas.microsoft.com/office/drawing/2010/main" xmlns:ma14="http://schemas.microsoft.com/office/mac/drawingml/2011/main" val="1"/>
             </a:ext>
           </a:extLst>
         </p:spPr>
@@ -9316,7 +8513,7 @@
           </a:ln>
           <a:extLst>
             <a:ext uri="{C572A759-6A51-4108-AA02-DFA0A04FC94B}">
-              <ma14:wrappingTextBoxFlag xmlns:ma14="http://schemas.microsoft.com/office/mac/drawingml/2011/main" xmlns:a14="http://schemas.microsoft.com/office/drawing/2010/main" xmlns:m="http://schemas.openxmlformats.org/officeDocument/2006/math" xmlns="" val="1"/>
+              <ma14:wrappingTextBoxFlag xmlns="" xmlns:m="http://schemas.openxmlformats.org/officeDocument/2006/math" xmlns:a14="http://schemas.microsoft.com/office/drawing/2010/main" xmlns:ma14="http://schemas.microsoft.com/office/mac/drawingml/2011/main" val="1"/>
             </a:ext>
           </a:extLst>
         </p:spPr>
@@ -9363,7 +8560,7 @@
           </a:ln>
           <a:extLst>
             <a:ext uri="{C572A759-6A51-4108-AA02-DFA0A04FC94B}">
-              <ma14:wrappingTextBoxFlag xmlns:ma14="http://schemas.microsoft.com/office/mac/drawingml/2011/main" xmlns:a14="http://schemas.microsoft.com/office/drawing/2010/main" xmlns:m="http://schemas.openxmlformats.org/officeDocument/2006/math" xmlns="" val="1"/>
+              <ma14:wrappingTextBoxFlag xmlns="" xmlns:m="http://schemas.openxmlformats.org/officeDocument/2006/math" xmlns:a14="http://schemas.microsoft.com/office/drawing/2010/main" xmlns:ma14="http://schemas.microsoft.com/office/mac/drawingml/2011/main" val="1"/>
             </a:ext>
           </a:extLst>
         </p:spPr>
@@ -9410,7 +8607,7 @@
           </a:ln>
           <a:extLst>
             <a:ext uri="{C572A759-6A51-4108-AA02-DFA0A04FC94B}">
-              <ma14:wrappingTextBoxFlag xmlns:ma14="http://schemas.microsoft.com/office/mac/drawingml/2011/main" xmlns:a14="http://schemas.microsoft.com/office/drawing/2010/main" xmlns:m="http://schemas.openxmlformats.org/officeDocument/2006/math" xmlns="" val="1"/>
+              <ma14:wrappingTextBoxFlag xmlns="" xmlns:m="http://schemas.openxmlformats.org/officeDocument/2006/math" xmlns:a14="http://schemas.microsoft.com/office/drawing/2010/main" xmlns:ma14="http://schemas.microsoft.com/office/mac/drawingml/2011/main" val="1"/>
             </a:ext>
           </a:extLst>
         </p:spPr>
@@ -9512,7 +8709,9 @@
           </a:prstGeom>
         </p:spPr>
         <p:txBody>
-          <a:bodyPr/>
+          <a:bodyPr>
+            <a:normAutofit fontScale="90000"/>
+          </a:bodyPr>
           <a:lstStyle>
             <a:lvl1pPr defTabSz="822958">
               <a:defRPr sz="2200">
@@ -9528,8 +8727,14 @@
           </a:lstStyle>
           <a:p>
             <a:r>
+              <a:rPr dirty="0"/>
               <a:t>Football predictor application</a:t>
             </a:r>
+            <a:r>
+              <a:rPr lang="fr-FR" dirty="0"/>
+              <a:t> - Démonstration</a:t>
+            </a:r>
+            <a:endParaRPr dirty="0"/>
           </a:p>
         </p:txBody>
       </p:sp>
@@ -9984,7 +9189,7 @@
           </a:ln>
           <a:extLst>
             <a:ext uri="{C572A759-6A51-4108-AA02-DFA0A04FC94B}">
-              <ma14:wrappingTextBoxFlag xmlns:ma14="http://schemas.microsoft.com/office/mac/drawingml/2011/main" xmlns:a14="http://schemas.microsoft.com/office/drawing/2010/main" xmlns:m="http://schemas.openxmlformats.org/officeDocument/2006/math" xmlns="" val="1"/>
+              <ma14:wrappingTextBoxFlag xmlns="" xmlns:m="http://schemas.openxmlformats.org/officeDocument/2006/math" xmlns:a14="http://schemas.microsoft.com/office/drawing/2010/main" xmlns:ma14="http://schemas.microsoft.com/office/mac/drawingml/2011/main" val="1"/>
             </a:ext>
           </a:extLst>
         </p:spPr>
@@ -10031,7 +9236,7 @@
           </a:ln>
           <a:extLst>
             <a:ext uri="{C572A759-6A51-4108-AA02-DFA0A04FC94B}">
-              <ma14:wrappingTextBoxFlag xmlns:ma14="http://schemas.microsoft.com/office/mac/drawingml/2011/main" xmlns:a14="http://schemas.microsoft.com/office/drawing/2010/main" xmlns:m="http://schemas.openxmlformats.org/officeDocument/2006/math" xmlns="" val="1"/>
+              <ma14:wrappingTextBoxFlag xmlns="" xmlns:m="http://schemas.openxmlformats.org/officeDocument/2006/math" xmlns:a14="http://schemas.microsoft.com/office/drawing/2010/main" xmlns:ma14="http://schemas.microsoft.com/office/mac/drawingml/2011/main" val="1"/>
             </a:ext>
           </a:extLst>
         </p:spPr>
@@ -10078,7 +9283,7 @@
           </a:ln>
           <a:extLst>
             <a:ext uri="{C572A759-6A51-4108-AA02-DFA0A04FC94B}">
-              <ma14:wrappingTextBoxFlag xmlns:ma14="http://schemas.microsoft.com/office/mac/drawingml/2011/main" xmlns:a14="http://schemas.microsoft.com/office/drawing/2010/main" xmlns:m="http://schemas.openxmlformats.org/officeDocument/2006/math" xmlns="" val="1"/>
+              <ma14:wrappingTextBoxFlag xmlns="" xmlns:m="http://schemas.openxmlformats.org/officeDocument/2006/math" xmlns:a14="http://schemas.microsoft.com/office/drawing/2010/main" xmlns:ma14="http://schemas.microsoft.com/office/mac/drawingml/2011/main" val="1"/>
             </a:ext>
           </a:extLst>
         </p:spPr>
@@ -10125,7 +9330,7 @@
           </a:ln>
           <a:extLst>
             <a:ext uri="{C572A759-6A51-4108-AA02-DFA0A04FC94B}">
-              <ma14:wrappingTextBoxFlag xmlns:ma14="http://schemas.microsoft.com/office/mac/drawingml/2011/main" xmlns:a14="http://schemas.microsoft.com/office/drawing/2010/main" xmlns:m="http://schemas.openxmlformats.org/officeDocument/2006/math" xmlns="" val="1"/>
+              <ma14:wrappingTextBoxFlag xmlns="" xmlns:m="http://schemas.openxmlformats.org/officeDocument/2006/math" xmlns:a14="http://schemas.microsoft.com/office/drawing/2010/main" xmlns:ma14="http://schemas.microsoft.com/office/mac/drawingml/2011/main" val="1"/>
             </a:ext>
           </a:extLst>
         </p:spPr>
@@ -10172,7 +9377,7 @@
           </a:ln>
           <a:extLst>
             <a:ext uri="{C572A759-6A51-4108-AA02-DFA0A04FC94B}">
-              <ma14:wrappingTextBoxFlag xmlns:ma14="http://schemas.microsoft.com/office/mac/drawingml/2011/main" xmlns:a14="http://schemas.microsoft.com/office/drawing/2010/main" xmlns:m="http://schemas.openxmlformats.org/officeDocument/2006/math" xmlns="" val="1"/>
+              <ma14:wrappingTextBoxFlag xmlns="" xmlns:m="http://schemas.openxmlformats.org/officeDocument/2006/math" xmlns:a14="http://schemas.microsoft.com/office/drawing/2010/main" xmlns:ma14="http://schemas.microsoft.com/office/mac/drawingml/2011/main" val="1"/>
             </a:ext>
           </a:extLst>
         </p:spPr>
@@ -10219,7 +9424,7 @@
           </a:ln>
           <a:extLst>
             <a:ext uri="{C572A759-6A51-4108-AA02-DFA0A04FC94B}">
-              <ma14:wrappingTextBoxFlag xmlns:ma14="http://schemas.microsoft.com/office/mac/drawingml/2011/main" xmlns:a14="http://schemas.microsoft.com/office/drawing/2010/main" xmlns:m="http://schemas.openxmlformats.org/officeDocument/2006/math" xmlns="" val="1"/>
+              <ma14:wrappingTextBoxFlag xmlns="" xmlns:m="http://schemas.openxmlformats.org/officeDocument/2006/math" xmlns:a14="http://schemas.microsoft.com/office/drawing/2010/main" xmlns:ma14="http://schemas.microsoft.com/office/mac/drawingml/2011/main" val="1"/>
             </a:ext>
           </a:extLst>
         </p:spPr>
@@ -10266,7 +9471,7 @@
           </a:ln>
           <a:extLst>
             <a:ext uri="{C572A759-6A51-4108-AA02-DFA0A04FC94B}">
-              <ma14:wrappingTextBoxFlag xmlns:ma14="http://schemas.microsoft.com/office/mac/drawingml/2011/main" xmlns:a14="http://schemas.microsoft.com/office/drawing/2010/main" xmlns:m="http://schemas.openxmlformats.org/officeDocument/2006/math" xmlns="" val="1"/>
+              <ma14:wrappingTextBoxFlag xmlns="" xmlns:m="http://schemas.openxmlformats.org/officeDocument/2006/math" xmlns:a14="http://schemas.microsoft.com/office/drawing/2010/main" xmlns:ma14="http://schemas.microsoft.com/office/mac/drawingml/2011/main" val="1"/>
             </a:ext>
           </a:extLst>
         </p:spPr>
@@ -10313,7 +9518,7 @@
           </a:ln>
           <a:extLst>
             <a:ext uri="{C572A759-6A51-4108-AA02-DFA0A04FC94B}">
-              <ma14:wrappingTextBoxFlag xmlns:ma14="http://schemas.microsoft.com/office/mac/drawingml/2011/main" xmlns:a14="http://schemas.microsoft.com/office/drawing/2010/main" xmlns:m="http://schemas.openxmlformats.org/officeDocument/2006/math" xmlns="" val="1"/>
+              <ma14:wrappingTextBoxFlag xmlns="" xmlns:m="http://schemas.openxmlformats.org/officeDocument/2006/math" xmlns:a14="http://schemas.microsoft.com/office/drawing/2010/main" xmlns:ma14="http://schemas.microsoft.com/office/mac/drawingml/2011/main" val="1"/>
             </a:ext>
           </a:extLst>
         </p:spPr>
@@ -10341,161 +9546,12 @@
           </a:p>
         </p:txBody>
       </p:sp>
-    </p:spTree>
-  </p:cSld>
-  <p:clrMapOvr>
-    <a:masterClrMapping/>
-  </p:clrMapOvr>
-  <p:transition spd="med"/>
-</p:sld>
-</file>
-
-<file path=ppt/slides/slide6.xml><?xml version="1.0" encoding="utf-8"?>
-<p:sld xmlns:a="http://schemas.openxmlformats.org/drawingml/2006/main" xmlns:r="http://schemas.openxmlformats.org/officeDocument/2006/relationships" xmlns:p="http://schemas.openxmlformats.org/presentationml/2006/main">
-  <p:cSld>
-    <p:spTree>
-      <p:nvGrpSpPr>
-        <p:cNvPr id="1" name="">
-          <a:extLst>
-            <a:ext uri="{FF2B5EF4-FFF2-40B4-BE49-F238E27FC236}">
-              <a16:creationId xmlns:a16="http://schemas.microsoft.com/office/drawing/2014/main" id="{A7B39AC5-8BE7-B9AA-7BBC-512B4E68391C}"/>
-            </a:ext>
-          </a:extLst>
-        </p:cNvPr>
-        <p:cNvGrpSpPr/>
-        <p:nvPr/>
-      </p:nvGrpSpPr>
-      <p:grpSpPr>
-        <a:xfrm>
-          <a:off x="0" y="0"/>
-          <a:ext cx="0" cy="0"/>
-          <a:chOff x="0" y="0"/>
-          <a:chExt cx="0" cy="0"/>
-        </a:xfrm>
-      </p:grpSpPr>
       <p:sp>
         <p:nvSpPr>
-          <p:cNvPr id="145" name="Google Shape;68;p15">
+          <p:cNvPr id="5" name="flab">
             <a:extLst>
               <a:ext uri="{FF2B5EF4-FFF2-40B4-BE49-F238E27FC236}">
-                <a16:creationId xmlns:a16="http://schemas.microsoft.com/office/drawing/2014/main" id="{2B5F8F97-9B12-1B98-6E8E-BD92FCE00B0C}"/>
-              </a:ext>
-            </a:extLst>
-          </p:cNvPr>
-          <p:cNvSpPr txBox="1">
-            <a:spLocks noGrp="1"/>
-          </p:cNvSpPr>
-          <p:nvPr>
-            <p:ph type="title"/>
-          </p:nvPr>
-        </p:nvSpPr>
-        <p:spPr>
-          <a:xfrm>
-            <a:off x="1192663" y="403307"/>
-            <a:ext cx="5315103" cy="533103"/>
-          </a:xfrm>
-          <a:prstGeom prst="rect">
-            <a:avLst/>
-          </a:prstGeom>
-        </p:spPr>
-        <p:txBody>
-          <a:bodyPr/>
-          <a:lstStyle>
-            <a:lvl1pPr defTabSz="822958">
-              <a:defRPr sz="2200">
-                <a:solidFill>
-                  <a:srgbClr val="0E3449"/>
-                </a:solidFill>
-                <a:latin typeface="Inter SemiBold"/>
-                <a:ea typeface="Inter SemiBold"/>
-                <a:cs typeface="Inter SemiBold"/>
-                <a:sym typeface="Inter SemiBold"/>
-              </a:defRPr>
-            </a:lvl1pPr>
-          </a:lstStyle>
-          <a:p>
-            <a:r>
-              <a:rPr lang="fr-FR" dirty="0"/>
-              <a:t>Démonstration de l’application</a:t>
-            </a:r>
-            <a:endParaRPr dirty="0"/>
-          </a:p>
-        </p:txBody>
-      </p:sp>
-      <p:sp>
-        <p:nvSpPr>
-          <p:cNvPr id="146" name="Google Shape;69;p15">
-            <a:extLst>
-              <a:ext uri="{FF2B5EF4-FFF2-40B4-BE49-F238E27FC236}">
-                <a16:creationId xmlns:a16="http://schemas.microsoft.com/office/drawing/2014/main" id="{C10E6EDA-84D2-625F-B159-CB5967207CE7}"/>
-              </a:ext>
-            </a:extLst>
-          </p:cNvPr>
-          <p:cNvSpPr/>
-          <p:nvPr/>
-        </p:nvSpPr>
-        <p:spPr>
-          <a:xfrm>
-            <a:off x="10224" y="4892025"/>
-            <a:ext cx="9144001" cy="251400"/>
-          </a:xfrm>
-          <a:prstGeom prst="rect">
-            <a:avLst/>
-          </a:prstGeom>
-          <a:solidFill>
-            <a:srgbClr val="C3FFFC"/>
-          </a:solidFill>
-          <a:ln w="12700">
-            <a:miter lim="400000"/>
-          </a:ln>
-        </p:spPr>
-        <p:txBody>
-          <a:bodyPr lIns="0" tIns="0" rIns="0" bIns="0" anchor="ctr"/>
-          <a:lstStyle/>
-          <a:p>
-            <a:endParaRPr/>
-          </a:p>
-        </p:txBody>
-      </p:sp>
-      <p:pic>
-        <p:nvPicPr>
-          <p:cNvPr id="147" name="Google Shape;70;p15" descr="Google Shape;70;p15">
-            <a:extLst>
-              <a:ext uri="{FF2B5EF4-FFF2-40B4-BE49-F238E27FC236}">
-                <a16:creationId xmlns:a16="http://schemas.microsoft.com/office/drawing/2014/main" id="{79120C56-AD4F-0425-A531-8C5BC25CF8A8}"/>
-              </a:ext>
-            </a:extLst>
-          </p:cNvPr>
-          <p:cNvPicPr>
-            <a:picLocks noChangeAspect="1"/>
-          </p:cNvPicPr>
-          <p:nvPr/>
-        </p:nvPicPr>
-        <p:blipFill>
-          <a:blip r:embed="rId2"/>
-          <a:stretch>
-            <a:fillRect/>
-          </a:stretch>
-        </p:blipFill>
-        <p:spPr>
-          <a:xfrm>
-            <a:off x="463375" y="482852"/>
-            <a:ext cx="576901" cy="385906"/>
-          </a:xfrm>
-          <a:prstGeom prst="rect">
-            <a:avLst/>
-          </a:prstGeom>
-          <a:ln w="12700">
-            <a:miter lim="400000"/>
-          </a:ln>
-        </p:spPr>
-      </p:pic>
-      <p:sp>
-        <p:nvSpPr>
-          <p:cNvPr id="161" name="flab">
-            <a:extLst>
-              <a:ext uri="{FF2B5EF4-FFF2-40B4-BE49-F238E27FC236}">
-                <a16:creationId xmlns:a16="http://schemas.microsoft.com/office/drawing/2014/main" id="{3F25130B-BAE3-3E9B-B2DB-36CA32F61DC0}"/>
+                <a16:creationId xmlns:a16="http://schemas.microsoft.com/office/drawing/2014/main" id="{5F1AD63F-A918-04BA-0C0B-3427DF1712C5}"/>
               </a:ext>
             </a:extLst>
           </p:cNvPr>
@@ -10504,7 +9560,7 @@
         </p:nvSpPr>
         <p:spPr>
           <a:xfrm>
-            <a:off x="3439333" y="2546750"/>
+            <a:off x="5582002" y="655423"/>
             <a:ext cx="2265334" cy="300001"/>
           </a:xfrm>
           <a:prstGeom prst="rect">
@@ -10538,19 +9594,19 @@
           </a:lstStyle>
           <a:p>
             <a:r>
-              <a:rPr lang="fr-FR" sz="2400" dirty="0"/>
-              <a:t>Vidéo</a:t>
+              <a:rPr lang="fr-FR" sz="2400" dirty="0">
+                <a:hlinkClick r:id="rId8"/>
+              </a:rPr>
+              <a:t>Vidéo </a:t>
             </a:r>
-            <a:endParaRPr sz="2400" dirty="0"/>
+            <a:endParaRPr lang="fr-FR" sz="2400" dirty="0"/>
+          </a:p>
+          <a:p>
+            <a:endParaRPr lang="fr-FR" sz="2400" dirty="0"/>
           </a:p>
         </p:txBody>
       </p:sp>
     </p:spTree>
-    <p:extLst>
-      <p:ext uri="{BB962C8B-B14F-4D97-AF65-F5344CB8AC3E}">
-        <p14:creationId xmlns:p14="http://schemas.microsoft.com/office/powerpoint/2010/main" val="3835693099"/>
-      </p:ext>
-    </p:extLst>
   </p:cSld>
   <p:clrMapOvr>
     <a:masterClrMapping/>
@@ -10559,7 +9615,7 @@
 </p:sld>
 </file>
 
-<file path=ppt/slides/slide7.xml><?xml version="1.0" encoding="utf-8"?>
+<file path=ppt/slides/slide6.xml><?xml version="1.0" encoding="utf-8"?>
 <p:sld xmlns:a="http://schemas.openxmlformats.org/drawingml/2006/main" xmlns:r="http://schemas.openxmlformats.org/officeDocument/2006/relationships" xmlns:p="http://schemas.openxmlformats.org/presentationml/2006/main">
   <p:cSld>
     <p:spTree>
@@ -10706,10 +9762,10 @@
         </p:nvGrpSpPr>
         <p:grpSpPr>
           <a:xfrm>
-            <a:off x="817152" y="2657189"/>
-            <a:ext cx="5680323" cy="1343027"/>
-            <a:chOff x="0" y="0"/>
-            <a:chExt cx="5680321" cy="1343025"/>
+            <a:off x="817150" y="2657189"/>
+            <a:ext cx="5680327" cy="1343029"/>
+            <a:chOff x="-2" y="0"/>
+            <a:chExt cx="5680325" cy="1343027"/>
           </a:xfrm>
         </p:grpSpPr>
         <p:grpSp>
@@ -10720,10 +9776,10 @@
           </p:nvGrpSpPr>
           <p:grpSpPr>
             <a:xfrm>
-              <a:off x="-1" y="0"/>
-              <a:ext cx="5680323" cy="1343026"/>
-              <a:chOff x="0" y="0"/>
-              <a:chExt cx="5680321" cy="1343025"/>
+              <a:off x="-2" y="0"/>
+              <a:ext cx="5680325" cy="1343027"/>
+              <a:chOff x="-1" y="0"/>
+              <a:chExt cx="5680323" cy="1343026"/>
             </a:xfrm>
           </p:grpSpPr>
           <p:sp>
@@ -10786,7 +9842,7 @@
               <a:effectLst/>
               <a:extLst>
                 <a:ext uri="{C572A759-6A51-4108-AA02-DFA0A04FC94B}">
-                  <ma14:wrappingTextBoxFlag xmlns:ma14="http://schemas.microsoft.com/office/mac/drawingml/2011/main" xmlns:a14="http://schemas.microsoft.com/office/drawing/2010/main" xmlns:m="http://schemas.openxmlformats.org/officeDocument/2006/math" xmlns="" val="1"/>
+                  <ma14:wrappingTextBoxFlag xmlns="" xmlns:m="http://schemas.openxmlformats.org/officeDocument/2006/math" xmlns:a14="http://schemas.microsoft.com/office/drawing/2010/main" xmlns:ma14="http://schemas.microsoft.com/office/mac/drawingml/2011/main" val="1"/>
                 </a:ext>
               </a:extLst>
             </p:spPr>
@@ -10834,7 +9890,7 @@
             <a:effectLst/>
             <a:extLst>
               <a:ext uri="{C572A759-6A51-4108-AA02-DFA0A04FC94B}">
-                <ma14:wrappingTextBoxFlag xmlns:ma14="http://schemas.microsoft.com/office/mac/drawingml/2011/main" xmlns:a14="http://schemas.microsoft.com/office/drawing/2010/main" xmlns:m="http://schemas.openxmlformats.org/officeDocument/2006/math" xmlns="" val="1"/>
+                <ma14:wrappingTextBoxFlag xmlns="" xmlns:m="http://schemas.openxmlformats.org/officeDocument/2006/math" xmlns:a14="http://schemas.microsoft.com/office/drawing/2010/main" xmlns:ma14="http://schemas.microsoft.com/office/mac/drawingml/2011/main" val="1"/>
               </a:ext>
             </a:extLst>
           </p:spPr>
@@ -10868,10 +9924,10 @@
         </p:nvGrpSpPr>
         <p:grpSpPr>
           <a:xfrm>
-            <a:off x="817152" y="1284870"/>
-            <a:ext cx="5778382" cy="662463"/>
-            <a:chOff x="0" y="0"/>
-            <a:chExt cx="5778380" cy="662461"/>
+            <a:off x="817151" y="1284870"/>
+            <a:ext cx="5778384" cy="662464"/>
+            <a:chOff x="-1" y="0"/>
+            <a:chExt cx="5778382" cy="662462"/>
           </a:xfrm>
         </p:grpSpPr>
         <p:sp>
@@ -10934,7 +9990,7 @@
             <a:effectLst/>
             <a:extLst>
               <a:ext uri="{C572A759-6A51-4108-AA02-DFA0A04FC94B}">
-                <ma14:wrappingTextBoxFlag xmlns:ma14="http://schemas.microsoft.com/office/mac/drawingml/2011/main" xmlns:a14="http://schemas.microsoft.com/office/drawing/2010/main" xmlns:m="http://schemas.openxmlformats.org/officeDocument/2006/math" xmlns="" val="1"/>
+                <ma14:wrappingTextBoxFlag xmlns="" xmlns:m="http://schemas.openxmlformats.org/officeDocument/2006/math" xmlns:a14="http://schemas.microsoft.com/office/drawing/2010/main" xmlns:ma14="http://schemas.microsoft.com/office/mac/drawingml/2011/main" val="1"/>
               </a:ext>
             </a:extLst>
           </p:spPr>
@@ -10983,7 +10039,7 @@
 </p:sld>
 </file>
 
-<file path=ppt/slides/slide8.xml><?xml version="1.0" encoding="utf-8"?>
+<file path=ppt/slides/slide7.xml><?xml version="1.0" encoding="utf-8"?>
 <p:sld xmlns:a="http://schemas.openxmlformats.org/drawingml/2006/main" xmlns:r="http://schemas.openxmlformats.org/officeDocument/2006/relationships" xmlns:p="http://schemas.openxmlformats.org/presentationml/2006/main">
   <p:cSld>
     <p:spTree>
@@ -11149,9 +10205,9 @@
         <p:grpSpPr>
           <a:xfrm>
             <a:off x="340861" y="1191904"/>
-            <a:ext cx="2510118" cy="1476045"/>
+            <a:ext cx="2510119" cy="1476047"/>
             <a:chOff x="0" y="0"/>
-            <a:chExt cx="2510117" cy="1476045"/>
+            <a:chExt cx="2510118" cy="1476047"/>
           </a:xfrm>
         </p:grpSpPr>
         <p:sp>
@@ -11176,7 +10232,7 @@
             <a:effectLst/>
             <a:extLst>
               <a:ext uri="{C572A759-6A51-4108-AA02-DFA0A04FC94B}">
-                <ma14:wrappingTextBoxFlag xmlns:ma14="http://schemas.microsoft.com/office/mac/drawingml/2011/main" xmlns:a14="http://schemas.microsoft.com/office/drawing/2010/main" xmlns:m="http://schemas.openxmlformats.org/officeDocument/2006/math" xmlns="" val="1"/>
+                <ma14:wrappingTextBoxFlag xmlns="" xmlns:m="http://schemas.openxmlformats.org/officeDocument/2006/math" xmlns:a14="http://schemas.microsoft.com/office/drawing/2010/main" xmlns:ma14="http://schemas.microsoft.com/office/mac/drawingml/2011/main" val="1"/>
               </a:ext>
             </a:extLst>
           </p:spPr>
@@ -11213,9 +10269,9 @@
           <p:grpSpPr>
             <a:xfrm>
               <a:off x="0" y="379061"/>
-              <a:ext cx="2320745" cy="1096985"/>
+              <a:ext cx="2320746" cy="1096986"/>
               <a:chOff x="0" y="0"/>
-              <a:chExt cx="2320744" cy="1096983"/>
+              <a:chExt cx="2320745" cy="1096984"/>
             </a:xfrm>
           </p:grpSpPr>
           <p:sp>
@@ -11278,7 +10334,7 @@
               <a:effectLst/>
               <a:extLst>
                 <a:ext uri="{C572A759-6A51-4108-AA02-DFA0A04FC94B}">
-                  <ma14:wrappingTextBoxFlag xmlns:ma14="http://schemas.microsoft.com/office/mac/drawingml/2011/main" xmlns:a14="http://schemas.microsoft.com/office/drawing/2010/main" xmlns:m="http://schemas.openxmlformats.org/officeDocument/2006/math" xmlns="" val="1"/>
+                  <ma14:wrappingTextBoxFlag xmlns="" xmlns:m="http://schemas.openxmlformats.org/officeDocument/2006/math" xmlns:a14="http://schemas.microsoft.com/office/drawing/2010/main" xmlns:ma14="http://schemas.microsoft.com/office/mac/drawingml/2011/main" val="1"/>
                 </a:ext>
               </a:extLst>
             </p:spPr>
@@ -11328,7 +10384,7 @@
               <a:effectLst/>
               <a:extLst>
                 <a:ext uri="{C572A759-6A51-4108-AA02-DFA0A04FC94B}">
-                  <ma14:wrappingTextBoxFlag xmlns:ma14="http://schemas.microsoft.com/office/mac/drawingml/2011/main" xmlns:a14="http://schemas.microsoft.com/office/drawing/2010/main" xmlns:m="http://schemas.openxmlformats.org/officeDocument/2006/math" xmlns="" val="1"/>
+                  <ma14:wrappingTextBoxFlag xmlns="" xmlns:m="http://schemas.openxmlformats.org/officeDocument/2006/math" xmlns:a14="http://schemas.microsoft.com/office/drawing/2010/main" xmlns:ma14="http://schemas.microsoft.com/office/mac/drawingml/2011/main" val="1"/>
                 </a:ext>
               </a:extLst>
             </p:spPr>
@@ -11363,10 +10419,10 @@
         </p:nvGrpSpPr>
         <p:grpSpPr>
           <a:xfrm>
-            <a:off x="340861" y="3612991"/>
-            <a:ext cx="2540362" cy="1071563"/>
-            <a:chOff x="0" y="0"/>
-            <a:chExt cx="2540361" cy="1071562"/>
+            <a:off x="340861" y="3612990"/>
+            <a:ext cx="2540364" cy="1071566"/>
+            <a:chOff x="0" y="-1"/>
+            <a:chExt cx="2540363" cy="1071565"/>
           </a:xfrm>
         </p:grpSpPr>
         <p:grpSp>
@@ -11377,10 +10433,10 @@
           </p:nvGrpSpPr>
           <p:grpSpPr>
             <a:xfrm>
-              <a:off x="0" y="0"/>
-              <a:ext cx="2540362" cy="1071563"/>
-              <a:chOff x="0" y="0"/>
-              <a:chExt cx="2540361" cy="1071562"/>
+              <a:off x="0" y="-1"/>
+              <a:ext cx="2540363" cy="1071565"/>
+              <a:chOff x="0" y="-1"/>
+              <a:chExt cx="2540362" cy="1071564"/>
             </a:xfrm>
           </p:grpSpPr>
           <p:sp>
@@ -11443,7 +10499,7 @@
               <a:effectLst/>
               <a:extLst>
                 <a:ext uri="{C572A759-6A51-4108-AA02-DFA0A04FC94B}">
-                  <ma14:wrappingTextBoxFlag xmlns:ma14="http://schemas.microsoft.com/office/mac/drawingml/2011/main" xmlns:a14="http://schemas.microsoft.com/office/drawing/2010/main" xmlns:m="http://schemas.openxmlformats.org/officeDocument/2006/math" xmlns="" val="1"/>
+                  <ma14:wrappingTextBoxFlag xmlns="" xmlns:m="http://schemas.openxmlformats.org/officeDocument/2006/math" xmlns:a14="http://schemas.microsoft.com/office/drawing/2010/main" xmlns:ma14="http://schemas.microsoft.com/office/mac/drawingml/2011/main" val="1"/>
                 </a:ext>
               </a:extLst>
             </p:spPr>
@@ -11494,7 +10550,7 @@
             <a:effectLst/>
             <a:extLst>
               <a:ext uri="{C572A759-6A51-4108-AA02-DFA0A04FC94B}">
-                <ma14:wrappingTextBoxFlag xmlns:ma14="http://schemas.microsoft.com/office/mac/drawingml/2011/main" xmlns:a14="http://schemas.microsoft.com/office/drawing/2010/main" xmlns:m="http://schemas.openxmlformats.org/officeDocument/2006/math" xmlns="" val="1"/>
+                <ma14:wrappingTextBoxFlag xmlns="" xmlns:m="http://schemas.openxmlformats.org/officeDocument/2006/math" xmlns:a14="http://schemas.microsoft.com/office/drawing/2010/main" xmlns:ma14="http://schemas.microsoft.com/office/mac/drawingml/2011/main" val="1"/>
               </a:ext>
             </a:extLst>
           </p:spPr>
@@ -11529,9 +10585,9 @@
         <p:grpSpPr>
           <a:xfrm>
             <a:off x="3010220" y="3001971"/>
-            <a:ext cx="866911" cy="418794"/>
+            <a:ext cx="866912" cy="418795"/>
             <a:chOff x="0" y="0"/>
-            <a:chExt cx="866909" cy="418792"/>
+            <a:chExt cx="866910" cy="418793"/>
           </a:xfrm>
         </p:grpSpPr>
         <p:sp>
@@ -11594,7 +10650,7 @@
             <a:effectLst/>
             <a:extLst>
               <a:ext uri="{C572A759-6A51-4108-AA02-DFA0A04FC94B}">
-                <ma14:wrappingTextBoxFlag xmlns:ma14="http://schemas.microsoft.com/office/mac/drawingml/2011/main" xmlns:a14="http://schemas.microsoft.com/office/drawing/2010/main" xmlns:m="http://schemas.openxmlformats.org/officeDocument/2006/math" xmlns="" val="1"/>
+                <ma14:wrappingTextBoxFlag xmlns="" xmlns:m="http://schemas.openxmlformats.org/officeDocument/2006/math" xmlns:a14="http://schemas.microsoft.com/office/drawing/2010/main" xmlns:ma14="http://schemas.microsoft.com/office/mac/drawingml/2011/main" val="1"/>
               </a:ext>
             </a:extLst>
           </p:spPr>
@@ -11632,9 +10688,9 @@
         <p:grpSpPr>
           <a:xfrm>
             <a:off x="3776910" y="1101850"/>
-            <a:ext cx="2894650" cy="1096274"/>
+            <a:ext cx="2894651" cy="1096275"/>
             <a:chOff x="0" y="0"/>
-            <a:chExt cx="2894649" cy="1096272"/>
+            <a:chExt cx="2894650" cy="1096273"/>
           </a:xfrm>
         </p:grpSpPr>
         <p:sp>
@@ -11697,7 +10753,7 @@
             <a:effectLst/>
             <a:extLst>
               <a:ext uri="{C572A759-6A51-4108-AA02-DFA0A04FC94B}">
-                <ma14:wrappingTextBoxFlag xmlns:ma14="http://schemas.microsoft.com/office/mac/drawingml/2011/main" xmlns:a14="http://schemas.microsoft.com/office/drawing/2010/main" xmlns:m="http://schemas.openxmlformats.org/officeDocument/2006/math" xmlns="" val="1"/>
+                <ma14:wrappingTextBoxFlag xmlns="" xmlns:m="http://schemas.openxmlformats.org/officeDocument/2006/math" xmlns:a14="http://schemas.microsoft.com/office/drawing/2010/main" xmlns:ma14="http://schemas.microsoft.com/office/mac/drawingml/2011/main" val="1"/>
               </a:ext>
             </a:extLst>
           </p:spPr>
@@ -11743,7 +10799,7 @@
             <a:effectLst/>
             <a:extLst>
               <a:ext uri="{C572A759-6A51-4108-AA02-DFA0A04FC94B}">
-                <ma14:wrappingTextBoxFlag xmlns:ma14="http://schemas.microsoft.com/office/mac/drawingml/2011/main" xmlns:a14="http://schemas.microsoft.com/office/drawing/2010/main" xmlns:m="http://schemas.openxmlformats.org/officeDocument/2006/math" xmlns="" val="1"/>
+                <ma14:wrappingTextBoxFlag xmlns="" xmlns:m="http://schemas.openxmlformats.org/officeDocument/2006/math" xmlns:a14="http://schemas.microsoft.com/office/drawing/2010/main" xmlns:ma14="http://schemas.microsoft.com/office/mac/drawingml/2011/main" val="1"/>
               </a:ext>
             </a:extLst>
           </p:spPr>
@@ -11806,10 +10862,10 @@
         </p:nvGrpSpPr>
         <p:grpSpPr>
           <a:xfrm>
-            <a:off x="7019905" y="2015012"/>
-            <a:ext cx="1931672" cy="1477240"/>
-            <a:chOff x="0" y="0"/>
-            <a:chExt cx="1931671" cy="1477239"/>
+            <a:off x="7019904" y="2015012"/>
+            <a:ext cx="1931676" cy="1477241"/>
+            <a:chOff x="-1" y="0"/>
+            <a:chExt cx="1931675" cy="1477241"/>
           </a:xfrm>
         </p:grpSpPr>
         <p:sp>
@@ -11834,7 +10890,7 @@
             <a:effectLst/>
             <a:extLst>
               <a:ext uri="{C572A759-6A51-4108-AA02-DFA0A04FC94B}">
-                <ma14:wrappingTextBoxFlag xmlns:ma14="http://schemas.microsoft.com/office/mac/drawingml/2011/main" xmlns:a14="http://schemas.microsoft.com/office/drawing/2010/main" xmlns:m="http://schemas.openxmlformats.org/officeDocument/2006/math" xmlns="" val="1"/>
+                <ma14:wrappingTextBoxFlag xmlns="" xmlns:m="http://schemas.openxmlformats.org/officeDocument/2006/math" xmlns:a14="http://schemas.microsoft.com/office/drawing/2010/main" xmlns:ma14="http://schemas.microsoft.com/office/mac/drawingml/2011/main" val="1"/>
               </a:ext>
             </a:extLst>
           </p:spPr>
@@ -11870,10 +10926,10 @@
           </p:nvGrpSpPr>
           <p:grpSpPr>
             <a:xfrm>
-              <a:off x="0" y="314798"/>
-              <a:ext cx="1931672" cy="1162442"/>
-              <a:chOff x="0" y="0"/>
-              <a:chExt cx="1931671" cy="1162440"/>
+              <a:off x="-1" y="314798"/>
+              <a:ext cx="1931675" cy="1162443"/>
+              <a:chOff x="-1" y="0"/>
+              <a:chExt cx="1931674" cy="1162441"/>
             </a:xfrm>
           </p:grpSpPr>
           <p:grpSp>
@@ -11884,10 +10940,10 @@
             </p:nvGrpSpPr>
             <p:grpSpPr>
               <a:xfrm>
-                <a:off x="0" y="0"/>
-                <a:ext cx="1931672" cy="1071563"/>
-                <a:chOff x="0" y="0"/>
-                <a:chExt cx="1931671" cy="1071562"/>
+                <a:off x="-1" y="0"/>
+                <a:ext cx="1931674" cy="1071564"/>
+                <a:chOff x="-1" y="0"/>
+                <a:chExt cx="1931673" cy="1071563"/>
               </a:xfrm>
             </p:grpSpPr>
             <p:sp>
@@ -11950,7 +11006,7 @@
                 <a:effectLst/>
                 <a:extLst>
                   <a:ext uri="{C572A759-6A51-4108-AA02-DFA0A04FC94B}">
-                    <ma14:wrappingTextBoxFlag xmlns:ma14="http://schemas.microsoft.com/office/mac/drawingml/2011/main" xmlns:a14="http://schemas.microsoft.com/office/drawing/2010/main" xmlns:m="http://schemas.openxmlformats.org/officeDocument/2006/math" xmlns="" val="1"/>
+                    <ma14:wrappingTextBoxFlag xmlns="" xmlns:m="http://schemas.openxmlformats.org/officeDocument/2006/math" xmlns:a14="http://schemas.microsoft.com/office/drawing/2010/main" xmlns:ma14="http://schemas.microsoft.com/office/mac/drawingml/2011/main" val="1"/>
                   </a:ext>
                 </a:extLst>
               </p:spPr>
@@ -12001,7 +11057,7 @@
               <a:effectLst/>
               <a:extLst>
                 <a:ext uri="{C572A759-6A51-4108-AA02-DFA0A04FC94B}">
-                  <ma14:wrappingTextBoxFlag xmlns:ma14="http://schemas.microsoft.com/office/mac/drawingml/2011/main" xmlns:a14="http://schemas.microsoft.com/office/drawing/2010/main" xmlns:m="http://schemas.openxmlformats.org/officeDocument/2006/math" xmlns="" val="1"/>
+                  <ma14:wrappingTextBoxFlag xmlns="" xmlns:m="http://schemas.openxmlformats.org/officeDocument/2006/math" xmlns:a14="http://schemas.microsoft.com/office/drawing/2010/main" xmlns:ma14="http://schemas.microsoft.com/office/mac/drawingml/2011/main" val="1"/>
                 </a:ext>
               </a:extLst>
             </p:spPr>
@@ -12253,7 +11309,7 @@
 </p:sld>
 </file>
 
-<file path=ppt/slides/slide9.xml><?xml version="1.0" encoding="utf-8"?>
+<file path=ppt/slides/slide8.xml><?xml version="1.0" encoding="utf-8"?>
 <p:sld xmlns:a="http://schemas.openxmlformats.org/drawingml/2006/main" xmlns:r="http://schemas.openxmlformats.org/officeDocument/2006/relationships" xmlns:p="http://schemas.openxmlformats.org/presentationml/2006/main">
   <p:cSld>
     <p:spTree>
@@ -12419,7 +11475,7 @@
           </a:ln>
           <a:extLst>
             <a:ext uri="{C572A759-6A51-4108-AA02-DFA0A04FC94B}">
-              <ma14:wrappingTextBoxFlag xmlns:ma14="http://schemas.microsoft.com/office/mac/drawingml/2011/main" xmlns:a14="http://schemas.microsoft.com/office/drawing/2010/main" xmlns:m="http://schemas.openxmlformats.org/officeDocument/2006/math" xmlns="" val="1"/>
+              <ma14:wrappingTextBoxFlag xmlns="" xmlns:m="http://schemas.openxmlformats.org/officeDocument/2006/math" xmlns:a14="http://schemas.microsoft.com/office/drawing/2010/main" xmlns:ma14="http://schemas.microsoft.com/office/mac/drawingml/2011/main" val="1"/>
             </a:ext>
           </a:extLst>
         </p:spPr>
@@ -12455,10 +11511,10 @@
         </p:nvGrpSpPr>
         <p:grpSpPr>
           <a:xfrm>
-            <a:off x="751824" y="1784186"/>
-            <a:ext cx="1928815" cy="1985964"/>
-            <a:chOff x="0" y="0"/>
-            <a:chExt cx="1928813" cy="1985963"/>
+            <a:off x="751822" y="1784184"/>
+            <a:ext cx="1928819" cy="1985968"/>
+            <a:chOff x="-2" y="-2"/>
+            <a:chExt cx="1928817" cy="1985967"/>
           </a:xfrm>
         </p:grpSpPr>
         <p:grpSp>
@@ -12469,10 +11525,10 @@
           </p:nvGrpSpPr>
           <p:grpSpPr>
             <a:xfrm>
-              <a:off x="-1" y="-1"/>
-              <a:ext cx="1928815" cy="1985965"/>
-              <a:chOff x="0" y="0"/>
-              <a:chExt cx="1928813" cy="1985963"/>
+              <a:off x="-2" y="-2"/>
+              <a:ext cx="1928817" cy="1985967"/>
+              <a:chOff x="-1" y="-1"/>
+              <a:chExt cx="1928815" cy="1985965"/>
             </a:xfrm>
           </p:grpSpPr>
           <p:sp>
@@ -12535,7 +11591,7 @@
               <a:effectLst/>
               <a:extLst>
                 <a:ext uri="{C572A759-6A51-4108-AA02-DFA0A04FC94B}">
-                  <ma14:wrappingTextBoxFlag xmlns:ma14="http://schemas.microsoft.com/office/mac/drawingml/2011/main" xmlns:a14="http://schemas.microsoft.com/office/drawing/2010/main" xmlns:m="http://schemas.openxmlformats.org/officeDocument/2006/math" xmlns="" val="1"/>
+                  <ma14:wrappingTextBoxFlag xmlns="" xmlns:m="http://schemas.openxmlformats.org/officeDocument/2006/math" xmlns:a14="http://schemas.microsoft.com/office/drawing/2010/main" xmlns:ma14="http://schemas.microsoft.com/office/mac/drawingml/2011/main" val="1"/>
                 </a:ext>
               </a:extLst>
             </p:spPr>
@@ -12578,7 +11634,7 @@
             <a:effectLst/>
             <a:extLst>
               <a:ext uri="{C572A759-6A51-4108-AA02-DFA0A04FC94B}">
-                <ma14:wrappingTextBoxFlag xmlns:ma14="http://schemas.microsoft.com/office/mac/drawingml/2011/main" xmlns:a14="http://schemas.microsoft.com/office/drawing/2010/main" xmlns:m="http://schemas.openxmlformats.org/officeDocument/2006/math" xmlns="" val="1"/>
+                <ma14:wrappingTextBoxFlag xmlns="" xmlns:m="http://schemas.openxmlformats.org/officeDocument/2006/math" xmlns:a14="http://schemas.microsoft.com/office/drawing/2010/main" xmlns:ma14="http://schemas.microsoft.com/office/mac/drawingml/2011/main" val="1"/>
               </a:ext>
             </a:extLst>
           </p:spPr>
@@ -12612,10 +11668,10 @@
         </p:nvGrpSpPr>
         <p:grpSpPr>
           <a:xfrm>
-            <a:off x="3135526" y="1798532"/>
-            <a:ext cx="1928814" cy="1985964"/>
-            <a:chOff x="0" y="0"/>
-            <a:chExt cx="1928813" cy="1985963"/>
+            <a:off x="3135524" y="1798530"/>
+            <a:ext cx="1928818" cy="1985968"/>
+            <a:chOff x="-2" y="-2"/>
+            <a:chExt cx="1928817" cy="1985967"/>
           </a:xfrm>
         </p:grpSpPr>
         <p:grpSp>
@@ -12626,10 +11682,10 @@
           </p:nvGrpSpPr>
           <p:grpSpPr>
             <a:xfrm>
-              <a:off x="-1" y="-1"/>
-              <a:ext cx="1928815" cy="1985965"/>
-              <a:chOff x="0" y="0"/>
-              <a:chExt cx="1928813" cy="1985963"/>
+              <a:off x="-2" y="-2"/>
+              <a:ext cx="1928817" cy="1985967"/>
+              <a:chOff x="-1" y="-1"/>
+              <a:chExt cx="1928815" cy="1985965"/>
             </a:xfrm>
           </p:grpSpPr>
           <p:sp>
@@ -12692,7 +11748,7 @@
               <a:effectLst/>
               <a:extLst>
                 <a:ext uri="{C572A759-6A51-4108-AA02-DFA0A04FC94B}">
-                  <ma14:wrappingTextBoxFlag xmlns:ma14="http://schemas.microsoft.com/office/mac/drawingml/2011/main" xmlns:a14="http://schemas.microsoft.com/office/drawing/2010/main" xmlns:m="http://schemas.openxmlformats.org/officeDocument/2006/math" xmlns="" val="1"/>
+                  <ma14:wrappingTextBoxFlag xmlns="" xmlns:m="http://schemas.openxmlformats.org/officeDocument/2006/math" xmlns:a14="http://schemas.microsoft.com/office/drawing/2010/main" xmlns:ma14="http://schemas.microsoft.com/office/mac/drawingml/2011/main" val="1"/>
                 </a:ext>
               </a:extLst>
             </p:spPr>
@@ -12735,7 +11791,7 @@
             <a:effectLst/>
             <a:extLst>
               <a:ext uri="{C572A759-6A51-4108-AA02-DFA0A04FC94B}">
-                <ma14:wrappingTextBoxFlag xmlns:ma14="http://schemas.microsoft.com/office/mac/drawingml/2011/main" xmlns:a14="http://schemas.microsoft.com/office/drawing/2010/main" xmlns:m="http://schemas.openxmlformats.org/officeDocument/2006/math" xmlns="" val="1"/>
+                <ma14:wrappingTextBoxFlag xmlns="" xmlns:m="http://schemas.openxmlformats.org/officeDocument/2006/math" xmlns:a14="http://schemas.microsoft.com/office/drawing/2010/main" xmlns:ma14="http://schemas.microsoft.com/office/mac/drawingml/2011/main" val="1"/>
               </a:ext>
             </a:extLst>
           </p:spPr>
@@ -12769,10 +11825,10 @@
         </p:nvGrpSpPr>
         <p:grpSpPr>
           <a:xfrm>
-            <a:off x="5915159" y="1784186"/>
-            <a:ext cx="1928814" cy="1985964"/>
-            <a:chOff x="0" y="0"/>
-            <a:chExt cx="1928813" cy="1985963"/>
+            <a:off x="5915157" y="1784184"/>
+            <a:ext cx="1928818" cy="1985968"/>
+            <a:chOff x="-2" y="-2"/>
+            <a:chExt cx="1928817" cy="1985967"/>
           </a:xfrm>
         </p:grpSpPr>
         <p:grpSp>
@@ -12783,10 +11839,10 @@
           </p:nvGrpSpPr>
           <p:grpSpPr>
             <a:xfrm>
-              <a:off x="-1" y="-1"/>
-              <a:ext cx="1928815" cy="1985965"/>
-              <a:chOff x="0" y="0"/>
-              <a:chExt cx="1928813" cy="1985963"/>
+              <a:off x="-2" y="-2"/>
+              <a:ext cx="1928817" cy="1985967"/>
+              <a:chOff x="-1" y="-1"/>
+              <a:chExt cx="1928815" cy="1985965"/>
             </a:xfrm>
           </p:grpSpPr>
           <p:sp>
@@ -12849,7 +11905,7 @@
               <a:effectLst/>
               <a:extLst>
                 <a:ext uri="{C572A759-6A51-4108-AA02-DFA0A04FC94B}">
-                  <ma14:wrappingTextBoxFlag xmlns:ma14="http://schemas.microsoft.com/office/mac/drawingml/2011/main" xmlns:a14="http://schemas.microsoft.com/office/drawing/2010/main" xmlns:m="http://schemas.openxmlformats.org/officeDocument/2006/math" xmlns="" val="1"/>
+                  <ma14:wrappingTextBoxFlag xmlns="" xmlns:m="http://schemas.openxmlformats.org/officeDocument/2006/math" xmlns:a14="http://schemas.microsoft.com/office/drawing/2010/main" xmlns:ma14="http://schemas.microsoft.com/office/mac/drawingml/2011/main" val="1"/>
                 </a:ext>
               </a:extLst>
             </p:spPr>
@@ -12892,7 +11948,7 @@
             <a:effectLst/>
             <a:extLst>
               <a:ext uri="{C572A759-6A51-4108-AA02-DFA0A04FC94B}">
-                <ma14:wrappingTextBoxFlag xmlns:ma14="http://schemas.microsoft.com/office/mac/drawingml/2011/main" xmlns:a14="http://schemas.microsoft.com/office/drawing/2010/main" xmlns:m="http://schemas.openxmlformats.org/officeDocument/2006/math" xmlns="" val="1"/>
+                <ma14:wrappingTextBoxFlag xmlns="" xmlns:m="http://schemas.openxmlformats.org/officeDocument/2006/math" xmlns:a14="http://schemas.microsoft.com/office/drawing/2010/main" xmlns:ma14="http://schemas.microsoft.com/office/mac/drawingml/2011/main" val="1"/>
               </a:ext>
             </a:extLst>
           </p:spPr>
@@ -12937,7 +11993,7 @@
           </a:ln>
           <a:extLst>
             <a:ext uri="{C572A759-6A51-4108-AA02-DFA0A04FC94B}">
-              <ma14:wrappingTextBoxFlag xmlns:ma14="http://schemas.microsoft.com/office/mac/drawingml/2011/main" xmlns:a14="http://schemas.microsoft.com/office/drawing/2010/main" xmlns:m="http://schemas.openxmlformats.org/officeDocument/2006/math" xmlns="" val="1"/>
+              <ma14:wrappingTextBoxFlag xmlns="" xmlns:m="http://schemas.openxmlformats.org/officeDocument/2006/math" xmlns:a14="http://schemas.microsoft.com/office/drawing/2010/main" xmlns:ma14="http://schemas.microsoft.com/office/mac/drawingml/2011/main" val="1"/>
             </a:ext>
           </a:extLst>
         </p:spPr>
@@ -12981,7 +12037,7 @@
           </a:ln>
           <a:extLst>
             <a:ext uri="{C572A759-6A51-4108-AA02-DFA0A04FC94B}">
-              <ma14:wrappingTextBoxFlag xmlns:ma14="http://schemas.microsoft.com/office/mac/drawingml/2011/main" xmlns:a14="http://schemas.microsoft.com/office/drawing/2010/main" xmlns:m="http://schemas.openxmlformats.org/officeDocument/2006/math" xmlns="" val="1"/>
+              <ma14:wrappingTextBoxFlag xmlns="" xmlns:m="http://schemas.openxmlformats.org/officeDocument/2006/math" xmlns:a14="http://schemas.microsoft.com/office/drawing/2010/main" xmlns:ma14="http://schemas.microsoft.com/office/mac/drawingml/2011/main" val="1"/>
             </a:ext>
           </a:extLst>
         </p:spPr>
@@ -13025,7 +12081,7 @@
           </a:ln>
           <a:extLst>
             <a:ext uri="{C572A759-6A51-4108-AA02-DFA0A04FC94B}">
-              <ma14:wrappingTextBoxFlag xmlns:ma14="http://schemas.microsoft.com/office/mac/drawingml/2011/main" xmlns:a14="http://schemas.microsoft.com/office/drawing/2010/main" xmlns:m="http://schemas.openxmlformats.org/officeDocument/2006/math" xmlns="" val="1"/>
+              <ma14:wrappingTextBoxFlag xmlns="" xmlns:m="http://schemas.openxmlformats.org/officeDocument/2006/math" xmlns:a14="http://schemas.microsoft.com/office/drawing/2010/main" xmlns:ma14="http://schemas.microsoft.com/office/mac/drawingml/2011/main" val="1"/>
             </a:ext>
           </a:extLst>
         </p:spPr>
@@ -13049,6 +12105,813 @@
           </a:p>
         </p:txBody>
       </p:sp>
+    </p:spTree>
+  </p:cSld>
+  <p:clrMapOvr>
+    <a:masterClrMapping/>
+  </p:clrMapOvr>
+  <p:transition spd="med"/>
+</p:sld>
+</file>
+
+<file path=ppt/slides/slide9.xml><?xml version="1.0" encoding="utf-8"?>
+<p:sld xmlns:a="http://schemas.openxmlformats.org/drawingml/2006/main" xmlns:r="http://schemas.openxmlformats.org/officeDocument/2006/relationships" xmlns:p="http://schemas.openxmlformats.org/presentationml/2006/main">
+  <p:cSld>
+    <p:spTree>
+      <p:nvGrpSpPr>
+        <p:cNvPr id="1" name=""/>
+        <p:cNvGrpSpPr/>
+        <p:nvPr/>
+      </p:nvGrpSpPr>
+      <p:grpSpPr>
+        <a:xfrm>
+          <a:off x="0" y="0"/>
+          <a:ext cx="0" cy="0"/>
+          <a:chOff x="0" y="0"/>
+          <a:chExt cx="0" cy="0"/>
+        </a:xfrm>
+      </p:grpSpPr>
+      <p:pic>
+        <p:nvPicPr>
+          <p:cNvPr id="266" name="Fond FC Barcelone" descr="Fond FC Barcelone"/>
+          <p:cNvPicPr>
+            <a:picLocks noChangeAspect="1"/>
+          </p:cNvPicPr>
+          <p:nvPr/>
+        </p:nvPicPr>
+        <p:blipFill>
+          <a:blip r:embed="rId2"/>
+          <a:srcRect t="7813" b="7812"/>
+          <a:stretch>
+            <a:fillRect/>
+          </a:stretch>
+        </p:blipFill>
+        <p:spPr>
+          <a:xfrm>
+            <a:off x="0" y="-1"/>
+            <a:ext cx="9144000" cy="5143502"/>
+          </a:xfrm>
+          <a:prstGeom prst="rect">
+            <a:avLst/>
+          </a:prstGeom>
+          <a:ln w="12700">
+            <a:miter lim="400000"/>
+          </a:ln>
+        </p:spPr>
+      </p:pic>
+      <p:sp>
+        <p:nvSpPr>
+          <p:cNvPr id="267" name="Google Shape;75;p16"/>
+          <p:cNvSpPr txBox="1">
+            <a:spLocks noGrp="1"/>
+          </p:cNvSpPr>
+          <p:nvPr>
+            <p:ph type="title"/>
+          </p:nvPr>
+        </p:nvSpPr>
+        <p:spPr>
+          <a:xfrm>
+            <a:off x="1192664" y="403309"/>
+            <a:ext cx="5315101" cy="533101"/>
+          </a:xfrm>
+          <a:prstGeom prst="rect">
+            <a:avLst/>
+          </a:prstGeom>
+        </p:spPr>
+        <p:txBody>
+          <a:bodyPr/>
+          <a:lstStyle>
+            <a:lvl1pPr defTabSz="822959">
+              <a:defRPr sz="2250">
+                <a:solidFill>
+                  <a:srgbClr val="0E3449"/>
+                </a:solidFill>
+                <a:latin typeface="Inter SemiBold"/>
+                <a:ea typeface="Inter SemiBold"/>
+                <a:cs typeface="Inter SemiBold"/>
+                <a:sym typeface="Inter SemiBold"/>
+              </a:defRPr>
+            </a:lvl1pPr>
+          </a:lstStyle>
+          <a:p>
+            <a:r>
+              <a:t>Architecture - Entrainement</a:t>
+            </a:r>
+          </a:p>
+        </p:txBody>
+      </p:sp>
+      <p:pic>
+        <p:nvPicPr>
+          <p:cNvPr id="268" name="Google Shape;76;p16" descr="Google Shape;76;p16"/>
+          <p:cNvPicPr>
+            <a:picLocks noChangeAspect="1"/>
+          </p:cNvPicPr>
+          <p:nvPr/>
+        </p:nvPicPr>
+        <p:blipFill>
+          <a:blip r:embed="rId3"/>
+          <a:stretch>
+            <a:fillRect/>
+          </a:stretch>
+        </p:blipFill>
+        <p:spPr>
+          <a:xfrm>
+            <a:off x="463375" y="482852"/>
+            <a:ext cx="576901" cy="385905"/>
+          </a:xfrm>
+          <a:prstGeom prst="rect">
+            <a:avLst/>
+          </a:prstGeom>
+          <a:ln w="12700">
+            <a:miter lim="400000"/>
+          </a:ln>
+        </p:spPr>
+      </p:pic>
+      <p:sp>
+        <p:nvSpPr>
+          <p:cNvPr id="269" name="Google Shape;77;p16"/>
+          <p:cNvSpPr/>
+          <p:nvPr/>
+        </p:nvSpPr>
+        <p:spPr>
+          <a:xfrm>
+            <a:off x="10224" y="4892025"/>
+            <a:ext cx="9144001" cy="251400"/>
+          </a:xfrm>
+          <a:prstGeom prst="rect">
+            <a:avLst/>
+          </a:prstGeom>
+          <a:solidFill>
+            <a:srgbClr val="C3FFFC"/>
+          </a:solidFill>
+          <a:ln w="12700">
+            <a:miter lim="400000"/>
+          </a:ln>
+        </p:spPr>
+        <p:txBody>
+          <a:bodyPr lIns="45719" rIns="45719" anchor="ctr"/>
+          <a:lstStyle/>
+          <a:p>
+            <a:endParaRPr/>
+          </a:p>
+        </p:txBody>
+      </p:sp>
+      <p:grpSp>
+        <p:nvGrpSpPr>
+          <p:cNvPr id="272" name="Groupe 27"/>
+          <p:cNvGrpSpPr/>
+          <p:nvPr/>
+        </p:nvGrpSpPr>
+        <p:grpSpPr>
+          <a:xfrm>
+            <a:off x="7096703" y="1678903"/>
+            <a:ext cx="1143100" cy="1615649"/>
+            <a:chOff x="0" y="0"/>
+            <a:chExt cx="1143099" cy="1615648"/>
+          </a:xfrm>
+        </p:grpSpPr>
+        <p:pic>
+          <p:nvPicPr>
+            <p:cNvPr id="270" name="Image 7" descr="Image 7"/>
+            <p:cNvPicPr>
+              <a:picLocks noChangeAspect="1"/>
+            </p:cNvPicPr>
+            <p:nvPr/>
+          </p:nvPicPr>
+          <p:blipFill>
+            <a:blip r:embed="rId4"/>
+            <a:stretch>
+              <a:fillRect/>
+            </a:stretch>
+          </p:blipFill>
+          <p:spPr>
+            <a:xfrm>
+              <a:off x="0" y="396341"/>
+              <a:ext cx="1143100" cy="1219307"/>
+            </a:xfrm>
+            <a:prstGeom prst="rect">
+              <a:avLst/>
+            </a:prstGeom>
+            <a:ln w="12700" cap="flat">
+              <a:noFill/>
+              <a:miter lim="400000"/>
+            </a:ln>
+            <a:effectLst/>
+          </p:spPr>
+        </p:pic>
+        <p:pic>
+          <p:nvPicPr>
+            <p:cNvPr id="271" name="Image 13" descr="Image 13"/>
+            <p:cNvPicPr>
+              <a:picLocks noChangeAspect="1"/>
+            </p:cNvPicPr>
+            <p:nvPr/>
+          </p:nvPicPr>
+          <p:blipFill>
+            <a:blip r:embed="rId5"/>
+            <a:stretch>
+              <a:fillRect/>
+            </a:stretch>
+          </p:blipFill>
+          <p:spPr>
+            <a:xfrm>
+              <a:off x="220147" y="-1"/>
+              <a:ext cx="844692" cy="530697"/>
+            </a:xfrm>
+            <a:prstGeom prst="rect">
+              <a:avLst/>
+            </a:prstGeom>
+            <a:ln w="12700" cap="flat">
+              <a:noFill/>
+              <a:miter lim="400000"/>
+            </a:ln>
+            <a:effectLst/>
+          </p:spPr>
+        </p:pic>
+      </p:grpSp>
+      <p:grpSp>
+        <p:nvGrpSpPr>
+          <p:cNvPr id="276" name="Groupe 17"/>
+          <p:cNvGrpSpPr/>
+          <p:nvPr/>
+        </p:nvGrpSpPr>
+        <p:grpSpPr>
+          <a:xfrm>
+            <a:off x="2546643" y="1488950"/>
+            <a:ext cx="2268736" cy="2356463"/>
+            <a:chOff x="0" y="0"/>
+            <a:chExt cx="2268734" cy="2356463"/>
+          </a:xfrm>
+        </p:grpSpPr>
+        <p:pic>
+          <p:nvPicPr>
+            <p:cNvPr id="273" name="Image 2" descr="Image 2"/>
+            <p:cNvPicPr>
+              <a:picLocks noChangeAspect="1"/>
+            </p:cNvPicPr>
+            <p:nvPr/>
+          </p:nvPicPr>
+          <p:blipFill>
+            <a:blip r:embed="rId6"/>
+            <a:stretch>
+              <a:fillRect/>
+            </a:stretch>
+          </p:blipFill>
+          <p:spPr>
+            <a:xfrm>
+              <a:off x="143865" y="837871"/>
+              <a:ext cx="1196483" cy="577613"/>
+            </a:xfrm>
+            <a:prstGeom prst="rect">
+              <a:avLst/>
+            </a:prstGeom>
+            <a:ln w="12700" cap="flat">
+              <a:noFill/>
+              <a:miter lim="400000"/>
+            </a:ln>
+            <a:effectLst/>
+          </p:spPr>
+        </p:pic>
+        <p:pic>
+          <p:nvPicPr>
+            <p:cNvPr id="274" name="Image 15" descr="Image 15"/>
+            <p:cNvPicPr>
+              <a:picLocks noChangeAspect="1"/>
+            </p:cNvPicPr>
+            <p:nvPr/>
+          </p:nvPicPr>
+          <p:blipFill>
+            <a:blip r:embed="rId7"/>
+            <a:stretch>
+              <a:fillRect/>
+            </a:stretch>
+          </p:blipFill>
+          <p:spPr>
+            <a:xfrm>
+              <a:off x="392206" y="0"/>
+              <a:ext cx="699801" cy="627208"/>
+            </a:xfrm>
+            <a:prstGeom prst="rect">
+              <a:avLst/>
+            </a:prstGeom>
+            <a:ln w="12700" cap="flat">
+              <a:noFill/>
+              <a:miter lim="400000"/>
+            </a:ln>
+            <a:effectLst/>
+          </p:spPr>
+        </p:pic>
+        <p:sp>
+          <p:nvSpPr>
+            <p:cNvPr id="275" name="ZoneTexte 16"/>
+            <p:cNvSpPr txBox="1"/>
+            <p:nvPr/>
+          </p:nvSpPr>
+          <p:spPr>
+            <a:xfrm>
+              <a:off x="0" y="1617322"/>
+              <a:ext cx="2268734" cy="739141"/>
+            </a:xfrm>
+            <a:prstGeom prst="rect">
+              <a:avLst/>
+            </a:prstGeom>
+            <a:noFill/>
+            <a:ln w="12700" cap="flat">
+              <a:noFill/>
+              <a:miter lim="400000"/>
+            </a:ln>
+            <a:effectLst/>
+            <a:extLst>
+              <a:ext uri="{C572A759-6A51-4108-AA02-DFA0A04FC94B}">
+                <ma14:wrappingTextBoxFlag xmlns="" xmlns:m="http://schemas.openxmlformats.org/officeDocument/2006/math" xmlns:a14="http://schemas.microsoft.com/office/drawing/2010/main" xmlns:ma14="http://schemas.microsoft.com/office/mac/drawingml/2011/main" val="1"/>
+              </a:ext>
+            </a:extLst>
+          </p:spPr>
+          <p:txBody>
+            <a:bodyPr wrap="none" lIns="45719" tIns="45719" rIns="45719" bIns="45719" numCol="1" anchor="t">
+              <a:spAutoFit/>
+            </a:bodyPr>
+            <a:lstStyle/>
+            <a:p>
+              <a:pPr>
+                <a:defRPr>
+                  <a:latin typeface="Inter"/>
+                  <a:ea typeface="Inter"/>
+                  <a:cs typeface="Inter"/>
+                  <a:sym typeface="Inter"/>
+                </a:defRPr>
+              </a:pPr>
+              <a:r>
+                <a:t>Construction dataset</a:t>
+              </a:r>
+              <a:br/>
+              <a:r>
+                <a:t>et entrainement du modèle </a:t>
+              </a:r>
+            </a:p>
+            <a:p>
+              <a:pPr>
+                <a:defRPr>
+                  <a:latin typeface="Inter"/>
+                  <a:ea typeface="Inter"/>
+                  <a:cs typeface="Inter"/>
+                  <a:sym typeface="Inter"/>
+                </a:defRPr>
+              </a:pPr>
+              <a:r>
+                <a:t>en Local</a:t>
+              </a:r>
+            </a:p>
+          </p:txBody>
+        </p:sp>
+      </p:grpSp>
+      <p:sp>
+        <p:nvSpPr>
+          <p:cNvPr id="291" name="Fleche FastAPI vers Render"/>
+          <p:cNvSpPr/>
+          <p:nvPr/>
+        </p:nvSpPr>
+        <p:spPr>
+          <a:xfrm>
+            <a:off x="1664018" y="2785794"/>
+            <a:ext cx="1026492" cy="122923"/>
+          </a:xfrm>
+          <a:custGeom>
+            <a:avLst/>
+            <a:gdLst/>
+            <a:ahLst/>
+            <a:cxnLst>
+              <a:cxn ang="0">
+                <a:pos x="wd2" y="hd2"/>
+              </a:cxn>
+              <a:cxn ang="5400000">
+                <a:pos x="wd2" y="hd2"/>
+              </a:cxn>
+              <a:cxn ang="10800000">
+                <a:pos x="wd2" y="hd2"/>
+              </a:cxn>
+              <a:cxn ang="16200000">
+                <a:pos x="wd2" y="hd2"/>
+              </a:cxn>
+            </a:cxnLst>
+            <a:rect l="0" t="0" r="r" b="b"/>
+            <a:pathLst>
+              <a:path w="21600" h="21600" extrusionOk="0">
+                <a:moveTo>
+                  <a:pt x="0" y="21600"/>
+                </a:moveTo>
+                <a:lnTo>
+                  <a:pt x="21600" y="0"/>
+                </a:lnTo>
+              </a:path>
+            </a:pathLst>
+          </a:custGeom>
+          <a:ln w="19050" cap="rnd">
+            <a:solidFill>
+              <a:srgbClr val="015955"/>
+            </a:solidFill>
+            <a:tailEnd type="triangle"/>
+          </a:ln>
+        </p:spPr>
+        <p:txBody>
+          <a:bodyPr/>
+          <a:lstStyle/>
+          <a:p>
+            <a:endParaRPr/>
+          </a:p>
+        </p:txBody>
+      </p:sp>
+      <p:sp>
+        <p:nvSpPr>
+          <p:cNvPr id="292" name="Fleche FastAPI vers Render"/>
+          <p:cNvSpPr/>
+          <p:nvPr/>
+        </p:nvSpPr>
+        <p:spPr>
+          <a:xfrm>
+            <a:off x="3886991" y="2579290"/>
+            <a:ext cx="863916" cy="70972"/>
+          </a:xfrm>
+          <a:custGeom>
+            <a:avLst/>
+            <a:gdLst/>
+            <a:ahLst/>
+            <a:cxnLst>
+              <a:cxn ang="0">
+                <a:pos x="wd2" y="hd2"/>
+              </a:cxn>
+              <a:cxn ang="5400000">
+                <a:pos x="wd2" y="hd2"/>
+              </a:cxn>
+              <a:cxn ang="10800000">
+                <a:pos x="wd2" y="hd2"/>
+              </a:cxn>
+              <a:cxn ang="16200000">
+                <a:pos x="wd2" y="hd2"/>
+              </a:cxn>
+            </a:cxnLst>
+            <a:rect l="0" t="0" r="r" b="b"/>
+            <a:pathLst>
+              <a:path w="21600" h="21600" extrusionOk="0">
+                <a:moveTo>
+                  <a:pt x="0" y="21600"/>
+                </a:moveTo>
+                <a:lnTo>
+                  <a:pt x="21600" y="0"/>
+                </a:lnTo>
+              </a:path>
+            </a:pathLst>
+          </a:custGeom>
+          <a:ln w="19050" cap="rnd">
+            <a:solidFill>
+              <a:srgbClr val="015955"/>
+            </a:solidFill>
+            <a:tailEnd type="triangle"/>
+          </a:ln>
+        </p:spPr>
+        <p:txBody>
+          <a:bodyPr/>
+          <a:lstStyle/>
+          <a:p>
+            <a:endParaRPr/>
+          </a:p>
+        </p:txBody>
+      </p:sp>
+      <p:sp>
+        <p:nvSpPr>
+          <p:cNvPr id="293" name="Fleche FastAPI vers Render"/>
+          <p:cNvSpPr/>
+          <p:nvPr/>
+        </p:nvSpPr>
+        <p:spPr>
+          <a:xfrm>
+            <a:off x="6259797" y="2494809"/>
+            <a:ext cx="836907" cy="11836"/>
+          </a:xfrm>
+          <a:custGeom>
+            <a:avLst/>
+            <a:gdLst/>
+            <a:ahLst/>
+            <a:cxnLst>
+              <a:cxn ang="0">
+                <a:pos x="wd2" y="hd2"/>
+              </a:cxn>
+              <a:cxn ang="5400000">
+                <a:pos x="wd2" y="hd2"/>
+              </a:cxn>
+              <a:cxn ang="10800000">
+                <a:pos x="wd2" y="hd2"/>
+              </a:cxn>
+              <a:cxn ang="16200000">
+                <a:pos x="wd2" y="hd2"/>
+              </a:cxn>
+            </a:cxnLst>
+            <a:rect l="0" t="0" r="r" b="b"/>
+            <a:pathLst>
+              <a:path w="21600" h="21600" extrusionOk="0">
+                <a:moveTo>
+                  <a:pt x="0" y="21600"/>
+                </a:moveTo>
+                <a:lnTo>
+                  <a:pt x="21600" y="0"/>
+                </a:lnTo>
+              </a:path>
+            </a:pathLst>
+          </a:custGeom>
+          <a:ln w="19050" cap="rnd">
+            <a:solidFill>
+              <a:srgbClr val="015955"/>
+            </a:solidFill>
+            <a:tailEnd type="triangle"/>
+          </a:ln>
+        </p:spPr>
+        <p:txBody>
+          <a:bodyPr/>
+          <a:lstStyle/>
+          <a:p>
+            <a:endParaRPr/>
+          </a:p>
+        </p:txBody>
+      </p:sp>
+      <p:grpSp>
+        <p:nvGrpSpPr>
+          <p:cNvPr id="282" name="Groupe 36"/>
+          <p:cNvGrpSpPr/>
+          <p:nvPr/>
+        </p:nvGrpSpPr>
+        <p:grpSpPr>
+          <a:xfrm>
+            <a:off x="904198" y="2278927"/>
+            <a:ext cx="759821" cy="1350567"/>
+            <a:chOff x="0" y="0"/>
+            <a:chExt cx="759819" cy="1350566"/>
+          </a:xfrm>
+        </p:grpSpPr>
+        <p:pic>
+          <p:nvPicPr>
+            <p:cNvPr id="280" name="Image 9" descr="Image 9"/>
+            <p:cNvPicPr>
+              <a:picLocks noChangeAspect="1"/>
+            </p:cNvPicPr>
+            <p:nvPr/>
+          </p:nvPicPr>
+          <p:blipFill>
+            <a:blip r:embed="rId8"/>
+            <a:stretch>
+              <a:fillRect/>
+            </a:stretch>
+          </p:blipFill>
+          <p:spPr>
+            <a:xfrm>
+              <a:off x="0" y="-1"/>
+              <a:ext cx="759820" cy="698366"/>
+            </a:xfrm>
+            <a:prstGeom prst="rect">
+              <a:avLst/>
+            </a:prstGeom>
+            <a:ln w="12700" cap="flat">
+              <a:noFill/>
+              <a:miter lim="400000"/>
+            </a:ln>
+            <a:effectLst/>
+          </p:spPr>
+        </p:pic>
+        <p:pic>
+          <p:nvPicPr>
+            <p:cNvPr id="281" name="Image 35" descr="Image 35"/>
+            <p:cNvPicPr>
+              <a:picLocks noChangeAspect="1"/>
+            </p:cNvPicPr>
+            <p:nvPr/>
+          </p:nvPicPr>
+          <p:blipFill>
+            <a:blip r:embed="rId9"/>
+            <a:stretch>
+              <a:fillRect/>
+            </a:stretch>
+          </p:blipFill>
+          <p:spPr>
+            <a:xfrm>
+              <a:off x="0" y="572214"/>
+              <a:ext cx="759820" cy="778353"/>
+            </a:xfrm>
+            <a:prstGeom prst="rect">
+              <a:avLst/>
+            </a:prstGeom>
+            <a:ln w="12700" cap="flat">
+              <a:noFill/>
+              <a:miter lim="400000"/>
+            </a:ln>
+            <a:effectLst/>
+          </p:spPr>
+        </p:pic>
+      </p:grpSp>
+      <p:grpSp>
+        <p:nvGrpSpPr>
+          <p:cNvPr id="289" name="Groupe 39"/>
+          <p:cNvGrpSpPr/>
+          <p:nvPr/>
+        </p:nvGrpSpPr>
+        <p:grpSpPr>
+          <a:xfrm>
+            <a:off x="4750906" y="1740510"/>
+            <a:ext cx="1508895" cy="1553608"/>
+            <a:chOff x="0" y="0"/>
+            <a:chExt cx="1508894" cy="1553606"/>
+          </a:xfrm>
+        </p:grpSpPr>
+        <p:grpSp>
+          <p:nvGrpSpPr>
+            <p:cNvPr id="287" name="Groupe 26"/>
+            <p:cNvGrpSpPr/>
+            <p:nvPr/>
+          </p:nvGrpSpPr>
+          <p:grpSpPr>
+            <a:xfrm>
+              <a:off x="0" y="0"/>
+              <a:ext cx="1508894" cy="1553606"/>
+              <a:chOff x="0" y="0"/>
+              <a:chExt cx="1508893" cy="1553606"/>
+            </a:xfrm>
+          </p:grpSpPr>
+          <p:grpSp>
+            <p:nvGrpSpPr>
+              <p:cNvPr id="285" name="Groupe 3"/>
+              <p:cNvGrpSpPr/>
+              <p:nvPr/>
+            </p:nvGrpSpPr>
+            <p:grpSpPr>
+              <a:xfrm>
+                <a:off x="0" y="484198"/>
+                <a:ext cx="1508893" cy="1069408"/>
+                <a:chOff x="0" y="0"/>
+                <a:chExt cx="1508892" cy="1069407"/>
+              </a:xfrm>
+            </p:grpSpPr>
+            <p:pic>
+              <p:nvPicPr>
+                <p:cNvPr id="283" name="Image 4" descr="Image 4"/>
+                <p:cNvPicPr>
+                  <a:picLocks noChangeAspect="1"/>
+                </p:cNvPicPr>
+                <p:nvPr/>
+              </p:nvPicPr>
+              <p:blipFill>
+                <a:blip r:embed="rId10"/>
+                <a:stretch>
+                  <a:fillRect/>
+                </a:stretch>
+              </p:blipFill>
+              <p:spPr>
+                <a:xfrm>
+                  <a:off x="0" y="0"/>
+                  <a:ext cx="1508892" cy="762067"/>
+                </a:xfrm>
+                <a:prstGeom prst="rect">
+                  <a:avLst/>
+                </a:prstGeom>
+                <a:ln w="12700" cap="flat">
+                  <a:noFill/>
+                  <a:miter lim="400000"/>
+                </a:ln>
+                <a:effectLst/>
+              </p:spPr>
+            </p:pic>
+            <p:sp>
+              <p:nvSpPr>
+                <p:cNvPr id="284" name="ZoneTexte 5"/>
+                <p:cNvSpPr txBox="1"/>
+                <p:nvPr/>
+              </p:nvSpPr>
+              <p:spPr>
+                <a:xfrm>
+                  <a:off x="345738" y="762066"/>
+                  <a:ext cx="779400" cy="307341"/>
+                </a:xfrm>
+                <a:prstGeom prst="rect">
+                  <a:avLst/>
+                </a:prstGeom>
+                <a:noFill/>
+                <a:ln w="12700" cap="flat">
+                  <a:noFill/>
+                  <a:miter lim="400000"/>
+                </a:ln>
+                <a:effectLst/>
+                <a:extLst>
+                  <a:ext uri="{C572A759-6A51-4108-AA02-DFA0A04FC94B}">
+                    <ma14:wrappingTextBoxFlag xmlns="" xmlns:m="http://schemas.openxmlformats.org/officeDocument/2006/math" xmlns:a14="http://schemas.microsoft.com/office/drawing/2010/main" xmlns:ma14="http://schemas.microsoft.com/office/mac/drawingml/2011/main" val="1"/>
+                  </a:ext>
+                </a:extLst>
+              </p:spPr>
+              <p:txBody>
+                <a:bodyPr wrap="none" lIns="45719" tIns="45719" rIns="45719" bIns="45719" numCol="1" anchor="t">
+                  <a:spAutoFit/>
+                </a:bodyPr>
+                <a:lstStyle>
+                  <a:lvl1pPr>
+                    <a:defRPr>
+                      <a:latin typeface="Inter"/>
+                      <a:ea typeface="Inter"/>
+                      <a:cs typeface="Inter"/>
+                      <a:sym typeface="Inter"/>
+                    </a:defRPr>
+                  </a:lvl1pPr>
+                </a:lstStyle>
+                <a:p>
+                  <a:r>
+                    <a:t>Tracking</a:t>
+                  </a:r>
+                </a:p>
+              </p:txBody>
+            </p:sp>
+          </p:grpSp>
+          <p:pic>
+            <p:nvPicPr>
+              <p:cNvPr id="286" name="Image 11" descr="Image 11"/>
+              <p:cNvPicPr>
+                <a:picLocks noChangeAspect="1"/>
+              </p:cNvPicPr>
+              <p:nvPr/>
+            </p:nvPicPr>
+            <p:blipFill>
+              <a:blip r:embed="rId11"/>
+              <a:stretch>
+                <a:fillRect/>
+              </a:stretch>
+            </p:blipFill>
+            <p:spPr>
+              <a:xfrm>
+                <a:off x="390419" y="0"/>
+                <a:ext cx="728055" cy="599032"/>
+              </a:xfrm>
+              <a:prstGeom prst="rect">
+                <a:avLst/>
+              </a:prstGeom>
+              <a:ln w="12700" cap="flat">
+                <a:noFill/>
+                <a:miter lim="400000"/>
+              </a:ln>
+              <a:effectLst/>
+            </p:spPr>
+          </p:pic>
+        </p:grpSp>
+        <p:pic>
+          <p:nvPicPr>
+            <p:cNvPr id="288" name="Image 38" descr="Image 38"/>
+            <p:cNvPicPr>
+              <a:picLocks noChangeAspect="1"/>
+            </p:cNvPicPr>
+            <p:nvPr/>
+          </p:nvPicPr>
+          <p:blipFill>
+            <a:blip r:embed="rId12"/>
+            <a:stretch>
+              <a:fillRect/>
+            </a:stretch>
+          </p:blipFill>
+          <p:spPr>
+            <a:xfrm>
+              <a:off x="1138058" y="320055"/>
+              <a:ext cx="351248" cy="213377"/>
+            </a:xfrm>
+            <a:prstGeom prst="rect">
+              <a:avLst/>
+            </a:prstGeom>
+            <a:ln w="12700" cap="flat">
+              <a:noFill/>
+              <a:miter lim="400000"/>
+            </a:ln>
+            <a:effectLst/>
+          </p:spPr>
+        </p:pic>
+      </p:grpSp>
+      <p:pic>
+        <p:nvPicPr>
+          <p:cNvPr id="290" name="Image 41" descr="Image 41"/>
+          <p:cNvPicPr>
+            <a:picLocks noChangeAspect="1"/>
+          </p:cNvPicPr>
+          <p:nvPr/>
+        </p:nvPicPr>
+        <p:blipFill>
+          <a:blip r:embed="rId13"/>
+          <a:stretch>
+            <a:fillRect/>
+          </a:stretch>
+        </p:blipFill>
+        <p:spPr>
+          <a:xfrm>
+            <a:off x="3092480" y="3816081"/>
+            <a:ext cx="759821" cy="410655"/>
+          </a:xfrm>
+          <a:prstGeom prst="rect">
+            <a:avLst/>
+          </a:prstGeom>
+          <a:ln w="12700">
+            <a:miter lim="400000"/>
+          </a:ln>
+        </p:spPr>
+      </p:pic>
     </p:spTree>
   </p:cSld>
   <p:clrMapOvr>

</xml_diff>

<commit_message>
update video link from Safidy
</commit_message>
<xml_diff>
--- a/docs/FootballPredictorDemoDay20260803.pptx
+++ b/docs/FootballPredictorDemoDay20260803.pptx
@@ -1966,7 +1966,7 @@
           </a:ln>
           <a:extLst>
             <a:ext uri="{C572A759-6A51-4108-AA02-DFA0A04FC94B}">
-              <ma14:wrappingTextBoxFlag xmlns="" xmlns:m="http://schemas.openxmlformats.org/officeDocument/2006/math" xmlns:a14="http://schemas.microsoft.com/office/drawing/2010/main" xmlns:ma14="http://schemas.microsoft.com/office/mac/drawingml/2011/main" val="1"/>
+              <ma14:wrappingTextBoxFlag xmlns:ma14="http://schemas.microsoft.com/office/mac/drawingml/2011/main" xmlns:a14="http://schemas.microsoft.com/office/drawing/2010/main" xmlns:m="http://schemas.openxmlformats.org/officeDocument/2006/math" xmlns="" val="1"/>
             </a:ext>
           </a:extLst>
         </p:spPr>
@@ -2005,7 +2005,7 @@
           </a:ln>
           <a:extLst>
             <a:ext uri="{C572A759-6A51-4108-AA02-DFA0A04FC94B}">
-              <ma14:wrappingTextBoxFlag xmlns="" xmlns:m="http://schemas.openxmlformats.org/officeDocument/2006/math" xmlns:a14="http://schemas.microsoft.com/office/drawing/2010/main" xmlns:ma14="http://schemas.microsoft.com/office/mac/drawingml/2011/main" val="1"/>
+              <ma14:wrappingTextBoxFlag xmlns:ma14="http://schemas.microsoft.com/office/mac/drawingml/2011/main" xmlns:a14="http://schemas.microsoft.com/office/drawing/2010/main" xmlns:m="http://schemas.openxmlformats.org/officeDocument/2006/math" xmlns="" val="1"/>
             </a:ext>
           </a:extLst>
         </p:spPr>
@@ -3111,7 +3111,7 @@
           </a:ln>
           <a:extLst>
             <a:ext uri="{C572A759-6A51-4108-AA02-DFA0A04FC94B}">
-              <ma14:wrappingTextBoxFlag xmlns:ma14="http://schemas.microsoft.com/office/mac/drawingml/2011/main" xmlns:a14="http://schemas.microsoft.com/office/drawing/2010/main" xmlns:m="http://schemas.openxmlformats.org/officeDocument/2006/math" xmlns="" val="1"/>
+              <ma14:wrappingTextBoxFlag xmlns="" xmlns:m="http://schemas.openxmlformats.org/officeDocument/2006/math" xmlns:a14="http://schemas.microsoft.com/office/drawing/2010/main" xmlns:ma14="http://schemas.microsoft.com/office/mac/drawingml/2011/main" val="1"/>
             </a:ext>
           </a:extLst>
         </p:spPr>
@@ -3332,7 +3332,7 @@
           </a:ln>
           <a:extLst>
             <a:ext uri="{C572A759-6A51-4108-AA02-DFA0A04FC94B}">
-              <ma14:wrappingTextBoxFlag xmlns="" xmlns:m="http://schemas.openxmlformats.org/officeDocument/2006/math" xmlns:a14="http://schemas.microsoft.com/office/drawing/2010/main" xmlns:ma14="http://schemas.microsoft.com/office/mac/drawingml/2011/main" val="1"/>
+              <ma14:wrappingTextBoxFlag xmlns:ma14="http://schemas.microsoft.com/office/mac/drawingml/2011/main" xmlns:a14="http://schemas.microsoft.com/office/drawing/2010/main" xmlns:m="http://schemas.openxmlformats.org/officeDocument/2006/math" xmlns="" val="1"/>
             </a:ext>
           </a:extLst>
         </p:spPr>
@@ -3390,19 +3390,53 @@
               </a:defRPr>
             </a:pPr>
             <a:r>
-              <a:rPr dirty="0" err="1"/>
+              <a:rPr lang="fr-FR" dirty="0">
+                <a:solidFill>
+                  <a:schemeClr val="accent3">
+                    <a:lumMod val="50000"/>
+                  </a:schemeClr>
+                </a:solidFill>
+              </a:rPr>
+              <a:t>  </a:t>
+            </a:r>
+            <a:r>
+              <a:rPr dirty="0" err="1">
+                <a:solidFill>
+                  <a:schemeClr val="accent3">
+                    <a:lumMod val="50000"/>
+                  </a:schemeClr>
+                </a:solidFill>
+              </a:rPr>
               <a:t>Besoin</a:t>
             </a:r>
             <a:r>
-              <a:rPr dirty="0"/>
+              <a:rPr dirty="0">
+                <a:solidFill>
+                  <a:schemeClr val="accent3">
+                    <a:lumMod val="50000"/>
+                  </a:schemeClr>
+                </a:solidFill>
+              </a:rPr>
               <a:t> : assister un </a:t>
             </a:r>
             <a:r>
-              <a:rPr dirty="0" err="1"/>
+              <a:rPr dirty="0" err="1">
+                <a:solidFill>
+                  <a:schemeClr val="accent3">
+                    <a:lumMod val="50000"/>
+                  </a:schemeClr>
+                </a:solidFill>
+              </a:rPr>
               <a:t>entraineur</a:t>
             </a:r>
             <a:r>
-              <a:rPr dirty="0"/>
+              <a:rPr dirty="0">
+                <a:solidFill>
+                  <a:schemeClr val="accent3">
+                    <a:lumMod val="50000"/>
+                  </a:schemeClr>
+                </a:solidFill>
+              </a:rPr>
               <a:t> de foot pour former son équipe</a:t>
             </a:r>
           </a:p>
@@ -3422,46 +3456,122 @@
               </a:defRPr>
             </a:pPr>
             <a:r>
-              <a:rPr dirty="0"/>
+              <a:rPr lang="fr-FR" dirty="0">
+                <a:solidFill>
+                  <a:schemeClr val="accent3">
+                    <a:lumMod val="50000"/>
+                  </a:schemeClr>
+                </a:solidFill>
+              </a:rPr>
+              <a:t>  </a:t>
+            </a:r>
+            <a:r>
+              <a:rPr dirty="0">
+                <a:solidFill>
+                  <a:schemeClr val="accent3">
+                    <a:lumMod val="50000"/>
+                  </a:schemeClr>
+                </a:solidFill>
+              </a:rPr>
               <a:t>Proposition : </a:t>
             </a:r>
             <a:r>
-              <a:rPr dirty="0" err="1"/>
+              <a:rPr dirty="0" err="1">
+                <a:solidFill>
+                  <a:schemeClr val="accent3">
+                    <a:lumMod val="50000"/>
+                  </a:schemeClr>
+                </a:solidFill>
+              </a:rPr>
               <a:t>une</a:t>
             </a:r>
             <a:r>
-              <a:rPr dirty="0"/>
+              <a:rPr dirty="0">
+                <a:solidFill>
+                  <a:schemeClr val="accent3">
+                    <a:lumMod val="50000"/>
+                  </a:schemeClr>
+                </a:solidFill>
+              </a:rPr>
               <a:t> application pour </a:t>
             </a:r>
             <a:r>
-              <a:rPr dirty="0" err="1"/>
+              <a:rPr dirty="0" err="1">
+                <a:solidFill>
+                  <a:schemeClr val="accent3">
+                    <a:lumMod val="50000"/>
+                  </a:schemeClr>
+                </a:solidFill>
+              </a:rPr>
               <a:t>l’aider</a:t>
             </a:r>
             <a:r>
-              <a:rPr dirty="0"/>
+              <a:rPr dirty="0">
+                <a:solidFill>
+                  <a:schemeClr val="accent3">
+                    <a:lumMod val="50000"/>
+                  </a:schemeClr>
+                </a:solidFill>
+              </a:rPr>
               <a:t> à </a:t>
             </a:r>
             <a:r>
-              <a:rPr dirty="0" err="1"/>
+              <a:rPr dirty="0" err="1">
+                <a:solidFill>
+                  <a:schemeClr val="accent3">
+                    <a:lumMod val="50000"/>
+                  </a:schemeClr>
+                </a:solidFill>
+              </a:rPr>
               <a:t>choisir</a:t>
             </a:r>
             <a:r>
-              <a:rPr dirty="0"/>
+              <a:rPr dirty="0">
+                <a:solidFill>
+                  <a:schemeClr val="accent3">
+                    <a:lumMod val="50000"/>
+                  </a:schemeClr>
+                </a:solidFill>
+              </a:rPr>
               <a:t> </a:t>
             </a:r>
             <a:r>
-              <a:rPr dirty="0" err="1"/>
+              <a:rPr dirty="0" err="1">
+                <a:solidFill>
+                  <a:schemeClr val="accent3">
+                    <a:lumMod val="50000"/>
+                  </a:schemeClr>
+                </a:solidFill>
+              </a:rPr>
               <a:t>ses</a:t>
             </a:r>
             <a:r>
-              <a:rPr dirty="0"/>
+              <a:rPr dirty="0">
+                <a:solidFill>
+                  <a:schemeClr val="accent3">
+                    <a:lumMod val="50000"/>
+                  </a:schemeClr>
+                </a:solidFill>
+              </a:rPr>
               <a:t> </a:t>
             </a:r>
             <a:r>
-              <a:rPr dirty="0" err="1"/>
+              <a:rPr dirty="0" err="1">
+                <a:solidFill>
+                  <a:schemeClr val="accent3">
+                    <a:lumMod val="50000"/>
+                  </a:schemeClr>
+                </a:solidFill>
+              </a:rPr>
               <a:t>joueurs</a:t>
             </a:r>
-            <a:endParaRPr lang="fr-FR" dirty="0"/>
+            <a:endParaRPr lang="fr-FR" dirty="0">
+              <a:solidFill>
+                <a:schemeClr val="accent3">
+                  <a:lumMod val="50000"/>
+                </a:schemeClr>
+              </a:solidFill>
+            </a:endParaRPr>
           </a:p>
           <a:p>
             <a:pPr>
@@ -3709,7 +3819,7 @@
           </a:ln>
           <a:extLst>
             <a:ext uri="{C572A759-6A51-4108-AA02-DFA0A04FC94B}">
-              <ma14:wrappingTextBoxFlag xmlns:ma14="http://schemas.microsoft.com/office/mac/drawingml/2011/main" xmlns:a14="http://schemas.microsoft.com/office/drawing/2010/main" xmlns:m="http://schemas.openxmlformats.org/officeDocument/2006/math" xmlns="" val="1"/>
+              <ma14:wrappingTextBoxFlag xmlns="" xmlns:m="http://schemas.openxmlformats.org/officeDocument/2006/math" xmlns:a14="http://schemas.microsoft.com/office/drawing/2010/main" xmlns:ma14="http://schemas.microsoft.com/office/mac/drawingml/2011/main" val="1"/>
             </a:ext>
           </a:extLst>
         </p:spPr>
@@ -4055,7 +4165,7 @@
           </a:ln>
           <a:extLst>
             <a:ext uri="{C572A759-6A51-4108-AA02-DFA0A04FC94B}">
-              <ma14:wrappingTextBoxFlag xmlns="" xmlns:m="http://schemas.openxmlformats.org/officeDocument/2006/math" xmlns:a14="http://schemas.microsoft.com/office/drawing/2010/main" xmlns:ma14="http://schemas.microsoft.com/office/mac/drawingml/2011/main" val="1"/>
+              <ma14:wrappingTextBoxFlag xmlns:ma14="http://schemas.microsoft.com/office/mac/drawingml/2011/main" xmlns:a14="http://schemas.microsoft.com/office/drawing/2010/main" xmlns:m="http://schemas.openxmlformats.org/officeDocument/2006/math" xmlns="" val="1"/>
             </a:ext>
           </a:extLst>
         </p:spPr>
@@ -4160,7 +4270,7 @@
           </a:ln>
           <a:extLst>
             <a:ext uri="{C572A759-6A51-4108-AA02-DFA0A04FC94B}">
-              <ma14:wrappingTextBoxFlag xmlns="" xmlns:m="http://schemas.openxmlformats.org/officeDocument/2006/math" xmlns:a14="http://schemas.microsoft.com/office/drawing/2010/main" xmlns:ma14="http://schemas.microsoft.com/office/mac/drawingml/2011/main" val="1"/>
+              <ma14:wrappingTextBoxFlag xmlns:ma14="http://schemas.microsoft.com/office/mac/drawingml/2011/main" xmlns:a14="http://schemas.microsoft.com/office/drawing/2010/main" xmlns:m="http://schemas.openxmlformats.org/officeDocument/2006/math" xmlns="" val="1"/>
             </a:ext>
           </a:extLst>
         </p:spPr>
@@ -4497,7 +4607,7 @@
             <a:effectLst/>
             <a:extLst>
               <a:ext uri="{C572A759-6A51-4108-AA02-DFA0A04FC94B}">
-                <ma14:wrappingTextBoxFlag xmlns="" xmlns:m="http://schemas.openxmlformats.org/officeDocument/2006/math" xmlns:a14="http://schemas.microsoft.com/office/drawing/2010/main" xmlns:ma14="http://schemas.microsoft.com/office/mac/drawingml/2011/main" val="1"/>
+                <ma14:wrappingTextBoxFlag xmlns:ma14="http://schemas.microsoft.com/office/mac/drawingml/2011/main" xmlns:a14="http://schemas.microsoft.com/office/drawing/2010/main" xmlns:m="http://schemas.openxmlformats.org/officeDocument/2006/math" xmlns="" val="1"/>
               </a:ext>
             </a:extLst>
           </p:spPr>
@@ -4588,7 +4698,7 @@
             <a:effectLst/>
             <a:extLst>
               <a:ext uri="{C572A759-6A51-4108-AA02-DFA0A04FC94B}">
-                <ma14:wrappingTextBoxFlag xmlns="" xmlns:m="http://schemas.openxmlformats.org/officeDocument/2006/math" xmlns:a14="http://schemas.microsoft.com/office/drawing/2010/main" xmlns:ma14="http://schemas.microsoft.com/office/mac/drawingml/2011/main" val="1"/>
+                <ma14:wrappingTextBoxFlag xmlns:ma14="http://schemas.microsoft.com/office/mac/drawingml/2011/main" xmlns:a14="http://schemas.microsoft.com/office/drawing/2010/main" xmlns:m="http://schemas.openxmlformats.org/officeDocument/2006/math" xmlns="" val="1"/>
               </a:ext>
             </a:extLst>
           </p:spPr>
@@ -5252,7 +5362,7 @@
           </a:ln>
           <a:extLst>
             <a:ext uri="{C572A759-6A51-4108-AA02-DFA0A04FC94B}">
-              <ma14:wrappingTextBoxFlag xmlns="" xmlns:m="http://schemas.openxmlformats.org/officeDocument/2006/math" xmlns:a14="http://schemas.microsoft.com/office/drawing/2010/main" xmlns:ma14="http://schemas.microsoft.com/office/mac/drawingml/2011/main" val="1"/>
+              <ma14:wrappingTextBoxFlag xmlns:ma14="http://schemas.microsoft.com/office/mac/drawingml/2011/main" xmlns:a14="http://schemas.microsoft.com/office/drawing/2010/main" xmlns:m="http://schemas.openxmlformats.org/officeDocument/2006/math" xmlns="" val="1"/>
             </a:ext>
           </a:extLst>
         </p:spPr>
@@ -5557,7 +5667,7 @@
           </a:ln>
           <a:extLst>
             <a:ext uri="{C572A759-6A51-4108-AA02-DFA0A04FC94B}">
-              <ma14:wrappingTextBoxFlag xmlns="" xmlns:m="http://schemas.openxmlformats.org/officeDocument/2006/math" xmlns:a14="http://schemas.microsoft.com/office/drawing/2010/main" xmlns:ma14="http://schemas.microsoft.com/office/mac/drawingml/2011/main" val="1"/>
+              <ma14:wrappingTextBoxFlag xmlns:ma14="http://schemas.microsoft.com/office/mac/drawingml/2011/main" xmlns:a14="http://schemas.microsoft.com/office/drawing/2010/main" xmlns:m="http://schemas.openxmlformats.org/officeDocument/2006/math" xmlns="" val="1"/>
             </a:ext>
           </a:extLst>
         </p:spPr>
@@ -5604,7 +5714,7 @@
           </a:ln>
           <a:extLst>
             <a:ext uri="{C572A759-6A51-4108-AA02-DFA0A04FC94B}">
-              <ma14:wrappingTextBoxFlag xmlns="" xmlns:m="http://schemas.openxmlformats.org/officeDocument/2006/math" xmlns:a14="http://schemas.microsoft.com/office/drawing/2010/main" xmlns:ma14="http://schemas.microsoft.com/office/mac/drawingml/2011/main" val="1"/>
+              <ma14:wrappingTextBoxFlag xmlns:ma14="http://schemas.microsoft.com/office/mac/drawingml/2011/main" xmlns:a14="http://schemas.microsoft.com/office/drawing/2010/main" xmlns:m="http://schemas.openxmlformats.org/officeDocument/2006/math" xmlns="" val="1"/>
             </a:ext>
           </a:extLst>
         </p:spPr>
@@ -5651,7 +5761,7 @@
           </a:ln>
           <a:extLst>
             <a:ext uri="{C572A759-6A51-4108-AA02-DFA0A04FC94B}">
-              <ma14:wrappingTextBoxFlag xmlns="" xmlns:m="http://schemas.openxmlformats.org/officeDocument/2006/math" xmlns:a14="http://schemas.microsoft.com/office/drawing/2010/main" xmlns:ma14="http://schemas.microsoft.com/office/mac/drawingml/2011/main" val="1"/>
+              <ma14:wrappingTextBoxFlag xmlns:ma14="http://schemas.microsoft.com/office/mac/drawingml/2011/main" xmlns:a14="http://schemas.microsoft.com/office/drawing/2010/main" xmlns:m="http://schemas.openxmlformats.org/officeDocument/2006/math" xmlns="" val="1"/>
             </a:ext>
           </a:extLst>
         </p:spPr>
@@ -5698,7 +5808,7 @@
           </a:ln>
           <a:extLst>
             <a:ext uri="{C572A759-6A51-4108-AA02-DFA0A04FC94B}">
-              <ma14:wrappingTextBoxFlag xmlns="" xmlns:m="http://schemas.openxmlformats.org/officeDocument/2006/math" xmlns:a14="http://schemas.microsoft.com/office/drawing/2010/main" xmlns:ma14="http://schemas.microsoft.com/office/mac/drawingml/2011/main" val="1"/>
+              <ma14:wrappingTextBoxFlag xmlns:ma14="http://schemas.microsoft.com/office/mac/drawingml/2011/main" xmlns:a14="http://schemas.microsoft.com/office/drawing/2010/main" xmlns:m="http://schemas.openxmlformats.org/officeDocument/2006/math" xmlns="" val="1"/>
             </a:ext>
           </a:extLst>
         </p:spPr>
@@ -6305,7 +6415,7 @@
           </a:ln>
           <a:extLst>
             <a:ext uri="{C572A759-6A51-4108-AA02-DFA0A04FC94B}">
-              <ma14:wrappingTextBoxFlag xmlns="" xmlns:m="http://schemas.openxmlformats.org/officeDocument/2006/math" xmlns:a14="http://schemas.microsoft.com/office/drawing/2010/main" xmlns:ma14="http://schemas.microsoft.com/office/mac/drawingml/2011/main" val="1"/>
+              <ma14:wrappingTextBoxFlag xmlns:ma14="http://schemas.microsoft.com/office/mac/drawingml/2011/main" xmlns:a14="http://schemas.microsoft.com/office/drawing/2010/main" xmlns:m="http://schemas.openxmlformats.org/officeDocument/2006/math" xmlns="" val="1"/>
             </a:ext>
           </a:extLst>
         </p:spPr>
@@ -6352,7 +6462,7 @@
           </a:ln>
           <a:extLst>
             <a:ext uri="{C572A759-6A51-4108-AA02-DFA0A04FC94B}">
-              <ma14:wrappingTextBoxFlag xmlns="" xmlns:m="http://schemas.openxmlformats.org/officeDocument/2006/math" xmlns:a14="http://schemas.microsoft.com/office/drawing/2010/main" xmlns:ma14="http://schemas.microsoft.com/office/mac/drawingml/2011/main" val="1"/>
+              <ma14:wrappingTextBoxFlag xmlns:ma14="http://schemas.microsoft.com/office/mac/drawingml/2011/main" xmlns:a14="http://schemas.microsoft.com/office/drawing/2010/main" xmlns:m="http://schemas.openxmlformats.org/officeDocument/2006/math" xmlns="" val="1"/>
             </a:ext>
           </a:extLst>
         </p:spPr>
@@ -6399,7 +6509,7 @@
           </a:ln>
           <a:extLst>
             <a:ext uri="{C572A759-6A51-4108-AA02-DFA0A04FC94B}">
-              <ma14:wrappingTextBoxFlag xmlns="" xmlns:m="http://schemas.openxmlformats.org/officeDocument/2006/math" xmlns:a14="http://schemas.microsoft.com/office/drawing/2010/main" xmlns:ma14="http://schemas.microsoft.com/office/mac/drawingml/2011/main" val="1"/>
+              <ma14:wrappingTextBoxFlag xmlns:ma14="http://schemas.microsoft.com/office/mac/drawingml/2011/main" xmlns:a14="http://schemas.microsoft.com/office/drawing/2010/main" xmlns:m="http://schemas.openxmlformats.org/officeDocument/2006/math" xmlns="" val="1"/>
             </a:ext>
           </a:extLst>
         </p:spPr>
@@ -6446,7 +6556,7 @@
           </a:ln>
           <a:extLst>
             <a:ext uri="{C572A759-6A51-4108-AA02-DFA0A04FC94B}">
-              <ma14:wrappingTextBoxFlag xmlns="" xmlns:m="http://schemas.openxmlformats.org/officeDocument/2006/math" xmlns:a14="http://schemas.microsoft.com/office/drawing/2010/main" xmlns:ma14="http://schemas.microsoft.com/office/mac/drawingml/2011/main" val="1"/>
+              <ma14:wrappingTextBoxFlag xmlns:ma14="http://schemas.microsoft.com/office/mac/drawingml/2011/main" xmlns:a14="http://schemas.microsoft.com/office/drawing/2010/main" xmlns:m="http://schemas.openxmlformats.org/officeDocument/2006/math" xmlns="" val="1"/>
             </a:ext>
           </a:extLst>
         </p:spPr>
@@ -6493,7 +6603,7 @@
           </a:ln>
           <a:extLst>
             <a:ext uri="{C572A759-6A51-4108-AA02-DFA0A04FC94B}">
-              <ma14:wrappingTextBoxFlag xmlns="" xmlns:m="http://schemas.openxmlformats.org/officeDocument/2006/math" xmlns:a14="http://schemas.microsoft.com/office/drawing/2010/main" xmlns:ma14="http://schemas.microsoft.com/office/mac/drawingml/2011/main" val="1"/>
+              <ma14:wrappingTextBoxFlag xmlns:ma14="http://schemas.microsoft.com/office/mac/drawingml/2011/main" xmlns:a14="http://schemas.microsoft.com/office/drawing/2010/main" xmlns:m="http://schemas.openxmlformats.org/officeDocument/2006/math" xmlns="" val="1"/>
             </a:ext>
           </a:extLst>
         </p:spPr>
@@ -6540,7 +6650,7 @@
           </a:ln>
           <a:extLst>
             <a:ext uri="{C572A759-6A51-4108-AA02-DFA0A04FC94B}">
-              <ma14:wrappingTextBoxFlag xmlns="" xmlns:m="http://schemas.openxmlformats.org/officeDocument/2006/math" xmlns:a14="http://schemas.microsoft.com/office/drawing/2010/main" xmlns:ma14="http://schemas.microsoft.com/office/mac/drawingml/2011/main" val="1"/>
+              <ma14:wrappingTextBoxFlag xmlns:ma14="http://schemas.microsoft.com/office/mac/drawingml/2011/main" xmlns:a14="http://schemas.microsoft.com/office/drawing/2010/main" xmlns:m="http://schemas.openxmlformats.org/officeDocument/2006/math" xmlns="" val="1"/>
             </a:ext>
           </a:extLst>
         </p:spPr>
@@ -6611,7 +6721,7 @@
         </p:blipFill>
         <p:spPr>
           <a:xfrm>
-            <a:off x="0" y="0"/>
+            <a:off x="10225" y="0"/>
             <a:ext cx="9144000" cy="5143500"/>
           </a:xfrm>
           <a:prstGeom prst="rect">
@@ -6657,10 +6767,19 @@
               </a:defRPr>
             </a:pPr>
             <a:r>
-              <a:t>Football predictor application - Démonstration </a:t>
+              <a:rPr dirty="0"/>
+              <a:t>Football predictor application - </a:t>
             </a:r>
             <a:r>
-              <a:rPr u="sng">
+              <a:rPr dirty="0" err="1"/>
+              <a:t>Démonstration</a:t>
+            </a:r>
+            <a:r>
+              <a:rPr dirty="0"/>
+              <a:t> </a:t>
+            </a:r>
+            <a:r>
+              <a:rPr u="sng" dirty="0" err="1">
                 <a:solidFill>
                   <a:srgbClr val="0000FF"/>
                 </a:solidFill>
@@ -6671,7 +6790,21 @@
                 </a:uFill>
                 <a:hlinkClick r:id="rId3"/>
               </a:rPr>
-              <a:t>Vidéo </a:t>
+              <a:t>Vidéo</a:t>
+            </a:r>
+            <a:r>
+              <a:rPr u="sng" dirty="0">
+                <a:solidFill>
+                  <a:srgbClr val="0000FF"/>
+                </a:solidFill>
+                <a:uFill>
+                  <a:solidFill>
+                    <a:srgbClr val="0000FF"/>
+                  </a:solidFill>
+                </a:uFill>
+                <a:hlinkClick r:id="rId4"/>
+              </a:rPr>
+              <a:t> </a:t>
             </a:r>
           </a:p>
         </p:txBody>
@@ -6685,7 +6818,7 @@
           <p:nvPr/>
         </p:nvPicPr>
         <p:blipFill>
-          <a:blip r:embed="rId4"/>
+          <a:blip r:embed="rId5"/>
           <a:stretch>
             <a:fillRect/>
           </a:stretch>
@@ -7081,7 +7214,7 @@
           <p:nvPr/>
         </p:nvPicPr>
         <p:blipFill>
-          <a:blip r:embed="rId5"/>
+          <a:blip r:embed="rId6"/>
           <a:stretch>
             <a:fillRect/>
           </a:stretch>
@@ -7108,7 +7241,7 @@
           <p:nvPr/>
         </p:nvPicPr>
         <p:blipFill>
-          <a:blip r:embed="rId6"/>
+          <a:blip r:embed="rId7"/>
           <a:stretch>
             <a:fillRect/>
           </a:stretch>
@@ -7135,7 +7268,7 @@
           <p:nvPr/>
         </p:nvPicPr>
         <p:blipFill>
-          <a:blip r:embed="rId7"/>
+          <a:blip r:embed="rId8"/>
           <a:stretch>
             <a:fillRect/>
           </a:stretch>
@@ -7162,7 +7295,7 @@
           <p:nvPr/>
         </p:nvPicPr>
         <p:blipFill>
-          <a:blip r:embed="rId8"/>
+          <a:blip r:embed="rId9"/>
           <a:stretch>
             <a:fillRect/>
           </a:stretch>
@@ -7199,7 +7332,7 @@
           </a:ln>
           <a:extLst>
             <a:ext uri="{C572A759-6A51-4108-AA02-DFA0A04FC94B}">
-              <ma14:wrappingTextBoxFlag xmlns="" xmlns:m="http://schemas.openxmlformats.org/officeDocument/2006/math" xmlns:a14="http://schemas.microsoft.com/office/drawing/2010/main" xmlns:ma14="http://schemas.microsoft.com/office/mac/drawingml/2011/main" val="1"/>
+              <ma14:wrappingTextBoxFlag xmlns:ma14="http://schemas.microsoft.com/office/mac/drawingml/2011/main" xmlns:a14="http://schemas.microsoft.com/office/drawing/2010/main" xmlns:m="http://schemas.openxmlformats.org/officeDocument/2006/math" xmlns="" val="1"/>
             </a:ext>
           </a:extLst>
         </p:spPr>
@@ -7246,7 +7379,7 @@
           </a:ln>
           <a:extLst>
             <a:ext uri="{C572A759-6A51-4108-AA02-DFA0A04FC94B}">
-              <ma14:wrappingTextBoxFlag xmlns="" xmlns:m="http://schemas.openxmlformats.org/officeDocument/2006/math" xmlns:a14="http://schemas.microsoft.com/office/drawing/2010/main" xmlns:ma14="http://schemas.microsoft.com/office/mac/drawingml/2011/main" val="1"/>
+              <ma14:wrappingTextBoxFlag xmlns:ma14="http://schemas.microsoft.com/office/mac/drawingml/2011/main" xmlns:a14="http://schemas.microsoft.com/office/drawing/2010/main" xmlns:m="http://schemas.openxmlformats.org/officeDocument/2006/math" xmlns="" val="1"/>
             </a:ext>
           </a:extLst>
         </p:spPr>
@@ -7293,7 +7426,7 @@
           </a:ln>
           <a:extLst>
             <a:ext uri="{C572A759-6A51-4108-AA02-DFA0A04FC94B}">
-              <ma14:wrappingTextBoxFlag xmlns="" xmlns:m="http://schemas.openxmlformats.org/officeDocument/2006/math" xmlns:a14="http://schemas.microsoft.com/office/drawing/2010/main" xmlns:ma14="http://schemas.microsoft.com/office/mac/drawingml/2011/main" val="1"/>
+              <ma14:wrappingTextBoxFlag xmlns:ma14="http://schemas.microsoft.com/office/mac/drawingml/2011/main" xmlns:a14="http://schemas.microsoft.com/office/drawing/2010/main" xmlns:m="http://schemas.openxmlformats.org/officeDocument/2006/math" xmlns="" val="1"/>
             </a:ext>
           </a:extLst>
         </p:spPr>
@@ -7340,7 +7473,7 @@
           </a:ln>
           <a:extLst>
             <a:ext uri="{C572A759-6A51-4108-AA02-DFA0A04FC94B}">
-              <ma14:wrappingTextBoxFlag xmlns="" xmlns:m="http://schemas.openxmlformats.org/officeDocument/2006/math" xmlns:a14="http://schemas.microsoft.com/office/drawing/2010/main" xmlns:ma14="http://schemas.microsoft.com/office/mac/drawingml/2011/main" val="1"/>
+              <ma14:wrappingTextBoxFlag xmlns:ma14="http://schemas.microsoft.com/office/mac/drawingml/2011/main" xmlns:a14="http://schemas.microsoft.com/office/drawing/2010/main" xmlns:m="http://schemas.openxmlformats.org/officeDocument/2006/math" xmlns="" val="1"/>
             </a:ext>
           </a:extLst>
         </p:spPr>
@@ -7387,7 +7520,7 @@
           </a:ln>
           <a:extLst>
             <a:ext uri="{C572A759-6A51-4108-AA02-DFA0A04FC94B}">
-              <ma14:wrappingTextBoxFlag xmlns="" xmlns:m="http://schemas.openxmlformats.org/officeDocument/2006/math" xmlns:a14="http://schemas.microsoft.com/office/drawing/2010/main" xmlns:ma14="http://schemas.microsoft.com/office/mac/drawingml/2011/main" val="1"/>
+              <ma14:wrappingTextBoxFlag xmlns:ma14="http://schemas.microsoft.com/office/mac/drawingml/2011/main" xmlns:a14="http://schemas.microsoft.com/office/drawing/2010/main" xmlns:m="http://schemas.openxmlformats.org/officeDocument/2006/math" xmlns="" val="1"/>
             </a:ext>
           </a:extLst>
         </p:spPr>
@@ -7434,7 +7567,7 @@
           </a:ln>
           <a:extLst>
             <a:ext uri="{C572A759-6A51-4108-AA02-DFA0A04FC94B}">
-              <ma14:wrappingTextBoxFlag xmlns="" xmlns:m="http://schemas.openxmlformats.org/officeDocument/2006/math" xmlns:a14="http://schemas.microsoft.com/office/drawing/2010/main" xmlns:ma14="http://schemas.microsoft.com/office/mac/drawingml/2011/main" val="1"/>
+              <ma14:wrappingTextBoxFlag xmlns:ma14="http://schemas.microsoft.com/office/mac/drawingml/2011/main" xmlns:a14="http://schemas.microsoft.com/office/drawing/2010/main" xmlns:m="http://schemas.openxmlformats.org/officeDocument/2006/math" xmlns="" val="1"/>
             </a:ext>
           </a:extLst>
         </p:spPr>
@@ -7481,7 +7614,7 @@
           </a:ln>
           <a:extLst>
             <a:ext uri="{C572A759-6A51-4108-AA02-DFA0A04FC94B}">
-              <ma14:wrappingTextBoxFlag xmlns="" xmlns:m="http://schemas.openxmlformats.org/officeDocument/2006/math" xmlns:a14="http://schemas.microsoft.com/office/drawing/2010/main" xmlns:ma14="http://schemas.microsoft.com/office/mac/drawingml/2011/main" val="1"/>
+              <ma14:wrappingTextBoxFlag xmlns:ma14="http://schemas.microsoft.com/office/mac/drawingml/2011/main" xmlns:a14="http://schemas.microsoft.com/office/drawing/2010/main" xmlns:m="http://schemas.openxmlformats.org/officeDocument/2006/math" xmlns="" val="1"/>
             </a:ext>
           </a:extLst>
         </p:spPr>
@@ -7528,7 +7661,7 @@
           </a:ln>
           <a:extLst>
             <a:ext uri="{C572A759-6A51-4108-AA02-DFA0A04FC94B}">
-              <ma14:wrappingTextBoxFlag xmlns="" xmlns:m="http://schemas.openxmlformats.org/officeDocument/2006/math" xmlns:a14="http://schemas.microsoft.com/office/drawing/2010/main" xmlns:ma14="http://schemas.microsoft.com/office/mac/drawingml/2011/main" val="1"/>
+              <ma14:wrappingTextBoxFlag xmlns:ma14="http://schemas.microsoft.com/office/mac/drawingml/2011/main" xmlns:a14="http://schemas.microsoft.com/office/drawing/2010/main" xmlns:m="http://schemas.openxmlformats.org/officeDocument/2006/math" xmlns="" val="1"/>
             </a:ext>
           </a:extLst>
         </p:spPr>
@@ -7791,7 +7924,7 @@
             <a:effectLst/>
             <a:extLst>
               <a:ext uri="{C572A759-6A51-4108-AA02-DFA0A04FC94B}">
-                <ma14:wrappingTextBoxFlag xmlns="" xmlns:m="http://schemas.openxmlformats.org/officeDocument/2006/math" xmlns:a14="http://schemas.microsoft.com/office/drawing/2010/main" xmlns:ma14="http://schemas.microsoft.com/office/mac/drawingml/2011/main" val="1"/>
+                <ma14:wrappingTextBoxFlag xmlns:ma14="http://schemas.microsoft.com/office/mac/drawingml/2011/main" xmlns:a14="http://schemas.microsoft.com/office/drawing/2010/main" xmlns:m="http://schemas.openxmlformats.org/officeDocument/2006/math" xmlns="" val="1"/>
               </a:ext>
             </a:extLst>
           </p:spPr>
@@ -7919,7 +8052,7 @@
             <a:effectLst/>
             <a:extLst>
               <a:ext uri="{C572A759-6A51-4108-AA02-DFA0A04FC94B}">
-                <ma14:wrappingTextBoxFlag xmlns="" xmlns:m="http://schemas.openxmlformats.org/officeDocument/2006/math" xmlns:a14="http://schemas.microsoft.com/office/drawing/2010/main" xmlns:ma14="http://schemas.microsoft.com/office/mac/drawingml/2011/main" val="1"/>
+                <ma14:wrappingTextBoxFlag xmlns:ma14="http://schemas.microsoft.com/office/mac/drawingml/2011/main" xmlns:a14="http://schemas.microsoft.com/office/drawing/2010/main" xmlns:m="http://schemas.openxmlformats.org/officeDocument/2006/math" xmlns="" val="1"/>
               </a:ext>
             </a:extLst>
           </p:spPr>
@@ -8181,7 +8314,7 @@
             <a:effectLst/>
             <a:extLst>
               <a:ext uri="{C572A759-6A51-4108-AA02-DFA0A04FC94B}">
-                <ma14:wrappingTextBoxFlag xmlns="" xmlns:m="http://schemas.openxmlformats.org/officeDocument/2006/math" xmlns:a14="http://schemas.microsoft.com/office/drawing/2010/main" xmlns:ma14="http://schemas.microsoft.com/office/mac/drawingml/2011/main" val="1"/>
+                <ma14:wrappingTextBoxFlag xmlns:ma14="http://schemas.microsoft.com/office/mac/drawingml/2011/main" xmlns:a14="http://schemas.microsoft.com/office/drawing/2010/main" xmlns:m="http://schemas.openxmlformats.org/officeDocument/2006/math" xmlns="" val="1"/>
               </a:ext>
             </a:extLst>
           </p:spPr>
@@ -8288,7 +8421,7 @@
               <a:effectLst/>
               <a:extLst>
                 <a:ext uri="{C572A759-6A51-4108-AA02-DFA0A04FC94B}">
-                  <ma14:wrappingTextBoxFlag xmlns="" xmlns:m="http://schemas.openxmlformats.org/officeDocument/2006/math" xmlns:a14="http://schemas.microsoft.com/office/drawing/2010/main" xmlns:ma14="http://schemas.microsoft.com/office/mac/drawingml/2011/main" val="1"/>
+                  <ma14:wrappingTextBoxFlag xmlns:ma14="http://schemas.microsoft.com/office/mac/drawingml/2011/main" xmlns:a14="http://schemas.microsoft.com/office/drawing/2010/main" xmlns:m="http://schemas.openxmlformats.org/officeDocument/2006/math" xmlns="" val="1"/>
                 </a:ext>
               </a:extLst>
             </p:spPr>
@@ -8338,7 +8471,7 @@
               <a:effectLst/>
               <a:extLst>
                 <a:ext uri="{C572A759-6A51-4108-AA02-DFA0A04FC94B}">
-                  <ma14:wrappingTextBoxFlag xmlns="" xmlns:m="http://schemas.openxmlformats.org/officeDocument/2006/math" xmlns:a14="http://schemas.microsoft.com/office/drawing/2010/main" xmlns:ma14="http://schemas.microsoft.com/office/mac/drawingml/2011/main" val="1"/>
+                  <ma14:wrappingTextBoxFlag xmlns:ma14="http://schemas.microsoft.com/office/mac/drawingml/2011/main" xmlns:a14="http://schemas.microsoft.com/office/drawing/2010/main" xmlns:m="http://schemas.openxmlformats.org/officeDocument/2006/math" xmlns="" val="1"/>
                 </a:ext>
               </a:extLst>
             </p:spPr>
@@ -8458,7 +8591,7 @@
               <a:effectLst/>
               <a:extLst>
                 <a:ext uri="{C572A759-6A51-4108-AA02-DFA0A04FC94B}">
-                  <ma14:wrappingTextBoxFlag xmlns="" xmlns:m="http://schemas.openxmlformats.org/officeDocument/2006/math" xmlns:a14="http://schemas.microsoft.com/office/drawing/2010/main" xmlns:ma14="http://schemas.microsoft.com/office/mac/drawingml/2011/main" val="1"/>
+                  <ma14:wrappingTextBoxFlag xmlns:ma14="http://schemas.microsoft.com/office/mac/drawingml/2011/main" xmlns:a14="http://schemas.microsoft.com/office/drawing/2010/main" xmlns:m="http://schemas.openxmlformats.org/officeDocument/2006/math" xmlns="" val="1"/>
                 </a:ext>
               </a:extLst>
             </p:spPr>
@@ -8509,7 +8642,7 @@
             <a:effectLst/>
             <a:extLst>
               <a:ext uri="{C572A759-6A51-4108-AA02-DFA0A04FC94B}">
-                <ma14:wrappingTextBoxFlag xmlns="" xmlns:m="http://schemas.openxmlformats.org/officeDocument/2006/math" xmlns:a14="http://schemas.microsoft.com/office/drawing/2010/main" xmlns:ma14="http://schemas.microsoft.com/office/mac/drawingml/2011/main" val="1"/>
+                <ma14:wrappingTextBoxFlag xmlns:ma14="http://schemas.microsoft.com/office/mac/drawingml/2011/main" xmlns:a14="http://schemas.microsoft.com/office/drawing/2010/main" xmlns:m="http://schemas.openxmlformats.org/officeDocument/2006/math" xmlns="" val="1"/>
               </a:ext>
             </a:extLst>
           </p:spPr>
@@ -8614,7 +8747,7 @@
             <a:effectLst/>
             <a:extLst>
               <a:ext uri="{C572A759-6A51-4108-AA02-DFA0A04FC94B}">
-                <ma14:wrappingTextBoxFlag xmlns="" xmlns:m="http://schemas.openxmlformats.org/officeDocument/2006/math" xmlns:a14="http://schemas.microsoft.com/office/drawing/2010/main" xmlns:ma14="http://schemas.microsoft.com/office/mac/drawingml/2011/main" val="1"/>
+                <ma14:wrappingTextBoxFlag xmlns:ma14="http://schemas.microsoft.com/office/mac/drawingml/2011/main" xmlns:a14="http://schemas.microsoft.com/office/drawing/2010/main" xmlns:m="http://schemas.openxmlformats.org/officeDocument/2006/math" xmlns="" val="1"/>
               </a:ext>
             </a:extLst>
           </p:spPr>
@@ -8722,7 +8855,7 @@
             <a:effectLst/>
             <a:extLst>
               <a:ext uri="{C572A759-6A51-4108-AA02-DFA0A04FC94B}">
-                <ma14:wrappingTextBoxFlag xmlns="" xmlns:m="http://schemas.openxmlformats.org/officeDocument/2006/math" xmlns:a14="http://schemas.microsoft.com/office/drawing/2010/main" xmlns:ma14="http://schemas.microsoft.com/office/mac/drawingml/2011/main" val="1"/>
+                <ma14:wrappingTextBoxFlag xmlns:ma14="http://schemas.microsoft.com/office/mac/drawingml/2011/main" xmlns:a14="http://schemas.microsoft.com/office/drawing/2010/main" xmlns:m="http://schemas.openxmlformats.org/officeDocument/2006/math" xmlns="" val="1"/>
               </a:ext>
             </a:extLst>
           </p:spPr>
@@ -8772,7 +8905,7 @@
             <a:effectLst/>
             <a:extLst>
               <a:ext uri="{C572A759-6A51-4108-AA02-DFA0A04FC94B}">
-                <ma14:wrappingTextBoxFlag xmlns="" xmlns:m="http://schemas.openxmlformats.org/officeDocument/2006/math" xmlns:a14="http://schemas.microsoft.com/office/drawing/2010/main" xmlns:ma14="http://schemas.microsoft.com/office/mac/drawingml/2011/main" val="1"/>
+                <ma14:wrappingTextBoxFlag xmlns:ma14="http://schemas.microsoft.com/office/mac/drawingml/2011/main" xmlns:a14="http://schemas.microsoft.com/office/drawing/2010/main" xmlns:m="http://schemas.openxmlformats.org/officeDocument/2006/math" xmlns="" val="1"/>
               </a:ext>
             </a:extLst>
           </p:spPr>
@@ -8911,7 +9044,7 @@
             <a:effectLst/>
             <a:extLst>
               <a:ext uri="{C572A759-6A51-4108-AA02-DFA0A04FC94B}">
-                <ma14:wrappingTextBoxFlag xmlns="" xmlns:m="http://schemas.openxmlformats.org/officeDocument/2006/math" xmlns:a14="http://schemas.microsoft.com/office/drawing/2010/main" xmlns:ma14="http://schemas.microsoft.com/office/mac/drawingml/2011/main" val="1"/>
+                <ma14:wrappingTextBoxFlag xmlns:ma14="http://schemas.microsoft.com/office/mac/drawingml/2011/main" xmlns:a14="http://schemas.microsoft.com/office/drawing/2010/main" xmlns:m="http://schemas.openxmlformats.org/officeDocument/2006/math" xmlns="" val="1"/>
               </a:ext>
             </a:extLst>
           </p:spPr>
@@ -9066,7 +9199,7 @@
                 <a:effectLst/>
                 <a:extLst>
                   <a:ext uri="{C572A759-6A51-4108-AA02-DFA0A04FC94B}">
-                    <ma14:wrappingTextBoxFlag xmlns="" xmlns:m="http://schemas.openxmlformats.org/officeDocument/2006/math" xmlns:a14="http://schemas.microsoft.com/office/drawing/2010/main" xmlns:ma14="http://schemas.microsoft.com/office/mac/drawingml/2011/main" val="1"/>
+                    <ma14:wrappingTextBoxFlag xmlns:ma14="http://schemas.microsoft.com/office/mac/drawingml/2011/main" xmlns:a14="http://schemas.microsoft.com/office/drawing/2010/main" xmlns:m="http://schemas.openxmlformats.org/officeDocument/2006/math" xmlns="" val="1"/>
                   </a:ext>
                 </a:extLst>
               </p:spPr>
@@ -9151,7 +9284,7 @@
               <a:effectLst/>
               <a:extLst>
                 <a:ext uri="{C572A759-6A51-4108-AA02-DFA0A04FC94B}">
-                  <ma14:wrappingTextBoxFlag xmlns="" xmlns:m="http://schemas.openxmlformats.org/officeDocument/2006/math" xmlns:a14="http://schemas.microsoft.com/office/drawing/2010/main" xmlns:ma14="http://schemas.microsoft.com/office/mac/drawingml/2011/main" val="1"/>
+                  <ma14:wrappingTextBoxFlag xmlns:ma14="http://schemas.microsoft.com/office/mac/drawingml/2011/main" xmlns:a14="http://schemas.microsoft.com/office/drawing/2010/main" xmlns:m="http://schemas.openxmlformats.org/officeDocument/2006/math" xmlns="" val="1"/>
                 </a:ext>
               </a:extLst>
             </p:spPr>
@@ -9572,7 +9705,7 @@
           </a:ln>
           <a:extLst>
             <a:ext uri="{C572A759-6A51-4108-AA02-DFA0A04FC94B}">
-              <ma14:wrappingTextBoxFlag xmlns="" xmlns:m="http://schemas.openxmlformats.org/officeDocument/2006/math" xmlns:a14="http://schemas.microsoft.com/office/drawing/2010/main" xmlns:ma14="http://schemas.microsoft.com/office/mac/drawingml/2011/main" val="1"/>
+              <ma14:wrappingTextBoxFlag xmlns:ma14="http://schemas.microsoft.com/office/mac/drawingml/2011/main" xmlns:a14="http://schemas.microsoft.com/office/drawing/2010/main" xmlns:m="http://schemas.openxmlformats.org/officeDocument/2006/math" xmlns="" val="1"/>
             </a:ext>
           </a:extLst>
         </p:spPr>
@@ -9693,7 +9826,7 @@
               <a:effectLst/>
               <a:extLst>
                 <a:ext uri="{C572A759-6A51-4108-AA02-DFA0A04FC94B}">
-                  <ma14:wrappingTextBoxFlag xmlns="" xmlns:m="http://schemas.openxmlformats.org/officeDocument/2006/math" xmlns:a14="http://schemas.microsoft.com/office/drawing/2010/main" xmlns:ma14="http://schemas.microsoft.com/office/mac/drawingml/2011/main" val="1"/>
+                  <ma14:wrappingTextBoxFlag xmlns:ma14="http://schemas.microsoft.com/office/mac/drawingml/2011/main" xmlns:a14="http://schemas.microsoft.com/office/drawing/2010/main" xmlns:m="http://schemas.openxmlformats.org/officeDocument/2006/math" xmlns="" val="1"/>
                 </a:ext>
               </a:extLst>
             </p:spPr>
@@ -9741,7 +9874,7 @@
             <a:effectLst/>
             <a:extLst>
               <a:ext uri="{C572A759-6A51-4108-AA02-DFA0A04FC94B}">
-                <ma14:wrappingTextBoxFlag xmlns="" xmlns:m="http://schemas.openxmlformats.org/officeDocument/2006/math" xmlns:a14="http://schemas.microsoft.com/office/drawing/2010/main" xmlns:ma14="http://schemas.microsoft.com/office/mac/drawingml/2011/main" val="1"/>
+                <ma14:wrappingTextBoxFlag xmlns:ma14="http://schemas.microsoft.com/office/mac/drawingml/2011/main" xmlns:a14="http://schemas.microsoft.com/office/drawing/2010/main" xmlns:m="http://schemas.openxmlformats.org/officeDocument/2006/math" xmlns="" val="1"/>
               </a:ext>
             </a:extLst>
           </p:spPr>
@@ -9860,7 +9993,7 @@
               <a:effectLst/>
               <a:extLst>
                 <a:ext uri="{C572A759-6A51-4108-AA02-DFA0A04FC94B}">
-                  <ma14:wrappingTextBoxFlag xmlns="" xmlns:m="http://schemas.openxmlformats.org/officeDocument/2006/math" xmlns:a14="http://schemas.microsoft.com/office/drawing/2010/main" xmlns:ma14="http://schemas.microsoft.com/office/mac/drawingml/2011/main" val="1"/>
+                  <ma14:wrappingTextBoxFlag xmlns:ma14="http://schemas.microsoft.com/office/mac/drawingml/2011/main" xmlns:a14="http://schemas.microsoft.com/office/drawing/2010/main" xmlns:m="http://schemas.openxmlformats.org/officeDocument/2006/math" xmlns="" val="1"/>
                 </a:ext>
               </a:extLst>
             </p:spPr>
@@ -9908,7 +10041,7 @@
             <a:effectLst/>
             <a:extLst>
               <a:ext uri="{C572A759-6A51-4108-AA02-DFA0A04FC94B}">
-                <ma14:wrappingTextBoxFlag xmlns="" xmlns:m="http://schemas.openxmlformats.org/officeDocument/2006/math" xmlns:a14="http://schemas.microsoft.com/office/drawing/2010/main" xmlns:ma14="http://schemas.microsoft.com/office/mac/drawingml/2011/main" val="1"/>
+                <ma14:wrappingTextBoxFlag xmlns:ma14="http://schemas.microsoft.com/office/mac/drawingml/2011/main" xmlns:a14="http://schemas.microsoft.com/office/drawing/2010/main" xmlns:m="http://schemas.openxmlformats.org/officeDocument/2006/math" xmlns="" val="1"/>
               </a:ext>
             </a:extLst>
           </p:spPr>
@@ -10027,7 +10160,7 @@
               <a:effectLst/>
               <a:extLst>
                 <a:ext uri="{C572A759-6A51-4108-AA02-DFA0A04FC94B}">
-                  <ma14:wrappingTextBoxFlag xmlns="" xmlns:m="http://schemas.openxmlformats.org/officeDocument/2006/math" xmlns:a14="http://schemas.microsoft.com/office/drawing/2010/main" xmlns:ma14="http://schemas.microsoft.com/office/mac/drawingml/2011/main" val="1"/>
+                  <ma14:wrappingTextBoxFlag xmlns:ma14="http://schemas.microsoft.com/office/mac/drawingml/2011/main" xmlns:a14="http://schemas.microsoft.com/office/drawing/2010/main" xmlns:m="http://schemas.openxmlformats.org/officeDocument/2006/math" xmlns="" val="1"/>
                 </a:ext>
               </a:extLst>
             </p:spPr>
@@ -10075,7 +10208,7 @@
             <a:effectLst/>
             <a:extLst>
               <a:ext uri="{C572A759-6A51-4108-AA02-DFA0A04FC94B}">
-                <ma14:wrappingTextBoxFlag xmlns="" xmlns:m="http://schemas.openxmlformats.org/officeDocument/2006/math" xmlns:a14="http://schemas.microsoft.com/office/drawing/2010/main" xmlns:ma14="http://schemas.microsoft.com/office/mac/drawingml/2011/main" val="1"/>
+                <ma14:wrappingTextBoxFlag xmlns:ma14="http://schemas.microsoft.com/office/mac/drawingml/2011/main" xmlns:a14="http://schemas.microsoft.com/office/drawing/2010/main" xmlns:m="http://schemas.openxmlformats.org/officeDocument/2006/math" xmlns="" val="1"/>
               </a:ext>
             </a:extLst>
           </p:spPr>
@@ -10120,7 +10253,7 @@
           </a:ln>
           <a:extLst>
             <a:ext uri="{C572A759-6A51-4108-AA02-DFA0A04FC94B}">
-              <ma14:wrappingTextBoxFlag xmlns="" xmlns:m="http://schemas.openxmlformats.org/officeDocument/2006/math" xmlns:a14="http://schemas.microsoft.com/office/drawing/2010/main" xmlns:ma14="http://schemas.microsoft.com/office/mac/drawingml/2011/main" val="1"/>
+              <ma14:wrappingTextBoxFlag xmlns:ma14="http://schemas.microsoft.com/office/mac/drawingml/2011/main" xmlns:a14="http://schemas.microsoft.com/office/drawing/2010/main" xmlns:m="http://schemas.openxmlformats.org/officeDocument/2006/math" xmlns="" val="1"/>
             </a:ext>
           </a:extLst>
         </p:spPr>
@@ -10164,7 +10297,7 @@
           </a:ln>
           <a:extLst>
             <a:ext uri="{C572A759-6A51-4108-AA02-DFA0A04FC94B}">
-              <ma14:wrappingTextBoxFlag xmlns="" xmlns:m="http://schemas.openxmlformats.org/officeDocument/2006/math" xmlns:a14="http://schemas.microsoft.com/office/drawing/2010/main" xmlns:ma14="http://schemas.microsoft.com/office/mac/drawingml/2011/main" val="1"/>
+              <ma14:wrappingTextBoxFlag xmlns:ma14="http://schemas.microsoft.com/office/mac/drawingml/2011/main" xmlns:a14="http://schemas.microsoft.com/office/drawing/2010/main" xmlns:m="http://schemas.openxmlformats.org/officeDocument/2006/math" xmlns="" val="1"/>
             </a:ext>
           </a:extLst>
         </p:spPr>
@@ -10208,7 +10341,7 @@
           </a:ln>
           <a:extLst>
             <a:ext uri="{C572A759-6A51-4108-AA02-DFA0A04FC94B}">
-              <ma14:wrappingTextBoxFlag xmlns="" xmlns:m="http://schemas.openxmlformats.org/officeDocument/2006/math" xmlns:a14="http://schemas.microsoft.com/office/drawing/2010/main" xmlns:ma14="http://schemas.microsoft.com/office/mac/drawingml/2011/main" val="1"/>
+              <ma14:wrappingTextBoxFlag xmlns:ma14="http://schemas.microsoft.com/office/mac/drawingml/2011/main" xmlns:a14="http://schemas.microsoft.com/office/drawing/2010/main" xmlns:m="http://schemas.openxmlformats.org/officeDocument/2006/math" xmlns="" val="1"/>
             </a:ext>
           </a:extLst>
         </p:spPr>
@@ -10562,7 +10695,7 @@
             <a:effectLst/>
             <a:extLst>
               <a:ext uri="{C572A759-6A51-4108-AA02-DFA0A04FC94B}">
-                <ma14:wrappingTextBoxFlag xmlns="" xmlns:m="http://schemas.openxmlformats.org/officeDocument/2006/math" xmlns:a14="http://schemas.microsoft.com/office/drawing/2010/main" xmlns:ma14="http://schemas.microsoft.com/office/mac/drawingml/2011/main" val="1"/>
+                <ma14:wrappingTextBoxFlag xmlns:ma14="http://schemas.microsoft.com/office/mac/drawingml/2011/main" xmlns:a14="http://schemas.microsoft.com/office/drawing/2010/main" xmlns:m="http://schemas.openxmlformats.org/officeDocument/2006/math" xmlns="" val="1"/>
               </a:ext>
             </a:extLst>
           </p:spPr>
@@ -10857,7 +10990,7 @@
                 <a:effectLst/>
                 <a:extLst>
                   <a:ext uri="{C572A759-6A51-4108-AA02-DFA0A04FC94B}">
-                    <ma14:wrappingTextBoxFlag xmlns="" xmlns:m="http://schemas.openxmlformats.org/officeDocument/2006/math" xmlns:a14="http://schemas.microsoft.com/office/drawing/2010/main" xmlns:ma14="http://schemas.microsoft.com/office/mac/drawingml/2011/main" val="1"/>
+                    <ma14:wrappingTextBoxFlag xmlns:ma14="http://schemas.microsoft.com/office/mac/drawingml/2011/main" xmlns:a14="http://schemas.microsoft.com/office/drawing/2010/main" xmlns:m="http://schemas.openxmlformats.org/officeDocument/2006/math" xmlns="" val="1"/>
                   </a:ext>
                 </a:extLst>
               </p:spPr>
@@ -11728,7 +11861,7 @@
                 <a:effectLst/>
                 <a:extLst>
                   <a:ext uri="{C572A759-6A51-4108-AA02-DFA0A04FC94B}">
-                    <ma14:wrappingTextBoxFlag xmlns="" xmlns:m="http://schemas.openxmlformats.org/officeDocument/2006/math" xmlns:a14="http://schemas.microsoft.com/office/drawing/2010/main" xmlns:ma14="http://schemas.microsoft.com/office/mac/drawingml/2011/main" val="1"/>
+                    <ma14:wrappingTextBoxFlag xmlns:ma14="http://schemas.microsoft.com/office/mac/drawingml/2011/main" xmlns:a14="http://schemas.microsoft.com/office/drawing/2010/main" xmlns:m="http://schemas.openxmlformats.org/officeDocument/2006/math" xmlns="" val="1"/>
                   </a:ext>
                 </a:extLst>
               </p:spPr>
@@ -11850,7 +11983,7 @@
             <a:effectLst/>
             <a:extLst>
               <a:ext uri="{C572A759-6A51-4108-AA02-DFA0A04FC94B}">
-                <ma14:wrappingTextBoxFlag xmlns="" xmlns:m="http://schemas.openxmlformats.org/officeDocument/2006/math" xmlns:a14="http://schemas.microsoft.com/office/drawing/2010/main" xmlns:ma14="http://schemas.microsoft.com/office/mac/drawingml/2011/main" val="1"/>
+                <ma14:wrappingTextBoxFlag xmlns:ma14="http://schemas.microsoft.com/office/mac/drawingml/2011/main" xmlns:a14="http://schemas.microsoft.com/office/drawing/2010/main" xmlns:m="http://schemas.openxmlformats.org/officeDocument/2006/math" xmlns="" val="1"/>
               </a:ext>
             </a:extLst>
           </p:spPr>
@@ -12028,7 +12161,7 @@
               <a:effectLst/>
               <a:extLst>
                 <a:ext uri="{C572A759-6A51-4108-AA02-DFA0A04FC94B}">
-                  <ma14:wrappingTextBoxFlag xmlns="" xmlns:m="http://schemas.openxmlformats.org/officeDocument/2006/math" xmlns:a14="http://schemas.microsoft.com/office/drawing/2010/main" xmlns:ma14="http://schemas.microsoft.com/office/mac/drawingml/2011/main" val="1"/>
+                  <ma14:wrappingTextBoxFlag xmlns:ma14="http://schemas.microsoft.com/office/mac/drawingml/2011/main" xmlns:a14="http://schemas.microsoft.com/office/drawing/2010/main" xmlns:m="http://schemas.openxmlformats.org/officeDocument/2006/math" xmlns="" val="1"/>
                 </a:ext>
               </a:extLst>
             </p:spPr>
@@ -12163,7 +12296,7 @@
               <a:effectLst/>
               <a:extLst>
                 <a:ext uri="{C572A759-6A51-4108-AA02-DFA0A04FC94B}">
-                  <ma14:wrappingTextBoxFlag xmlns="" xmlns:m="http://schemas.openxmlformats.org/officeDocument/2006/math" xmlns:a14="http://schemas.microsoft.com/office/drawing/2010/main" xmlns:ma14="http://schemas.microsoft.com/office/mac/drawingml/2011/main" val="1"/>
+                  <ma14:wrappingTextBoxFlag xmlns:ma14="http://schemas.microsoft.com/office/mac/drawingml/2011/main" xmlns:a14="http://schemas.microsoft.com/office/drawing/2010/main" xmlns:m="http://schemas.openxmlformats.org/officeDocument/2006/math" xmlns="" val="1"/>
                 </a:ext>
               </a:extLst>
             </p:spPr>
@@ -12310,7 +12443,7 @@
               <a:effectLst/>
               <a:extLst>
                 <a:ext uri="{C572A759-6A51-4108-AA02-DFA0A04FC94B}">
-                  <ma14:wrappingTextBoxFlag xmlns="" xmlns:m="http://schemas.openxmlformats.org/officeDocument/2006/math" xmlns:a14="http://schemas.microsoft.com/office/drawing/2010/main" xmlns:ma14="http://schemas.microsoft.com/office/mac/drawingml/2011/main" val="1"/>
+                  <ma14:wrappingTextBoxFlag xmlns:ma14="http://schemas.microsoft.com/office/mac/drawingml/2011/main" xmlns:a14="http://schemas.microsoft.com/office/drawing/2010/main" xmlns:m="http://schemas.openxmlformats.org/officeDocument/2006/math" xmlns="" val="1"/>
                 </a:ext>
               </a:extLst>
             </p:spPr>

</xml_diff>